<commit_message>
Update pitch deck cover tagline
</commit_message>
<xml_diff>
--- a/LifeOS-Agent-路演PPT.pptx
+++ b/LifeOS-Agent-路演PPT.pptx
@@ -2897,8 +2897,8 @@
         </p:nvSpPr>
         <p:spPr>
           <a:xfrm>
-            <a:off x="7452360" y="5074920"/>
-            <a:ext cx="3154680" cy="256032"/>
+            <a:off x="6720840" y="5074920"/>
+            <a:ext cx="4526280" cy="256032"/>
           </a:xfrm>
           <a:prstGeom prst="rect">
             <a:avLst/>
@@ -2907,7 +2907,9 @@
           <a:ln/>
         </p:spPr>
         <p:txBody>
-          <a:bodyPr wrap="square" lIns="0" tIns="0" rIns="0" bIns="0" rtlCol="0" anchor="ctr"/>
+          <a:bodyPr wrap="square" lIns="0" tIns="0" rIns="0" bIns="0" rtlCol="0" anchor="ctr">
+            <a:normAutofit/>
+          </a:bodyPr>
           <a:lstStyle/>
           <a:p>
             <a:pPr algn="ctr" indent="0" marL="0">
@@ -2919,7 +2921,7 @@
                   <a:srgbClr val="F6C768"/>
                 </a:solidFill>
               </a:rPr>
-              <a:t>修仙是框架，Agent 工程是核心</a:t>
+              <a:t>融修仙之框架，铸Agent工程之核</a:t>
             </a:r>
             <a:endParaRPr lang="en-US" sz="1500" dirty="0"/>
           </a:p>

</xml_diff>

<commit_message>
Add README for LifeOS Agent
</commit_message>
<xml_diff>
--- a/LifeOS-Agent-路演PPT.pptx
+++ b/LifeOS-Agent-路演PPT.pptx
@@ -1,26 +1,26 @@
 
 <file path=ppt/presentation.xml><?xml version="1.0" encoding="utf-8"?>
-<p:presentation xmlns:a="http://schemas.openxmlformats.org/drawingml/2006/main" xmlns:r="http://schemas.openxmlformats.org/officeDocument/2006/relationships" xmlns:p="http://schemas.openxmlformats.org/presentationml/2006/main" saveSubsetFonts="1" autoCompressPictures="0">
+<p:presentation xmlns:a="http://schemas.openxmlformats.org/drawingml/2006/main" xmlns:r="http://schemas.openxmlformats.org/officeDocument/2006/relationships" xmlns:p="http://schemas.openxmlformats.org/presentationml/2006/main" autoCompressPictures="0">
   <p:sldMasterIdLst>
     <p:sldMasterId id="2147483648" r:id="rId1"/>
   </p:sldMasterIdLst>
+  <p:notesMasterIdLst>
+    <p:notesMasterId r:id="rId4"/>
+  </p:notesMasterIdLst>
   <p:sldIdLst>
-    <p:sldId id="256" r:id="rId2"/>
-    <p:sldId id="257" r:id="rId3"/>
-    <p:sldId id="258" r:id="rId4"/>
-    <p:sldId id="259" r:id="rId5"/>
-    <p:sldId id="260" r:id="rId6"/>
-    <p:sldId id="261" r:id="rId7"/>
-    <p:sldId id="262" r:id="rId8"/>
-    <p:sldId id="263" r:id="rId9"/>
-    <p:sldId id="264" r:id="rId10"/>
-    <p:sldId id="265" r:id="rId11"/>
+    <p:sldId id="256" r:id="rId3"/>
+    <p:sldId id="257" r:id="rId5"/>
+    <p:sldId id="258" r:id="rId6"/>
+    <p:sldId id="259" r:id="rId7"/>
+    <p:sldId id="260" r:id="rId8"/>
+    <p:sldId id="261" r:id="rId9"/>
+    <p:sldId id="262" r:id="rId10"/>
+    <p:sldId id="263" r:id="rId11"/>
+    <p:sldId id="264" r:id="rId12"/>
+    <p:sldId id="265" r:id="rId13"/>
   </p:sldIdLst>
-  <p:notesMasterIdLst>
-    <p:notesMasterId r:id="rId12"/>
-  </p:notesMasterIdLst>
-  <p:sldSz cx="12191695" cy="6858000"/>
-  <p:notesSz cx="6858000" cy="12191695"/>
+  <p:sldSz cx="12191365" cy="6858000"/>
+  <p:notesSz cx="6858000" cy="12191365"/>
   <p:defaultTextStyle>
     <a:lvl1pPr marL="0" algn="l" defTabSz="914400" rtl="0" eaLnBrk="1" latinLnBrk="0" hangingPunct="1">
       <a:defRPr sz="1800" kern="1200">
@@ -198,7 +198,6 @@
           <a:p>
             <a:fld id="{5282F153-3F37-0F45-9E97-73ACFA13230C}" type="datetimeFigureOut">
               <a:rPr lang="en-US"/>
-              <a:t>7/23/19</a:t>
             </a:fld>
             <a:endParaRPr lang="en-US"/>
           </a:p>
@@ -265,6 +264,7 @@
               <a:rPr lang="en-US"/>
               <a:t>Click to edit Master text styles</a:t>
             </a:r>
+            <a:endParaRPr lang="en-US"/>
           </a:p>
           <a:p>
             <a:pPr lvl="1"/>
@@ -272,6 +272,7 @@
               <a:rPr lang="en-US"/>
               <a:t>Second level</a:t>
             </a:r>
+            <a:endParaRPr lang="en-US"/>
           </a:p>
           <a:p>
             <a:pPr lvl="2"/>
@@ -279,6 +280,7 @@
               <a:rPr lang="en-US"/>
               <a:t>Third level</a:t>
             </a:r>
+            <a:endParaRPr lang="en-US"/>
           </a:p>
           <a:p>
             <a:pPr lvl="3"/>
@@ -286,6 +288,7 @@
               <a:rPr lang="en-US"/>
               <a:t>Fourth level</a:t>
             </a:r>
+            <a:endParaRPr lang="en-US"/>
           </a:p>
           <a:p>
             <a:pPr lvl="4"/>
@@ -293,6 +296,7 @@
               <a:rPr lang="en-US"/>
               <a:t>Fifth level</a:t>
             </a:r>
+            <a:endParaRPr lang="en-US"/>
           </a:p>
         </p:txBody>
       </p:sp>
@@ -356,18 +360,12 @@
           <a:p>
             <a:fld id="{CE5E9CC1-C706-0F49-92D6-E571CC5EEA8F}" type="slidenum">
               <a:rPr lang="en-US"/>
-              <a:t>‹#›</a:t>
             </a:fld>
             <a:endParaRPr lang="en-US"/>
           </a:p>
         </p:txBody>
       </p:sp>
     </p:spTree>
-    <p:extLst>
-      <p:ext uri="{BB962C8B-B14F-4D97-AF65-F5344CB8AC3E}">
-        <p14:creationId xmlns:p14="http://schemas.microsoft.com/office/powerpoint/2010/main" val="1024086991"/>
-      </p:ext>
-    </p:extLst>
   </p:cSld>
   <p:clrMap bg1="lt1" tx1="dk1" bg2="lt2" tx2="dk2" accent1="accent1" accent2="accent2" accent3="accent3" accent4="accent4" accent5="accent5" accent6="accent6" hlink="hlink" folHlink="folHlink"/>
   <p:notesStyle>
@@ -509,10 +507,6 @@
           <a:bodyPr/>
           <a:lstStyle/>
           <a:p>
-            <a:r>
-              <a:rPr lang="en-US" dirty="0"/>
-              <a:t/>
-            </a:r>
             <a:endParaRPr lang="en-US" dirty="0"/>
           </a:p>
         </p:txBody>
@@ -534,18 +528,12 @@
           <a:p>
             <a:fld id="{F7021451-1387-4CA6-816F-3879F97B5CBC}" type="slidenum">
               <a:rPr lang="en-US"/>
-              <a:t>1</a:t>
             </a:fld>
             <a:endParaRPr lang="en-US"/>
           </a:p>
         </p:txBody>
       </p:sp>
     </p:spTree>
-    <p:extLst>
-      <p:ext uri="{BB962C8B-B14F-4D97-AF65-F5344CB8AC3E}">
-        <p14:creationId xmlns:p14="http://schemas.microsoft.com/office/powerpoint/2010/main" val="1024086991"/>
-      </p:ext>
-    </p:extLst>
   </p:cSld>
   <p:clrMapOvr>
     <a:masterClrMapping/>
@@ -597,10 +585,6 @@
           <a:bodyPr/>
           <a:lstStyle/>
           <a:p>
-            <a:r>
-              <a:rPr lang="en-US" dirty="0"/>
-              <a:t/>
-            </a:r>
             <a:endParaRPr lang="en-US" dirty="0"/>
           </a:p>
         </p:txBody>
@@ -622,18 +606,12 @@
           <a:p>
             <a:fld id="{F7021451-1387-4CA6-816F-3879F97B5CBC}" type="slidenum">
               <a:rPr lang="en-US"/>
-              <a:t>10</a:t>
             </a:fld>
             <a:endParaRPr lang="en-US"/>
           </a:p>
         </p:txBody>
       </p:sp>
     </p:spTree>
-    <p:extLst>
-      <p:ext uri="{BB962C8B-B14F-4D97-AF65-F5344CB8AC3E}">
-        <p14:creationId xmlns:p14="http://schemas.microsoft.com/office/powerpoint/2010/main" val="1024086991"/>
-      </p:ext>
-    </p:extLst>
   </p:cSld>
   <p:clrMapOvr>
     <a:masterClrMapping/>
@@ -685,10 +663,6 @@
           <a:bodyPr/>
           <a:lstStyle/>
           <a:p>
-            <a:r>
-              <a:rPr lang="en-US" dirty="0"/>
-              <a:t/>
-            </a:r>
             <a:endParaRPr lang="en-US" dirty="0"/>
           </a:p>
         </p:txBody>
@@ -710,18 +684,12 @@
           <a:p>
             <a:fld id="{F7021451-1387-4CA6-816F-3879F97B5CBC}" type="slidenum">
               <a:rPr lang="en-US"/>
-              <a:t>2</a:t>
             </a:fld>
             <a:endParaRPr lang="en-US"/>
           </a:p>
         </p:txBody>
       </p:sp>
     </p:spTree>
-    <p:extLst>
-      <p:ext uri="{BB962C8B-B14F-4D97-AF65-F5344CB8AC3E}">
-        <p14:creationId xmlns:p14="http://schemas.microsoft.com/office/powerpoint/2010/main" val="1024086991"/>
-      </p:ext>
-    </p:extLst>
   </p:cSld>
   <p:clrMapOvr>
     <a:masterClrMapping/>
@@ -773,10 +741,6 @@
           <a:bodyPr/>
           <a:lstStyle/>
           <a:p>
-            <a:r>
-              <a:rPr lang="en-US" dirty="0"/>
-              <a:t/>
-            </a:r>
             <a:endParaRPr lang="en-US" dirty="0"/>
           </a:p>
         </p:txBody>
@@ -798,18 +762,12 @@
           <a:p>
             <a:fld id="{F7021451-1387-4CA6-816F-3879F97B5CBC}" type="slidenum">
               <a:rPr lang="en-US"/>
-              <a:t>3</a:t>
             </a:fld>
             <a:endParaRPr lang="en-US"/>
           </a:p>
         </p:txBody>
       </p:sp>
     </p:spTree>
-    <p:extLst>
-      <p:ext uri="{BB962C8B-B14F-4D97-AF65-F5344CB8AC3E}">
-        <p14:creationId xmlns:p14="http://schemas.microsoft.com/office/powerpoint/2010/main" val="1024086991"/>
-      </p:ext>
-    </p:extLst>
   </p:cSld>
   <p:clrMapOvr>
     <a:masterClrMapping/>
@@ -861,10 +819,6 @@
           <a:bodyPr/>
           <a:lstStyle/>
           <a:p>
-            <a:r>
-              <a:rPr lang="en-US" dirty="0"/>
-              <a:t/>
-            </a:r>
             <a:endParaRPr lang="en-US" dirty="0"/>
           </a:p>
         </p:txBody>
@@ -886,18 +840,12 @@
           <a:p>
             <a:fld id="{F7021451-1387-4CA6-816F-3879F97B5CBC}" type="slidenum">
               <a:rPr lang="en-US"/>
-              <a:t>4</a:t>
             </a:fld>
             <a:endParaRPr lang="en-US"/>
           </a:p>
         </p:txBody>
       </p:sp>
     </p:spTree>
-    <p:extLst>
-      <p:ext uri="{BB962C8B-B14F-4D97-AF65-F5344CB8AC3E}">
-        <p14:creationId xmlns:p14="http://schemas.microsoft.com/office/powerpoint/2010/main" val="1024086991"/>
-      </p:ext>
-    </p:extLst>
   </p:cSld>
   <p:clrMapOvr>
     <a:masterClrMapping/>
@@ -949,10 +897,6 @@
           <a:bodyPr/>
           <a:lstStyle/>
           <a:p>
-            <a:r>
-              <a:rPr lang="en-US" dirty="0"/>
-              <a:t/>
-            </a:r>
             <a:endParaRPr lang="en-US" dirty="0"/>
           </a:p>
         </p:txBody>
@@ -974,18 +918,12 @@
           <a:p>
             <a:fld id="{F7021451-1387-4CA6-816F-3879F97B5CBC}" type="slidenum">
               <a:rPr lang="en-US"/>
-              <a:t>5</a:t>
             </a:fld>
             <a:endParaRPr lang="en-US"/>
           </a:p>
         </p:txBody>
       </p:sp>
     </p:spTree>
-    <p:extLst>
-      <p:ext uri="{BB962C8B-B14F-4D97-AF65-F5344CB8AC3E}">
-        <p14:creationId xmlns:p14="http://schemas.microsoft.com/office/powerpoint/2010/main" val="1024086991"/>
-      </p:ext>
-    </p:extLst>
   </p:cSld>
   <p:clrMapOvr>
     <a:masterClrMapping/>
@@ -1037,10 +975,6 @@
           <a:bodyPr/>
           <a:lstStyle/>
           <a:p>
-            <a:r>
-              <a:rPr lang="en-US" dirty="0"/>
-              <a:t/>
-            </a:r>
             <a:endParaRPr lang="en-US" dirty="0"/>
           </a:p>
         </p:txBody>
@@ -1062,18 +996,12 @@
           <a:p>
             <a:fld id="{F7021451-1387-4CA6-816F-3879F97B5CBC}" type="slidenum">
               <a:rPr lang="en-US"/>
-              <a:t>6</a:t>
             </a:fld>
             <a:endParaRPr lang="en-US"/>
           </a:p>
         </p:txBody>
       </p:sp>
     </p:spTree>
-    <p:extLst>
-      <p:ext uri="{BB962C8B-B14F-4D97-AF65-F5344CB8AC3E}">
-        <p14:creationId xmlns:p14="http://schemas.microsoft.com/office/powerpoint/2010/main" val="1024086991"/>
-      </p:ext>
-    </p:extLst>
   </p:cSld>
   <p:clrMapOvr>
     <a:masterClrMapping/>
@@ -1125,10 +1053,6 @@
           <a:bodyPr/>
           <a:lstStyle/>
           <a:p>
-            <a:r>
-              <a:rPr lang="en-US" dirty="0"/>
-              <a:t/>
-            </a:r>
             <a:endParaRPr lang="en-US" dirty="0"/>
           </a:p>
         </p:txBody>
@@ -1150,18 +1074,12 @@
           <a:p>
             <a:fld id="{F7021451-1387-4CA6-816F-3879F97B5CBC}" type="slidenum">
               <a:rPr lang="en-US"/>
-              <a:t>7</a:t>
             </a:fld>
             <a:endParaRPr lang="en-US"/>
           </a:p>
         </p:txBody>
       </p:sp>
     </p:spTree>
-    <p:extLst>
-      <p:ext uri="{BB962C8B-B14F-4D97-AF65-F5344CB8AC3E}">
-        <p14:creationId xmlns:p14="http://schemas.microsoft.com/office/powerpoint/2010/main" val="1024086991"/>
-      </p:ext>
-    </p:extLst>
   </p:cSld>
   <p:clrMapOvr>
     <a:masterClrMapping/>
@@ -1213,10 +1131,6 @@
           <a:bodyPr/>
           <a:lstStyle/>
           <a:p>
-            <a:r>
-              <a:rPr lang="en-US" dirty="0"/>
-              <a:t/>
-            </a:r>
             <a:endParaRPr lang="en-US" dirty="0"/>
           </a:p>
         </p:txBody>
@@ -1238,18 +1152,12 @@
           <a:p>
             <a:fld id="{F7021451-1387-4CA6-816F-3879F97B5CBC}" type="slidenum">
               <a:rPr lang="en-US"/>
-              <a:t>8</a:t>
             </a:fld>
             <a:endParaRPr lang="en-US"/>
           </a:p>
         </p:txBody>
       </p:sp>
     </p:spTree>
-    <p:extLst>
-      <p:ext uri="{BB962C8B-B14F-4D97-AF65-F5344CB8AC3E}">
-        <p14:creationId xmlns:p14="http://schemas.microsoft.com/office/powerpoint/2010/main" val="1024086991"/>
-      </p:ext>
-    </p:extLst>
   </p:cSld>
   <p:clrMapOvr>
     <a:masterClrMapping/>
@@ -1301,10 +1209,6 @@
           <a:bodyPr/>
           <a:lstStyle/>
           <a:p>
-            <a:r>
-              <a:rPr lang="en-US" dirty="0"/>
-              <a:t/>
-            </a:r>
             <a:endParaRPr lang="en-US" dirty="0"/>
           </a:p>
         </p:txBody>
@@ -1326,18 +1230,12 @@
           <a:p>
             <a:fld id="{F7021451-1387-4CA6-816F-3879F97B5CBC}" type="slidenum">
               <a:rPr lang="en-US"/>
-              <a:t>9</a:t>
             </a:fld>
             <a:endParaRPr lang="en-US"/>
           </a:p>
         </p:txBody>
       </p:sp>
     </p:spTree>
-    <p:extLst>
-      <p:ext uri="{BB962C8B-B14F-4D97-AF65-F5344CB8AC3E}">
-        <p14:creationId xmlns:p14="http://schemas.microsoft.com/office/powerpoint/2010/main" val="1024086991"/>
-      </p:ext>
-    </p:extLst>
   </p:cSld>
   <p:clrMapOvr>
     <a:masterClrMapping/>
@@ -1378,6 +1276,11 @@
 <file path=ppt/slideMasters/slideMaster1.xml><?xml version="1.0" encoding="utf-8"?>
 <p:sldMaster xmlns:a="http://schemas.openxmlformats.org/drawingml/2006/main" xmlns:r="http://schemas.openxmlformats.org/officeDocument/2006/relationships" xmlns:p="http://schemas.openxmlformats.org/presentationml/2006/main">
   <p:cSld>
+    <p:bg>
+      <p:bgRef idx="1001">
+        <a:schemeClr val="bg1"/>
+      </p:bgRef>
+    </p:bg>
     <p:spTree>
       <p:nvGrpSpPr>
         <p:cNvPr id="1" name=""/>
@@ -1421,7 +1324,7 @@
         <a:spcBef>
           <a:spcPct val="20000"/>
         </a:spcBef>
-        <a:buFont typeface="Arial" pitchFamily="34" charset="0"/>
+        <a:buFont typeface="Arial" panose="020B0604020202020204" pitchFamily="34" charset="0"/>
         <a:buChar char="•"/>
         <a:defRPr sz="3200" kern="1200">
           <a:solidFill>
@@ -1436,7 +1339,7 @@
         <a:spcBef>
           <a:spcPct val="20000"/>
         </a:spcBef>
-        <a:buFont typeface="Arial" pitchFamily="34" charset="0"/>
+        <a:buFont typeface="Arial" panose="020B0604020202020204" pitchFamily="34" charset="0"/>
         <a:buChar char="–"/>
         <a:defRPr sz="2800" kern="1200">
           <a:solidFill>
@@ -1451,7 +1354,7 @@
         <a:spcBef>
           <a:spcPct val="20000"/>
         </a:spcBef>
-        <a:buFont typeface="Arial" pitchFamily="34" charset="0"/>
+        <a:buFont typeface="Arial" panose="020B0604020202020204" pitchFamily="34" charset="0"/>
         <a:buChar char="•"/>
         <a:defRPr sz="2400" kern="1200">
           <a:solidFill>
@@ -1466,7 +1369,7 @@
         <a:spcBef>
           <a:spcPct val="20000"/>
         </a:spcBef>
-        <a:buFont typeface="Arial" pitchFamily="34" charset="0"/>
+        <a:buFont typeface="Arial" panose="020B0604020202020204" pitchFamily="34" charset="0"/>
         <a:buChar char="–"/>
         <a:defRPr sz="2000" kern="1200">
           <a:solidFill>
@@ -1481,7 +1384,7 @@
         <a:spcBef>
           <a:spcPct val="20000"/>
         </a:spcBef>
-        <a:buFont typeface="Arial" pitchFamily="34" charset="0"/>
+        <a:buFont typeface="Arial" panose="020B0604020202020204" pitchFamily="34" charset="0"/>
         <a:buChar char="»"/>
         <a:defRPr sz="2000" kern="1200">
           <a:solidFill>
@@ -1496,7 +1399,7 @@
         <a:spcBef>
           <a:spcPct val="20000"/>
         </a:spcBef>
-        <a:buFont typeface="Arial" pitchFamily="34" charset="0"/>
+        <a:buFont typeface="Arial" panose="020B0604020202020204" pitchFamily="34" charset="0"/>
         <a:buChar char="•"/>
         <a:defRPr sz="2000" kern="1200">
           <a:solidFill>
@@ -1511,7 +1414,7 @@
         <a:spcBef>
           <a:spcPct val="20000"/>
         </a:spcBef>
-        <a:buFont typeface="Arial" pitchFamily="34" charset="0"/>
+        <a:buFont typeface="Arial" panose="020B0604020202020204" pitchFamily="34" charset="0"/>
         <a:buChar char="•"/>
         <a:defRPr sz="2000" kern="1200">
           <a:solidFill>
@@ -1526,7 +1429,7 @@
         <a:spcBef>
           <a:spcPct val="20000"/>
         </a:spcBef>
-        <a:buFont typeface="Arial" pitchFamily="34" charset="0"/>
+        <a:buFont typeface="Arial" panose="020B0604020202020204" pitchFamily="34" charset="0"/>
         <a:buChar char="•"/>
         <a:defRPr sz="2000" kern="1200">
           <a:solidFill>
@@ -1541,7 +1444,7 @@
         <a:spcBef>
           <a:spcPct val="20000"/>
         </a:spcBef>
-        <a:buFont typeface="Arial" pitchFamily="34" charset="0"/>
+        <a:buFont typeface="Arial" panose="020B0604020202020204" pitchFamily="34" charset="0"/>
         <a:buChar char="•"/>
         <a:defRPr sz="2000" kern="1200">
           <a:solidFill>
@@ -1654,12 +1557,13 @@
 
 <file path=ppt/slides/slide1.xml><?xml version="1.0" encoding="utf-8"?>
 <p:sld xmlns:a="http://schemas.openxmlformats.org/drawingml/2006/main" xmlns:r="http://schemas.openxmlformats.org/officeDocument/2006/relationships" xmlns:p="http://schemas.openxmlformats.org/presentationml/2006/main">
-  <p:cSld name="Slide 1">
+  <p:cSld>
     <p:bg>
       <p:bgPr>
         <a:solidFill>
           <a:srgbClr val="050816"/>
         </a:solidFill>
+        <a:effectLst/>
       </p:bgPr>
     </p:bg>
     <p:spTree>
@@ -2418,13 +2322,12 @@
             <a:avLst/>
           </a:prstGeom>
           <a:noFill/>
-          <a:ln/>
         </p:spPr>
         <p:txBody>
           <a:bodyPr wrap="square" lIns="0" tIns="0" rIns="0" bIns="0" rtlCol="0" anchor="ctr"/>
           <a:lstStyle/>
           <a:p>
-            <a:pPr indent="0" marL="0">
+            <a:pPr marL="0" indent="0">
               <a:buNone/>
             </a:pPr>
             <a:r>
@@ -2454,13 +2357,12 @@
             <a:avLst/>
           </a:prstGeom>
           <a:noFill/>
-          <a:ln/>
         </p:spPr>
         <p:txBody>
           <a:bodyPr wrap="square" lIns="0" tIns="0" rIns="0" bIns="0" rtlCol="0" anchor="ctr"/>
           <a:lstStyle/>
           <a:p>
-            <a:pPr indent="0" marL="0">
+            <a:pPr marL="0" indent="0">
               <a:buNone/>
             </a:pPr>
             <a:r>
@@ -2490,7 +2392,6 @@
             <a:avLst/>
           </a:prstGeom>
           <a:noFill/>
-          <a:ln/>
         </p:spPr>
         <p:txBody>
           <a:bodyPr wrap="square" lIns="0" tIns="0" rIns="0" bIns="0" rtlCol="0" anchor="ctr">
@@ -2498,7 +2399,7 @@
           </a:bodyPr>
           <a:lstStyle/>
           <a:p>
-            <a:pPr indent="0" marL="0">
+            <a:pPr marL="0" indent="0">
               <a:buNone/>
             </a:pPr>
             <a:r>
@@ -2559,17 +2460,16 @@
             <a:avLst/>
           </a:prstGeom>
           <a:noFill/>
-          <a:ln/>
         </p:spPr>
         <p:txBody>
           <a:bodyPr wrap="square" lIns="0" tIns="0" rIns="0" bIns="0" rtlCol="0" anchor="ctr"/>
           <a:lstStyle/>
           <a:p>
-            <a:pPr algn="ctr" indent="0" marL="0">
+            <a:pPr marL="0" indent="0" algn="ctr">
               <a:buNone/>
             </a:pPr>
             <a:r>
-              <a:rPr lang="en-US" sz="850" b="1" spc="110" kern="0" dirty="0">
+              <a:rPr lang="en-US" sz="850" b="1" kern="0" spc="110" dirty="0">
                 <a:solidFill>
                   <a:srgbClr val="5EEAD4"/>
                 </a:solidFill>
@@ -2626,17 +2526,16 @@
             <a:avLst/>
           </a:prstGeom>
           <a:noFill/>
-          <a:ln/>
         </p:spPr>
         <p:txBody>
           <a:bodyPr wrap="square" lIns="0" tIns="0" rIns="0" bIns="0" rtlCol="0" anchor="ctr"/>
           <a:lstStyle/>
           <a:p>
-            <a:pPr algn="ctr" indent="0" marL="0">
+            <a:pPr marL="0" indent="0" algn="ctr">
               <a:buNone/>
             </a:pPr>
             <a:r>
-              <a:rPr lang="en-US" sz="850" b="1" spc="110" kern="0" dirty="0">
+              <a:rPr lang="en-US" sz="850" b="1" kern="0" spc="110" dirty="0">
                 <a:solidFill>
                   <a:srgbClr val="A78BFA"/>
                 </a:solidFill>
@@ -2693,17 +2592,16 @@
             <a:avLst/>
           </a:prstGeom>
           <a:noFill/>
-          <a:ln/>
         </p:spPr>
         <p:txBody>
           <a:bodyPr wrap="square" lIns="0" tIns="0" rIns="0" bIns="0" rtlCol="0" anchor="ctr"/>
           <a:lstStyle/>
           <a:p>
-            <a:pPr algn="ctr" indent="0" marL="0">
+            <a:pPr marL="0" indent="0" algn="ctr">
               <a:buNone/>
             </a:pPr>
             <a:r>
-              <a:rPr lang="en-US" sz="850" b="1" spc="110" kern="0" dirty="0">
+              <a:rPr lang="en-US" sz="850" b="1" kern="0" spc="110" dirty="0">
                 <a:solidFill>
                   <a:srgbClr val="5EEAD4"/>
                 </a:solidFill>
@@ -2760,17 +2658,16 @@
             <a:avLst/>
           </a:prstGeom>
           <a:noFill/>
-          <a:ln/>
         </p:spPr>
         <p:txBody>
           <a:bodyPr wrap="square" lIns="0" tIns="0" rIns="0" bIns="0" rtlCol="0" anchor="ctr"/>
           <a:lstStyle/>
           <a:p>
-            <a:pPr algn="ctr" indent="0" marL="0">
+            <a:pPr marL="0" indent="0" algn="ctr">
               <a:buNone/>
             </a:pPr>
             <a:r>
-              <a:rPr lang="en-US" sz="850" b="1" spc="110" kern="0" dirty="0">
+              <a:rPr lang="en-US" sz="850" b="1" kern="0" spc="110" dirty="0">
                 <a:solidFill>
                   <a:srgbClr val="A78BFA"/>
                 </a:solidFill>
@@ -2827,17 +2724,16 @@
             <a:avLst/>
           </a:prstGeom>
           <a:noFill/>
-          <a:ln/>
         </p:spPr>
         <p:txBody>
           <a:bodyPr wrap="square" lIns="0" tIns="0" rIns="0" bIns="0" rtlCol="0" anchor="ctr"/>
           <a:lstStyle/>
           <a:p>
-            <a:pPr algn="ctr" indent="0" marL="0">
+            <a:pPr marL="0" indent="0" algn="ctr">
               <a:buNone/>
             </a:pPr>
             <a:r>
-              <a:rPr lang="en-US" sz="850" b="1" spc="110" kern="0" dirty="0">
+              <a:rPr lang="en-US" sz="850" b="1" kern="0" spc="110" dirty="0">
                 <a:solidFill>
                   <a:srgbClr val="5EEAD4"/>
                 </a:solidFill>
@@ -2921,13 +2817,12 @@
             <a:avLst/>
           </a:prstGeom>
           <a:noFill/>
-          <a:ln/>
         </p:spPr>
         <p:txBody>
           <a:bodyPr wrap="square" lIns="0" tIns="0" rIns="0" bIns="0" rtlCol="0" anchor="ctr"/>
           <a:lstStyle/>
           <a:p>
-            <a:pPr algn="ctr" indent="0" marL="0">
+            <a:pPr marL="0" indent="0" algn="ctr">
               <a:buNone/>
             </a:pPr>
             <a:r>
@@ -2957,17 +2852,16 @@
             <a:avLst/>
           </a:prstGeom>
           <a:noFill/>
-          <a:ln/>
         </p:spPr>
         <p:txBody>
           <a:bodyPr wrap="square" lIns="0" tIns="0" rIns="0" bIns="0" rtlCol="0" anchor="ctr"/>
           <a:lstStyle/>
           <a:p>
-            <a:pPr algn="ctr" indent="0" marL="0">
+            <a:pPr marL="0" indent="0" algn="ctr">
               <a:buNone/>
             </a:pPr>
             <a:r>
-              <a:rPr lang="en-US" sz="850" spc="180" kern="0" dirty="0">
+              <a:rPr lang="en-US" sz="850" kern="0" spc="180" dirty="0">
                 <a:solidFill>
                   <a:srgbClr val="5EEAD4"/>
                 </a:solidFill>
@@ -2993,7 +2887,6 @@
             <a:avLst/>
           </a:prstGeom>
           <a:noFill/>
-          <a:ln/>
         </p:spPr>
         <p:txBody>
           <a:bodyPr wrap="square" lIns="0" tIns="0" rIns="0" bIns="0" rtlCol="0" anchor="ctr">
@@ -3001,7 +2894,7 @@
           </a:bodyPr>
           <a:lstStyle/>
           <a:p>
-            <a:pPr algn="ctr" indent="0" marL="0">
+            <a:pPr marL="0" indent="0" algn="ctr">
               <a:buNone/>
             </a:pPr>
             <a:r>
@@ -3031,13 +2924,12 @@
             <a:avLst/>
           </a:prstGeom>
           <a:noFill/>
-          <a:ln/>
         </p:spPr>
         <p:txBody>
           <a:bodyPr wrap="square" lIns="0" tIns="0" rIns="0" bIns="0" rtlCol="0" anchor="ctr"/>
           <a:lstStyle/>
           <a:p>
-            <a:pPr indent="0" marL="0">
+            <a:pPr marL="0" indent="0">
               <a:buNone/>
             </a:pPr>
             <a:r>
@@ -3062,12 +2954,13 @@
 
 <file path=ppt/slides/slide10.xml><?xml version="1.0" encoding="utf-8"?>
 <p:sld xmlns:a="http://schemas.openxmlformats.org/drawingml/2006/main" xmlns:r="http://schemas.openxmlformats.org/officeDocument/2006/relationships" xmlns:p="http://schemas.openxmlformats.org/presentationml/2006/main">
-  <p:cSld name="Slide 10">
+  <p:cSld>
     <p:bg>
       <p:bgPr>
         <a:solidFill>
           <a:srgbClr val="050816"/>
         </a:solidFill>
+        <a:effectLst/>
       </p:bgPr>
     </p:bg>
     <p:spTree>
@@ -3819,24 +3712,23 @@
         </p:nvSpPr>
         <p:spPr>
           <a:xfrm>
-            <a:off x="566928" y="384048"/>
+            <a:off x="502793" y="155448"/>
             <a:ext cx="4389120" cy="228600"/>
           </a:xfrm>
           <a:prstGeom prst="rect">
             <a:avLst/>
           </a:prstGeom>
           <a:noFill/>
-          <a:ln/>
         </p:spPr>
         <p:txBody>
           <a:bodyPr wrap="square" lIns="0" tIns="0" rIns="0" bIns="0" rtlCol="0" anchor="ctr"/>
           <a:lstStyle/>
           <a:p>
-            <a:pPr indent="0" marL="0">
+            <a:pPr marL="0" indent="0">
               <a:buNone/>
             </a:pPr>
             <a:r>
-              <a:rPr lang="en-US" sz="950" b="1" spc="260" kern="0" dirty="0">
+              <a:rPr lang="en-US" sz="950" b="1" kern="0" spc="260" dirty="0">
                 <a:solidFill>
                   <a:srgbClr val="5EEAD4"/>
                 </a:solidFill>
@@ -3862,13 +3754,12 @@
             <a:avLst/>
           </a:prstGeom>
           <a:noFill/>
-          <a:ln/>
         </p:spPr>
         <p:txBody>
           <a:bodyPr wrap="square" lIns="0" tIns="0" rIns="0" bIns="0" rtlCol="0" anchor="ctr"/>
           <a:lstStyle/>
           <a:p>
-            <a:pPr indent="0" marL="0">
+            <a:pPr marL="0" indent="0">
               <a:buNone/>
             </a:pPr>
             <a:r>
@@ -3876,9 +3767,9 @@
                 <a:solidFill>
                   <a:srgbClr val="F8FAFC"/>
                 </a:solidFill>
-                <a:latin typeface="Microsoft YaHei UI" pitchFamily="34" charset="0"/>
-                <a:ea typeface="Microsoft YaHei UI" pitchFamily="34" charset="-122"/>
-                <a:cs typeface="Microsoft YaHei UI" pitchFamily="34" charset="-120"/>
+                <a:latin typeface="Microsoft YaHei UI" panose="020B0503020204020204" pitchFamily="34" charset="-122"/>
+                <a:ea typeface="Microsoft YaHei UI" panose="020B0503020204020204" pitchFamily="34" charset="-122"/>
+                <a:cs typeface="Microsoft YaHei UI" panose="020B0503020204020204" pitchFamily="34" charset="-120"/>
               </a:rPr>
               <a:t>LifeOS Agent：让一个人的长期成长拥有反馈系统</a:t>
             </a:r>
@@ -3901,7 +3792,6 @@
             <a:avLst/>
           </a:prstGeom>
           <a:noFill/>
-          <a:ln/>
         </p:spPr>
         <p:txBody>
           <a:bodyPr wrap="square" lIns="0" tIns="0" rIns="0" bIns="0" rtlCol="0" anchor="ctr">
@@ -3909,7 +3799,7 @@
           </a:bodyPr>
           <a:lstStyle/>
           <a:p>
-            <a:pPr indent="0" marL="0">
+            <a:pPr marL="0" indent="0">
               <a:buNone/>
             </a:pPr>
             <a:r>
@@ -3970,24 +3860,27 @@
             <a:avLst/>
           </a:prstGeom>
           <a:noFill/>
-          <a:ln/>
         </p:spPr>
         <p:txBody>
           <a:bodyPr wrap="square" lIns="0" tIns="0" rIns="0" bIns="0" rtlCol="0" anchor="ctr"/>
           <a:lstStyle/>
           <a:p>
-            <a:pPr algn="ctr" indent="0" marL="0">
+            <a:pPr marL="0" indent="0" algn="ctr">
               <a:buNone/>
             </a:pPr>
             <a:r>
-              <a:rPr lang="en-US" sz="840" b="1" spc="120" kern="0" dirty="0">
+              <a:rPr lang="en-US" sz="1200" b="1" kern="0" spc="120" dirty="0">
                 <a:solidFill>
                   <a:srgbClr val="5EEAD4"/>
                 </a:solidFill>
               </a:rPr>
-              <a:t>总结 / 3→1</a:t>
-            </a:r>
-            <a:endParaRPr lang="en-US" sz="840" dirty="0"/>
+              <a:t>总结 </a:t>
+            </a:r>
+            <a:endParaRPr lang="en-US" sz="1200" b="1" kern="0" spc="120" dirty="0">
+              <a:solidFill>
+                <a:srgbClr val="5EEAD4"/>
+              </a:solidFill>
+            </a:endParaRPr>
           </a:p>
         </p:txBody>
       </p:sp>
@@ -3999,14 +3892,13 @@
         </p:nvSpPr>
         <p:spPr>
           <a:xfrm>
-            <a:off x="9784080" y="566928"/>
+            <a:off x="9902825" y="603123"/>
             <a:ext cx="1481328" cy="146304"/>
           </a:xfrm>
           <a:prstGeom prst="rect">
             <a:avLst/>
           </a:prstGeom>
           <a:noFill/>
-          <a:ln/>
         </p:spPr>
         <p:txBody>
           <a:bodyPr wrap="square" lIns="0" tIns="0" rIns="0" bIns="0" rtlCol="0" anchor="ctr">
@@ -4014,7 +3906,7 @@
           </a:bodyPr>
           <a:lstStyle/>
           <a:p>
-            <a:pPr indent="0" marL="0">
+            <a:pPr marL="0" indent="0">
               <a:buNone/>
             </a:pPr>
             <a:r>
@@ -4059,7 +3951,7 @@
             <a:prstDash val="solid"/>
           </a:ln>
           <a:effectLst>
-            <a:outerShdw sx="100000" sy="100000" kx="0" ky="0" algn="bl" rotWithShape="0" blurRad="25400" dist="12700" dir="2700000">
+            <a:outerShdw blurRad="25400" dist="12700" dir="2700000" algn="bl" rotWithShape="0">
               <a:srgbClr val="000000">
                 <a:alpha val="16000"/>
               </a:srgbClr>
@@ -4082,13 +3974,12 @@
             <a:avLst/>
           </a:prstGeom>
           <a:noFill/>
-          <a:ln/>
         </p:spPr>
         <p:txBody>
           <a:bodyPr wrap="square" lIns="0" tIns="0" rIns="0" bIns="0" rtlCol="0" anchor="ctr"/>
           <a:lstStyle/>
           <a:p>
-            <a:pPr indent="0" marL="0">
+            <a:pPr marL="0" indent="0">
               <a:buNone/>
             </a:pPr>
             <a:r>
@@ -4118,7 +4009,6 @@
             <a:avLst/>
           </a:prstGeom>
           <a:noFill/>
-          <a:ln/>
         </p:spPr>
         <p:txBody>
           <a:bodyPr wrap="square" lIns="0" tIns="0" rIns="0" bIns="0" rtlCol="0" anchor="ctr">
@@ -4126,7 +4016,7 @@
           </a:bodyPr>
           <a:lstStyle/>
           <a:p>
-            <a:pPr indent="0" marL="0">
+            <a:pPr marL="0" indent="0">
               <a:buNone/>
             </a:pPr>
             <a:r>
@@ -4171,7 +4061,7 @@
             <a:prstDash val="solid"/>
           </a:ln>
           <a:effectLst>
-            <a:outerShdw sx="100000" sy="100000" kx="0" ky="0" algn="bl" rotWithShape="0" blurRad="25400" dist="12700" dir="2700000">
+            <a:outerShdw blurRad="25400" dist="12700" dir="2700000" algn="bl" rotWithShape="0">
               <a:srgbClr val="000000">
                 <a:alpha val="16000"/>
               </a:srgbClr>
@@ -4194,13 +4084,12 @@
             <a:avLst/>
           </a:prstGeom>
           <a:noFill/>
-          <a:ln/>
         </p:spPr>
         <p:txBody>
           <a:bodyPr wrap="square" lIns="0" tIns="0" rIns="0" bIns="0" rtlCol="0" anchor="ctr"/>
           <a:lstStyle/>
           <a:p>
-            <a:pPr indent="0" marL="0">
+            <a:pPr marL="0" indent="0">
               <a:buNone/>
             </a:pPr>
             <a:r>
@@ -4230,7 +4119,6 @@
             <a:avLst/>
           </a:prstGeom>
           <a:noFill/>
-          <a:ln/>
         </p:spPr>
         <p:txBody>
           <a:bodyPr wrap="square" lIns="0" tIns="0" rIns="0" bIns="0" rtlCol="0" anchor="ctr">
@@ -4238,7 +4126,7 @@
           </a:bodyPr>
           <a:lstStyle/>
           <a:p>
-            <a:pPr indent="0" marL="0">
+            <a:pPr marL="0" indent="0">
               <a:buNone/>
             </a:pPr>
             <a:r>
@@ -4283,7 +4171,7 @@
             <a:prstDash val="solid"/>
           </a:ln>
           <a:effectLst>
-            <a:outerShdw sx="100000" sy="100000" kx="0" ky="0" algn="bl" rotWithShape="0" blurRad="25400" dist="12700" dir="2700000">
+            <a:outerShdw blurRad="25400" dist="12700" dir="2700000" algn="bl" rotWithShape="0">
               <a:srgbClr val="000000">
                 <a:alpha val="16000"/>
               </a:srgbClr>
@@ -4306,13 +4194,12 @@
             <a:avLst/>
           </a:prstGeom>
           <a:noFill/>
-          <a:ln/>
         </p:spPr>
         <p:txBody>
           <a:bodyPr wrap="square" lIns="0" tIns="0" rIns="0" bIns="0" rtlCol="0" anchor="ctr"/>
           <a:lstStyle/>
           <a:p>
-            <a:pPr indent="0" marL="0">
+            <a:pPr marL="0" indent="0">
               <a:buNone/>
             </a:pPr>
             <a:r>
@@ -4342,7 +4229,6 @@
             <a:avLst/>
           </a:prstGeom>
           <a:noFill/>
-          <a:ln/>
         </p:spPr>
         <p:txBody>
           <a:bodyPr wrap="square" lIns="0" tIns="0" rIns="0" bIns="0" rtlCol="0" anchor="ctr">
@@ -4350,7 +4236,7 @@
           </a:bodyPr>
           <a:lstStyle/>
           <a:p>
-            <a:pPr indent="0" marL="0">
+            <a:pPr marL="0" indent="0">
               <a:buNone/>
             </a:pPr>
             <a:r>
@@ -4380,7 +4266,6 @@
             <a:avLst/>
           </a:prstGeom>
           <a:noFill/>
-          <a:ln/>
         </p:spPr>
         <p:txBody>
           <a:bodyPr wrap="square" lIns="0" tIns="0" rIns="0" bIns="0" rtlCol="0" anchor="ctr">
@@ -4388,7 +4273,7 @@
           </a:bodyPr>
           <a:lstStyle/>
           <a:p>
-            <a:pPr algn="ctr" indent="0" marL="0">
+            <a:pPr marL="0" indent="0" algn="ctr">
               <a:buNone/>
             </a:pPr>
             <a:r>
@@ -4411,20 +4296,19 @@
         </p:nvSpPr>
         <p:spPr>
           <a:xfrm>
-            <a:off x="4937760" y="5715000"/>
-            <a:ext cx="2194560" cy="274320"/>
-          </a:xfrm>
-          <a:prstGeom prst="rect">
-            <a:avLst/>
-          </a:prstGeom>
-          <a:noFill/>
-          <a:ln/>
+            <a:off x="4340860" y="5485765"/>
+            <a:ext cx="3479165" cy="805180"/>
+          </a:xfrm>
+          <a:prstGeom prst="rect">
+            <a:avLst/>
+          </a:prstGeom>
+          <a:noFill/>
         </p:spPr>
         <p:txBody>
           <a:bodyPr wrap="square" lIns="0" tIns="0" rIns="0" bIns="0" rtlCol="0" anchor="ctr"/>
           <a:lstStyle/>
           <a:p>
-            <a:pPr algn="ctr" indent="0" marL="0">
+            <a:pPr marL="0" indent="0" algn="ctr">
               <a:buNone/>
             </a:pPr>
             <a:r>
@@ -4454,13 +4338,12 @@
             <a:avLst/>
           </a:prstGeom>
           <a:noFill/>
-          <a:ln/>
         </p:spPr>
         <p:txBody>
           <a:bodyPr wrap="square" lIns="0" tIns="0" rIns="0" bIns="0" rtlCol="0" anchor="ctr"/>
           <a:lstStyle/>
           <a:p>
-            <a:pPr indent="0" marL="0">
+            <a:pPr marL="0" indent="0">
               <a:buNone/>
             </a:pPr>
             <a:r>
@@ -4485,12 +4368,13 @@
 
 <file path=ppt/slides/slide2.xml><?xml version="1.0" encoding="utf-8"?>
 <p:sld xmlns:a="http://schemas.openxmlformats.org/drawingml/2006/main" xmlns:r="http://schemas.openxmlformats.org/officeDocument/2006/relationships" xmlns:p="http://schemas.openxmlformats.org/presentationml/2006/main">
-  <p:cSld name="Slide 2">
+  <p:cSld>
     <p:bg>
       <p:bgPr>
         <a:solidFill>
           <a:srgbClr val="050816"/>
         </a:solidFill>
+        <a:effectLst/>
       </p:bgPr>
     </p:bg>
     <p:spTree>
@@ -5249,17 +5133,16 @@
             <a:avLst/>
           </a:prstGeom>
           <a:noFill/>
-          <a:ln/>
         </p:spPr>
         <p:txBody>
           <a:bodyPr wrap="square" lIns="0" tIns="0" rIns="0" bIns="0" rtlCol="0" anchor="ctr"/>
           <a:lstStyle/>
           <a:p>
-            <a:pPr indent="0" marL="0">
+            <a:pPr marL="0" indent="0">
               <a:buNone/>
             </a:pPr>
             <a:r>
-              <a:rPr lang="en-US" sz="950" b="1" spc="260" kern="0" dirty="0">
+              <a:rPr lang="en-US" sz="950" b="1" kern="0" spc="260" dirty="0">
                 <a:solidFill>
                   <a:srgbClr val="5EEAD4"/>
                 </a:solidFill>
@@ -5285,13 +5168,12 @@
             <a:avLst/>
           </a:prstGeom>
           <a:noFill/>
-          <a:ln/>
         </p:spPr>
         <p:txBody>
           <a:bodyPr wrap="square" lIns="0" tIns="0" rIns="0" bIns="0" rtlCol="0" anchor="ctr"/>
           <a:lstStyle/>
           <a:p>
-            <a:pPr indent="0" marL="0">
+            <a:pPr marL="0" indent="0">
               <a:buNone/>
             </a:pPr>
             <a:r>
@@ -5299,9 +5181,9 @@
                 <a:solidFill>
                   <a:srgbClr val="F8FAFC"/>
                 </a:solidFill>
-                <a:latin typeface="Microsoft YaHei UI" pitchFamily="34" charset="0"/>
-                <a:ea typeface="Microsoft YaHei UI" pitchFamily="34" charset="-122"/>
-                <a:cs typeface="Microsoft YaHei UI" pitchFamily="34" charset="-120"/>
+                <a:latin typeface="Microsoft YaHei UI" panose="020B0503020204020204" pitchFamily="34" charset="-122"/>
+                <a:ea typeface="Microsoft YaHei UI" panose="020B0503020204020204" pitchFamily="34" charset="-122"/>
+                <a:cs typeface="Microsoft YaHei UI" panose="020B0503020204020204" pitchFamily="34" charset="-120"/>
               </a:rPr>
               <a:t>路演目录：三段式讲清 LifeOS Agent</a:t>
             </a:r>
@@ -5324,7 +5206,6 @@
             <a:avLst/>
           </a:prstGeom>
           <a:noFill/>
-          <a:ln/>
         </p:spPr>
         <p:txBody>
           <a:bodyPr wrap="square" lIns="0" tIns="0" rIns="0" bIns="0" rtlCol="0" anchor="ctr">
@@ -5332,7 +5213,7 @@
           </a:bodyPr>
           <a:lstStyle/>
           <a:p>
-            <a:pPr indent="0" marL="0">
+            <a:pPr marL="0" indent="0">
               <a:buNone/>
             </a:pPr>
             <a:r>
@@ -5377,7 +5258,7 @@
             <a:prstDash val="solid"/>
           </a:ln>
           <a:effectLst>
-            <a:outerShdw sx="100000" sy="100000" kx="0" ky="0" algn="bl" rotWithShape="0" blurRad="25400" dist="12700" dir="2700000">
+            <a:outerShdw blurRad="25400" dist="12700" dir="2700000" algn="bl" rotWithShape="0">
               <a:srgbClr val="000000">
                 <a:alpha val="16000"/>
               </a:srgbClr>
@@ -5400,13 +5281,12 @@
             <a:avLst/>
           </a:prstGeom>
           <a:noFill/>
-          <a:ln/>
         </p:spPr>
         <p:txBody>
           <a:bodyPr wrap="square" lIns="0" tIns="0" rIns="0" bIns="0" rtlCol="0" anchor="ctr"/>
           <a:lstStyle/>
           <a:p>
-            <a:pPr algn="ctr" indent="0" marL="0">
+            <a:pPr marL="0" indent="0" algn="ctr">
               <a:buNone/>
             </a:pPr>
             <a:r>
@@ -5436,13 +5316,12 @@
             <a:avLst/>
           </a:prstGeom>
           <a:noFill/>
-          <a:ln/>
         </p:spPr>
         <p:txBody>
           <a:bodyPr wrap="square" lIns="0" tIns="0" rIns="0" bIns="0" rtlCol="0" anchor="ctr"/>
           <a:lstStyle/>
           <a:p>
-            <a:pPr indent="0" marL="0">
+            <a:pPr marL="0" indent="0">
               <a:buNone/>
             </a:pPr>
             <a:r>
@@ -5472,13 +5351,12 @@
             <a:avLst/>
           </a:prstGeom>
           <a:noFill/>
-          <a:ln/>
         </p:spPr>
         <p:txBody>
           <a:bodyPr wrap="square" lIns="0" tIns="0" rIns="0" bIns="0" rtlCol="0" anchor="ctr"/>
           <a:lstStyle/>
           <a:p>
-            <a:pPr indent="0" marL="0">
+            <a:pPr marL="0" indent="0">
               <a:buNone/>
             </a:pPr>
             <a:r>
@@ -5537,7 +5415,6 @@
             <a:avLst/>
           </a:prstGeom>
           <a:noFill/>
-          <a:ln/>
         </p:spPr>
         <p:txBody>
           <a:bodyPr wrap="square" lIns="0" tIns="0" rIns="0" bIns="0" rtlCol="0" anchor="ctr">
@@ -5545,7 +5422,7 @@
           </a:bodyPr>
           <a:lstStyle/>
           <a:p>
-            <a:pPr indent="0" marL="0">
+            <a:pPr marL="0" indent="0">
               <a:buNone/>
             </a:pPr>
             <a:r>
@@ -5604,7 +5481,6 @@
             <a:avLst/>
           </a:prstGeom>
           <a:noFill/>
-          <a:ln/>
         </p:spPr>
         <p:txBody>
           <a:bodyPr wrap="square" lIns="0" tIns="0" rIns="0" bIns="0" rtlCol="0" anchor="ctr">
@@ -5612,7 +5488,7 @@
           </a:bodyPr>
           <a:lstStyle/>
           <a:p>
-            <a:pPr indent="0" marL="0">
+            <a:pPr marL="0" indent="0">
               <a:buNone/>
             </a:pPr>
             <a:r>
@@ -5671,7 +5547,6 @@
             <a:avLst/>
           </a:prstGeom>
           <a:noFill/>
-          <a:ln/>
         </p:spPr>
         <p:txBody>
           <a:bodyPr wrap="square" lIns="0" tIns="0" rIns="0" bIns="0" rtlCol="0" anchor="ctr">
@@ -5679,7 +5554,7 @@
           </a:bodyPr>
           <a:lstStyle/>
           <a:p>
-            <a:pPr indent="0" marL="0">
+            <a:pPr marL="0" indent="0">
               <a:buNone/>
             </a:pPr>
             <a:r>
@@ -5724,7 +5599,7 @@
             <a:prstDash val="solid"/>
           </a:ln>
           <a:effectLst>
-            <a:outerShdw sx="100000" sy="100000" kx="0" ky="0" algn="bl" rotWithShape="0" blurRad="25400" dist="12700" dir="2700000">
+            <a:outerShdw blurRad="25400" dist="12700" dir="2700000" algn="bl" rotWithShape="0">
               <a:srgbClr val="000000">
                 <a:alpha val="16000"/>
               </a:srgbClr>
@@ -5747,13 +5622,12 @@
             <a:avLst/>
           </a:prstGeom>
           <a:noFill/>
-          <a:ln/>
         </p:spPr>
         <p:txBody>
           <a:bodyPr wrap="square" lIns="0" tIns="0" rIns="0" bIns="0" rtlCol="0" anchor="ctr"/>
           <a:lstStyle/>
           <a:p>
-            <a:pPr algn="ctr" indent="0" marL="0">
+            <a:pPr marL="0" indent="0" algn="ctr">
               <a:buNone/>
             </a:pPr>
             <a:r>
@@ -5783,13 +5657,12 @@
             <a:avLst/>
           </a:prstGeom>
           <a:noFill/>
-          <a:ln/>
         </p:spPr>
         <p:txBody>
           <a:bodyPr wrap="square" lIns="0" tIns="0" rIns="0" bIns="0" rtlCol="0" anchor="ctr"/>
           <a:lstStyle/>
           <a:p>
-            <a:pPr indent="0" marL="0">
+            <a:pPr marL="0" indent="0">
               <a:buNone/>
             </a:pPr>
             <a:r>
@@ -5819,13 +5692,12 @@
             <a:avLst/>
           </a:prstGeom>
           <a:noFill/>
-          <a:ln/>
         </p:spPr>
         <p:txBody>
           <a:bodyPr wrap="square" lIns="0" tIns="0" rIns="0" bIns="0" rtlCol="0" anchor="ctr"/>
           <a:lstStyle/>
           <a:p>
-            <a:pPr indent="0" marL="0">
+            <a:pPr marL="0" indent="0">
               <a:buNone/>
             </a:pPr>
             <a:r>
@@ -5884,7 +5756,6 @@
             <a:avLst/>
           </a:prstGeom>
           <a:noFill/>
-          <a:ln/>
         </p:spPr>
         <p:txBody>
           <a:bodyPr wrap="square" lIns="0" tIns="0" rIns="0" bIns="0" rtlCol="0" anchor="ctr">
@@ -5892,7 +5763,7 @@
           </a:bodyPr>
           <a:lstStyle/>
           <a:p>
-            <a:pPr indent="0" marL="0">
+            <a:pPr marL="0" indent="0">
               <a:buNone/>
             </a:pPr>
             <a:r>
@@ -5951,7 +5822,6 @@
             <a:avLst/>
           </a:prstGeom>
           <a:noFill/>
-          <a:ln/>
         </p:spPr>
         <p:txBody>
           <a:bodyPr wrap="square" lIns="0" tIns="0" rIns="0" bIns="0" rtlCol="0" anchor="ctr">
@@ -5959,7 +5829,7 @@
           </a:bodyPr>
           <a:lstStyle/>
           <a:p>
-            <a:pPr indent="0" marL="0">
+            <a:pPr marL="0" indent="0">
               <a:buNone/>
             </a:pPr>
             <a:r>
@@ -6018,7 +5888,6 @@
             <a:avLst/>
           </a:prstGeom>
           <a:noFill/>
-          <a:ln/>
         </p:spPr>
         <p:txBody>
           <a:bodyPr wrap="square" lIns="0" tIns="0" rIns="0" bIns="0" rtlCol="0" anchor="ctr">
@@ -6026,7 +5895,7 @@
           </a:bodyPr>
           <a:lstStyle/>
           <a:p>
-            <a:pPr indent="0" marL="0">
+            <a:pPr marL="0" indent="0">
               <a:buNone/>
             </a:pPr>
             <a:r>
@@ -6071,7 +5940,7 @@
             <a:prstDash val="solid"/>
           </a:ln>
           <a:effectLst>
-            <a:outerShdw sx="100000" sy="100000" kx="0" ky="0" algn="bl" rotWithShape="0" blurRad="25400" dist="12700" dir="2700000">
+            <a:outerShdw blurRad="25400" dist="12700" dir="2700000" algn="bl" rotWithShape="0">
               <a:srgbClr val="000000">
                 <a:alpha val="16000"/>
               </a:srgbClr>
@@ -6094,13 +5963,12 @@
             <a:avLst/>
           </a:prstGeom>
           <a:noFill/>
-          <a:ln/>
         </p:spPr>
         <p:txBody>
           <a:bodyPr wrap="square" lIns="0" tIns="0" rIns="0" bIns="0" rtlCol="0" anchor="ctr"/>
           <a:lstStyle/>
           <a:p>
-            <a:pPr algn="ctr" indent="0" marL="0">
+            <a:pPr marL="0" indent="0" algn="ctr">
               <a:buNone/>
             </a:pPr>
             <a:r>
@@ -6130,13 +5998,12 @@
             <a:avLst/>
           </a:prstGeom>
           <a:noFill/>
-          <a:ln/>
         </p:spPr>
         <p:txBody>
           <a:bodyPr wrap="square" lIns="0" tIns="0" rIns="0" bIns="0" rtlCol="0" anchor="ctr"/>
           <a:lstStyle/>
           <a:p>
-            <a:pPr indent="0" marL="0">
+            <a:pPr marL="0" indent="0">
               <a:buNone/>
             </a:pPr>
             <a:r>
@@ -6166,13 +6033,12 @@
             <a:avLst/>
           </a:prstGeom>
           <a:noFill/>
-          <a:ln/>
         </p:spPr>
         <p:txBody>
           <a:bodyPr wrap="square" lIns="0" tIns="0" rIns="0" bIns="0" rtlCol="0" anchor="ctr"/>
           <a:lstStyle/>
           <a:p>
-            <a:pPr indent="0" marL="0">
+            <a:pPr marL="0" indent="0">
               <a:buNone/>
             </a:pPr>
             <a:r>
@@ -6231,7 +6097,6 @@
             <a:avLst/>
           </a:prstGeom>
           <a:noFill/>
-          <a:ln/>
         </p:spPr>
         <p:txBody>
           <a:bodyPr wrap="square" lIns="0" tIns="0" rIns="0" bIns="0" rtlCol="0" anchor="ctr">
@@ -6239,7 +6104,7 @@
           </a:bodyPr>
           <a:lstStyle/>
           <a:p>
-            <a:pPr indent="0" marL="0">
+            <a:pPr marL="0" indent="0">
               <a:buNone/>
             </a:pPr>
             <a:r>
@@ -6298,7 +6163,6 @@
             <a:avLst/>
           </a:prstGeom>
           <a:noFill/>
-          <a:ln/>
         </p:spPr>
         <p:txBody>
           <a:bodyPr wrap="square" lIns="0" tIns="0" rIns="0" bIns="0" rtlCol="0" anchor="ctr">
@@ -6306,7 +6170,7 @@
           </a:bodyPr>
           <a:lstStyle/>
           <a:p>
-            <a:pPr indent="0" marL="0">
+            <a:pPr marL="0" indent="0">
               <a:buNone/>
             </a:pPr>
             <a:r>
@@ -6365,7 +6229,6 @@
             <a:avLst/>
           </a:prstGeom>
           <a:noFill/>
-          <a:ln/>
         </p:spPr>
         <p:txBody>
           <a:bodyPr wrap="square" lIns="0" tIns="0" rIns="0" bIns="0" rtlCol="0" anchor="ctr">
@@ -6373,7 +6236,7 @@
           </a:bodyPr>
           <a:lstStyle/>
           <a:p>
-            <a:pPr indent="0" marL="0">
+            <a:pPr marL="0" indent="0">
               <a:buNone/>
             </a:pPr>
             <a:r>
@@ -6390,78 +6253,6 @@
       </p:sp>
       <p:sp>
         <p:nvSpPr>
-          <p:cNvPr id="64" name="Text 62"/>
-          <p:cNvSpPr/>
-          <p:nvPr/>
-        </p:nvSpPr>
-        <p:spPr>
-          <a:xfrm>
-            <a:off x="822960" y="5715000"/>
-            <a:ext cx="1005840" cy="182880"/>
-          </a:xfrm>
-          <a:prstGeom prst="rect">
-            <a:avLst/>
-          </a:prstGeom>
-          <a:noFill/>
-          <a:ln/>
-        </p:spPr>
-        <p:txBody>
-          <a:bodyPr wrap="square" lIns="0" tIns="0" rIns="0" bIns="0" rtlCol="0" anchor="ctr"/>
-          <a:lstStyle/>
-          <a:p>
-            <a:pPr indent="0" marL="0">
-              <a:buNone/>
-            </a:pPr>
-            <a:r>
-              <a:rPr lang="en-US" sz="1200" b="1" dirty="0">
-                <a:solidFill>
-                  <a:srgbClr val="5EEAD4"/>
-                </a:solidFill>
-              </a:rPr>
-              <a:t>路演节奏</a:t>
-            </a:r>
-            <a:endParaRPr lang="en-US" sz="1200" dirty="0"/>
-          </a:p>
-        </p:txBody>
-      </p:sp>
-      <p:sp>
-        <p:nvSpPr>
-          <p:cNvPr id="65" name="Text 63"/>
-          <p:cNvSpPr/>
-          <p:nvPr/>
-        </p:nvSpPr>
-        <p:spPr>
-          <a:xfrm>
-            <a:off x="1828800" y="5687568"/>
-            <a:ext cx="6492240" cy="201168"/>
-          </a:xfrm>
-          <a:prstGeom prst="rect">
-            <a:avLst/>
-          </a:prstGeom>
-          <a:noFill/>
-          <a:ln/>
-        </p:spPr>
-        <p:txBody>
-          <a:bodyPr wrap="square" lIns="0" tIns="0" rIns="0" bIns="0" rtlCol="0" anchor="ctr"/>
-          <a:lstStyle/>
-          <a:p>
-            <a:pPr indent="0" marL="0">
-              <a:buNone/>
-            </a:pPr>
-            <a:r>
-              <a:rPr lang="en-US" sz="1350" b="1" dirty="0">
-                <a:solidFill>
-                  <a:srgbClr val="F8FAFC"/>
-                </a:solidFill>
-              </a:rPr>
-              <a:t>4-5 分钟：需求 60s / 体验 90s / 工程 120s / 总结 30s。</a:t>
-            </a:r>
-            <a:endParaRPr lang="en-US" sz="1350" dirty="0"/>
-          </a:p>
-        </p:txBody>
-      </p:sp>
-      <p:sp>
-        <p:nvSpPr>
           <p:cNvPr id="66" name="Text 64"/>
           <p:cNvSpPr/>
           <p:nvPr/>
@@ -6475,13 +6266,12 @@
             <a:avLst/>
           </a:prstGeom>
           <a:noFill/>
-          <a:ln/>
         </p:spPr>
         <p:txBody>
           <a:bodyPr wrap="square" lIns="0" tIns="0" rIns="0" bIns="0" rtlCol="0" anchor="ctr"/>
           <a:lstStyle/>
           <a:p>
-            <a:pPr indent="0" marL="0">
+            <a:pPr marL="0" indent="0">
               <a:buNone/>
             </a:pPr>
             <a:r>
@@ -6506,12 +6296,13 @@
 
 <file path=ppt/slides/slide3.xml><?xml version="1.0" encoding="utf-8"?>
 <p:sld xmlns:a="http://schemas.openxmlformats.org/drawingml/2006/main" xmlns:r="http://schemas.openxmlformats.org/officeDocument/2006/relationships" xmlns:p="http://schemas.openxmlformats.org/presentationml/2006/main">
-  <p:cSld name="Slide 3">
+  <p:cSld>
     <p:bg>
       <p:bgPr>
         <a:solidFill>
           <a:srgbClr val="050816"/>
         </a:solidFill>
+        <a:effectLst/>
       </p:bgPr>
     </p:bg>
     <p:spTree>
@@ -7263,24 +7054,23 @@
         </p:nvSpPr>
         <p:spPr>
           <a:xfrm>
-            <a:off x="566928" y="384048"/>
+            <a:off x="631063" y="117983"/>
             <a:ext cx="4389120" cy="228600"/>
           </a:xfrm>
           <a:prstGeom prst="rect">
             <a:avLst/>
           </a:prstGeom>
           <a:noFill/>
-          <a:ln/>
         </p:spPr>
         <p:txBody>
           <a:bodyPr wrap="square" lIns="0" tIns="0" rIns="0" bIns="0" rtlCol="0" anchor="ctr"/>
           <a:lstStyle/>
           <a:p>
-            <a:pPr indent="0" marL="0">
+            <a:pPr marL="0" indent="0">
               <a:buNone/>
             </a:pPr>
             <a:r>
-              <a:rPr lang="en-US" sz="950" b="1" spc="260" kern="0" dirty="0">
+              <a:rPr lang="en-US" sz="950" b="1" kern="0" spc="260" dirty="0">
                 <a:solidFill>
                   <a:srgbClr val="5EEAD4"/>
                 </a:solidFill>
@@ -7306,13 +7096,12 @@
             <a:avLst/>
           </a:prstGeom>
           <a:noFill/>
-          <a:ln/>
         </p:spPr>
         <p:txBody>
           <a:bodyPr wrap="square" lIns="0" tIns="0" rIns="0" bIns="0" rtlCol="0" anchor="ctr"/>
           <a:lstStyle/>
           <a:p>
-            <a:pPr indent="0" marL="0">
+            <a:pPr marL="0" indent="0">
               <a:buNone/>
             </a:pPr>
             <a:r>
@@ -7320,9 +7109,9 @@
                 <a:solidFill>
                   <a:srgbClr val="F8FAFC"/>
                 </a:solidFill>
-                <a:latin typeface="Microsoft YaHei UI" pitchFamily="34" charset="0"/>
-                <a:ea typeface="Microsoft YaHei UI" pitchFamily="34" charset="-122"/>
-                <a:cs typeface="Microsoft YaHei UI" pitchFamily="34" charset="-120"/>
+                <a:latin typeface="Microsoft YaHei UI" panose="020B0503020204020204" pitchFamily="34" charset="-122"/>
+                <a:ea typeface="Microsoft YaHei UI" panose="020B0503020204020204" pitchFamily="34" charset="-122"/>
+                <a:cs typeface="Microsoft YaHei UI" panose="020B0503020204020204" pitchFamily="34" charset="-120"/>
               </a:rPr>
               <a:t>长期独自学习，不缺工具，缺一个会进化的陪伴者</a:t>
             </a:r>
@@ -7345,7 +7134,6 @@
             <a:avLst/>
           </a:prstGeom>
           <a:noFill/>
-          <a:ln/>
         </p:spPr>
         <p:txBody>
           <a:bodyPr wrap="square" lIns="0" tIns="0" rIns="0" bIns="0" rtlCol="0" anchor="ctr">
@@ -7353,7 +7141,7 @@
           </a:bodyPr>
           <a:lstStyle/>
           <a:p>
-            <a:pPr indent="0" marL="0">
+            <a:pPr marL="0" indent="0">
               <a:buNone/>
             </a:pPr>
             <a:r>
@@ -7414,22 +7202,37 @@
             <a:avLst/>
           </a:prstGeom>
           <a:noFill/>
-          <a:ln/>
         </p:spPr>
         <p:txBody>
           <a:bodyPr wrap="square" lIns="0" tIns="0" rIns="0" bIns="0" rtlCol="0" anchor="ctr"/>
           <a:lstStyle/>
           <a:p>
-            <a:pPr algn="ctr" indent="0" marL="0">
+            <a:pPr marL="0" indent="0" algn="ctr">
               <a:buNone/>
             </a:pPr>
             <a:r>
-              <a:rPr lang="en-US" sz="840" b="1" spc="120" kern="0" dirty="0">
+              <a:rPr lang="en-US" sz="840" b="1" kern="0" spc="120" dirty="0">
                 <a:solidFill>
                   <a:srgbClr val="5EEAD4"/>
                 </a:solidFill>
               </a:rPr>
-              <a:t>一 / 1</a:t>
+              <a:t>一 </a:t>
+            </a:r>
+            <a:r>
+              <a:rPr lang="zh-CN" altLang="en-US" sz="840" b="1" kern="0" spc="120" dirty="0">
+                <a:solidFill>
+                  <a:srgbClr val="5EEAD4"/>
+                </a:solidFill>
+              </a:rPr>
+              <a:t>、</a:t>
+            </a:r>
+            <a:r>
+              <a:rPr lang="en-US" sz="840" b="1" kern="0" spc="120" dirty="0">
+                <a:solidFill>
+                  <a:srgbClr val="5EEAD4"/>
+                </a:solidFill>
+              </a:rPr>
+              <a:t> 1</a:t>
             </a:r>
             <a:endParaRPr lang="en-US" sz="840" dirty="0"/>
           </a:p>
@@ -7450,7 +7253,6 @@
             <a:avLst/>
           </a:prstGeom>
           <a:noFill/>
-          <a:ln/>
         </p:spPr>
         <p:txBody>
           <a:bodyPr wrap="square" lIns="0" tIns="0" rIns="0" bIns="0" rtlCol="0" anchor="ctr">
@@ -7458,7 +7260,7 @@
           </a:bodyPr>
           <a:lstStyle/>
           <a:p>
-            <a:pPr indent="0" marL="0">
+            <a:pPr marL="0" indent="0">
               <a:buNone/>
             </a:pPr>
             <a:r>
@@ -7503,7 +7305,7 @@
             <a:prstDash val="solid"/>
           </a:ln>
           <a:effectLst>
-            <a:outerShdw sx="100000" sy="100000" kx="0" ky="0" algn="bl" rotWithShape="0" blurRad="25400" dist="12700" dir="2700000">
+            <a:outerShdw blurRad="25400" dist="12700" dir="2700000" algn="bl" rotWithShape="0">
               <a:srgbClr val="000000">
                 <a:alpha val="16000"/>
               </a:srgbClr>
@@ -7555,13 +7357,12 @@
             <a:avLst/>
           </a:prstGeom>
           <a:noFill/>
-          <a:ln/>
         </p:spPr>
         <p:txBody>
           <a:bodyPr wrap="square" lIns="0" tIns="0" rIns="0" bIns="0" rtlCol="0" anchor="ctr"/>
           <a:lstStyle/>
           <a:p>
-            <a:pPr indent="0" marL="0">
+            <a:pPr marL="0" indent="0">
               <a:buNone/>
             </a:pPr>
             <a:r>
@@ -7591,13 +7392,12 @@
             <a:avLst/>
           </a:prstGeom>
           <a:noFill/>
-          <a:ln/>
         </p:spPr>
         <p:txBody>
           <a:bodyPr wrap="square" lIns="0" tIns="0" rIns="0" bIns="0" rtlCol="0" anchor="ctr"/>
           <a:lstStyle/>
           <a:p>
-            <a:pPr indent="0" marL="0">
+            <a:pPr marL="0" indent="0">
               <a:buNone/>
             </a:pPr>
             <a:r>
@@ -7627,13 +7427,12 @@
             <a:avLst/>
           </a:prstGeom>
           <a:noFill/>
-          <a:ln/>
         </p:spPr>
         <p:txBody>
           <a:bodyPr wrap="square" lIns="0" tIns="0" rIns="0" bIns="0" rtlCol="0" anchor="ctr"/>
           <a:lstStyle/>
           <a:p>
-            <a:pPr indent="0" marL="0">
+            <a:pPr marL="0" indent="0">
               <a:buNone/>
             </a:pPr>
             <a:r>
@@ -7678,7 +7477,7 @@
             <a:prstDash val="solid"/>
           </a:ln>
           <a:effectLst>
-            <a:outerShdw sx="100000" sy="100000" kx="0" ky="0" algn="bl" rotWithShape="0" blurRad="25400" dist="12700" dir="2700000">
+            <a:outerShdw blurRad="25400" dist="12700" dir="2700000" algn="bl" rotWithShape="0">
               <a:srgbClr val="000000">
                 <a:alpha val="16000"/>
               </a:srgbClr>
@@ -7730,13 +7529,12 @@
             <a:avLst/>
           </a:prstGeom>
           <a:noFill/>
-          <a:ln/>
         </p:spPr>
         <p:txBody>
           <a:bodyPr wrap="square" lIns="0" tIns="0" rIns="0" bIns="0" rtlCol="0" anchor="ctr"/>
           <a:lstStyle/>
           <a:p>
-            <a:pPr indent="0" marL="0">
+            <a:pPr marL="0" indent="0">
               <a:buNone/>
             </a:pPr>
             <a:r>
@@ -7766,13 +7564,12 @@
             <a:avLst/>
           </a:prstGeom>
           <a:noFill/>
-          <a:ln/>
         </p:spPr>
         <p:txBody>
           <a:bodyPr wrap="square" lIns="0" tIns="0" rIns="0" bIns="0" rtlCol="0" anchor="ctr"/>
           <a:lstStyle/>
           <a:p>
-            <a:pPr indent="0" marL="0">
+            <a:pPr marL="0" indent="0">
               <a:buNone/>
             </a:pPr>
             <a:r>
@@ -7802,13 +7599,12 @@
             <a:avLst/>
           </a:prstGeom>
           <a:noFill/>
-          <a:ln/>
         </p:spPr>
         <p:txBody>
           <a:bodyPr wrap="square" lIns="0" tIns="0" rIns="0" bIns="0" rtlCol="0" anchor="ctr"/>
           <a:lstStyle/>
           <a:p>
-            <a:pPr indent="0" marL="0">
+            <a:pPr marL="0" indent="0">
               <a:buNone/>
             </a:pPr>
             <a:r>
@@ -7853,7 +7649,7 @@
             <a:prstDash val="solid"/>
           </a:ln>
           <a:effectLst>
-            <a:outerShdw sx="100000" sy="100000" kx="0" ky="0" algn="bl" rotWithShape="0" blurRad="25400" dist="12700" dir="2700000">
+            <a:outerShdw blurRad="25400" dist="12700" dir="2700000" algn="bl" rotWithShape="0">
               <a:srgbClr val="000000">
                 <a:alpha val="16000"/>
               </a:srgbClr>
@@ -7905,13 +7701,12 @@
             <a:avLst/>
           </a:prstGeom>
           <a:noFill/>
-          <a:ln/>
         </p:spPr>
         <p:txBody>
           <a:bodyPr wrap="square" lIns="0" tIns="0" rIns="0" bIns="0" rtlCol="0" anchor="ctr"/>
           <a:lstStyle/>
           <a:p>
-            <a:pPr indent="0" marL="0">
+            <a:pPr marL="0" indent="0">
               <a:buNone/>
             </a:pPr>
             <a:r>
@@ -7941,13 +7736,12 @@
             <a:avLst/>
           </a:prstGeom>
           <a:noFill/>
-          <a:ln/>
         </p:spPr>
         <p:txBody>
           <a:bodyPr wrap="square" lIns="0" tIns="0" rIns="0" bIns="0" rtlCol="0" anchor="ctr"/>
           <a:lstStyle/>
           <a:p>
-            <a:pPr indent="0" marL="0">
+            <a:pPr marL="0" indent="0">
               <a:buNone/>
             </a:pPr>
             <a:r>
@@ -7977,13 +7771,12 @@
             <a:avLst/>
           </a:prstGeom>
           <a:noFill/>
-          <a:ln/>
         </p:spPr>
         <p:txBody>
           <a:bodyPr wrap="square" lIns="0" tIns="0" rIns="0" bIns="0" rtlCol="0" anchor="ctr"/>
           <a:lstStyle/>
           <a:p>
-            <a:pPr indent="0" marL="0">
+            <a:pPr marL="0" indent="0">
               <a:buNone/>
             </a:pPr>
             <a:r>
@@ -8028,7 +7821,7 @@
             <a:prstDash val="solid"/>
           </a:ln>
           <a:effectLst>
-            <a:outerShdw sx="100000" sy="100000" kx="0" ky="0" algn="bl" rotWithShape="0" blurRad="25400" dist="12700" dir="2700000">
+            <a:outerShdw blurRad="25400" dist="12700" dir="2700000" algn="bl" rotWithShape="0">
               <a:srgbClr val="000000">
                 <a:alpha val="16000"/>
               </a:srgbClr>
@@ -8080,13 +7873,12 @@
             <a:avLst/>
           </a:prstGeom>
           <a:noFill/>
-          <a:ln/>
         </p:spPr>
         <p:txBody>
           <a:bodyPr wrap="square" lIns="0" tIns="0" rIns="0" bIns="0" rtlCol="0" anchor="ctr"/>
           <a:lstStyle/>
           <a:p>
-            <a:pPr indent="0" marL="0">
+            <a:pPr marL="0" indent="0">
               <a:buNone/>
             </a:pPr>
             <a:r>
@@ -8116,13 +7908,12 @@
             <a:avLst/>
           </a:prstGeom>
           <a:noFill/>
-          <a:ln/>
         </p:spPr>
         <p:txBody>
           <a:bodyPr wrap="square" lIns="0" tIns="0" rIns="0" bIns="0" rtlCol="0" anchor="ctr"/>
           <a:lstStyle/>
           <a:p>
-            <a:pPr indent="0" marL="0">
+            <a:pPr marL="0" indent="0">
               <a:buNone/>
             </a:pPr>
             <a:r>
@@ -8152,13 +7943,12 @@
             <a:avLst/>
           </a:prstGeom>
           <a:noFill/>
-          <a:ln/>
         </p:spPr>
         <p:txBody>
           <a:bodyPr wrap="square" lIns="0" tIns="0" rIns="0" bIns="0" rtlCol="0" anchor="ctr"/>
           <a:lstStyle/>
           <a:p>
-            <a:pPr indent="0" marL="0">
+            <a:pPr marL="0" indent="0">
               <a:buNone/>
             </a:pPr>
             <a:r>
@@ -8188,13 +7978,12 @@
             <a:avLst/>
           </a:prstGeom>
           <a:noFill/>
-          <a:ln/>
         </p:spPr>
         <p:txBody>
           <a:bodyPr wrap="square" lIns="0" tIns="0" rIns="0" bIns="0" rtlCol="0" anchor="ctr"/>
           <a:lstStyle/>
           <a:p>
-            <a:pPr indent="0" marL="0">
+            <a:pPr marL="0" indent="0">
               <a:buNone/>
             </a:pPr>
             <a:r>
@@ -8224,7 +8013,6 @@
             <a:avLst/>
           </a:prstGeom>
           <a:noFill/>
-          <a:ln/>
         </p:spPr>
         <p:txBody>
           <a:bodyPr wrap="square" lIns="0" tIns="0" rIns="0" bIns="0" rtlCol="0" anchor="ctr">
@@ -8232,7 +8020,7 @@
           </a:bodyPr>
           <a:lstStyle/>
           <a:p>
-            <a:pPr indent="0" marL="0">
+            <a:pPr marL="0" indent="0">
               <a:buNone/>
             </a:pPr>
             <a:r>
@@ -8262,13 +8050,12 @@
             <a:avLst/>
           </a:prstGeom>
           <a:noFill/>
-          <a:ln/>
         </p:spPr>
         <p:txBody>
           <a:bodyPr wrap="square" lIns="0" tIns="0" rIns="0" bIns="0" rtlCol="0" anchor="ctr"/>
           <a:lstStyle/>
           <a:p>
-            <a:pPr indent="0" marL="0">
+            <a:pPr marL="0" indent="0">
               <a:buNone/>
             </a:pPr>
             <a:r>
@@ -8293,12 +8080,13 @@
 
 <file path=ppt/slides/slide4.xml><?xml version="1.0" encoding="utf-8"?>
 <p:sld xmlns:a="http://schemas.openxmlformats.org/drawingml/2006/main" xmlns:r="http://schemas.openxmlformats.org/officeDocument/2006/relationships" xmlns:p="http://schemas.openxmlformats.org/presentationml/2006/main">
-  <p:cSld name="Slide 4">
+  <p:cSld>
     <p:bg>
       <p:bgPr>
         <a:solidFill>
           <a:srgbClr val="050816"/>
         </a:solidFill>
+        <a:effectLst/>
       </p:bgPr>
     </p:bg>
     <p:spTree>
@@ -9057,17 +8845,16 @@
             <a:avLst/>
           </a:prstGeom>
           <a:noFill/>
-          <a:ln/>
         </p:spPr>
         <p:txBody>
           <a:bodyPr wrap="square" lIns="0" tIns="0" rIns="0" bIns="0" rtlCol="0" anchor="ctr"/>
           <a:lstStyle/>
           <a:p>
-            <a:pPr indent="0" marL="0">
+            <a:pPr marL="0" indent="0">
               <a:buNone/>
             </a:pPr>
             <a:r>
-              <a:rPr lang="en-US" sz="950" b="1" spc="260" kern="0" dirty="0">
+              <a:rPr lang="en-US" sz="950" b="1" kern="0" spc="260" dirty="0">
                 <a:solidFill>
                   <a:srgbClr val="5EEAD4"/>
                 </a:solidFill>
@@ -9093,13 +8880,12 @@
             <a:avLst/>
           </a:prstGeom>
           <a:noFill/>
-          <a:ln/>
         </p:spPr>
         <p:txBody>
           <a:bodyPr wrap="square" lIns="0" tIns="0" rIns="0" bIns="0" rtlCol="0" anchor="ctr"/>
           <a:lstStyle/>
           <a:p>
-            <a:pPr indent="0" marL="0">
+            <a:pPr marL="0" indent="0">
               <a:buNone/>
             </a:pPr>
             <a:r>
@@ -9107,9 +8893,9 @@
                 <a:solidFill>
                   <a:srgbClr val="F8FAFC"/>
                 </a:solidFill>
-                <a:latin typeface="Microsoft YaHei UI" pitchFamily="34" charset="0"/>
-                <a:ea typeface="Microsoft YaHei UI" pitchFamily="34" charset="-122"/>
-                <a:cs typeface="Microsoft YaHei UI" pitchFamily="34" charset="-120"/>
+                <a:latin typeface="Microsoft YaHei UI" panose="020B0503020204020204" pitchFamily="34" charset="-122"/>
+                <a:ea typeface="Microsoft YaHei UI" panose="020B0503020204020204" pitchFamily="34" charset="-122"/>
+                <a:cs typeface="Microsoft YaHei UI" panose="020B0503020204020204" pitchFamily="34" charset="-120"/>
               </a:rPr>
               <a:t>LifeOS：伴随式成长操作系统</a:t>
             </a:r>
@@ -9132,7 +8918,6 @@
             <a:avLst/>
           </a:prstGeom>
           <a:noFill/>
-          <a:ln/>
         </p:spPr>
         <p:txBody>
           <a:bodyPr wrap="square" lIns="0" tIns="0" rIns="0" bIns="0" rtlCol="0" anchor="ctr">
@@ -9140,7 +8925,7 @@
           </a:bodyPr>
           <a:lstStyle/>
           <a:p>
-            <a:pPr indent="0" marL="0">
+            <a:pPr marL="0" indent="0">
               <a:buNone/>
             </a:pPr>
             <a:r>
@@ -9201,22 +8986,37 @@
             <a:avLst/>
           </a:prstGeom>
           <a:noFill/>
-          <a:ln/>
         </p:spPr>
         <p:txBody>
           <a:bodyPr wrap="square" lIns="0" tIns="0" rIns="0" bIns="0" rtlCol="0" anchor="ctr"/>
           <a:lstStyle/>
           <a:p>
-            <a:pPr algn="ctr" indent="0" marL="0">
+            <a:pPr marL="0" indent="0" algn="ctr">
               <a:buNone/>
             </a:pPr>
             <a:r>
-              <a:rPr lang="en-US" sz="840" b="1" spc="120" kern="0" dirty="0">
+              <a:rPr lang="en-US" sz="840" b="1" kern="0" spc="120" dirty="0">
                 <a:solidFill>
                   <a:srgbClr val="5EEAD4"/>
                 </a:solidFill>
               </a:rPr>
-              <a:t>一 / 2-3</a:t>
+              <a:t>一 </a:t>
+            </a:r>
+            <a:r>
+              <a:rPr lang="zh-CN" altLang="en-US" sz="840" b="1" kern="0" spc="120" dirty="0">
+                <a:solidFill>
+                  <a:srgbClr val="5EEAD4"/>
+                </a:solidFill>
+              </a:rPr>
+              <a:t>、</a:t>
+            </a:r>
+            <a:r>
+              <a:rPr lang="en-US" sz="840" b="1" kern="0" spc="120" dirty="0">
+                <a:solidFill>
+                  <a:srgbClr val="5EEAD4"/>
+                </a:solidFill>
+              </a:rPr>
+              <a:t> 2-3</a:t>
             </a:r>
             <a:endParaRPr lang="en-US" sz="840" dirty="0"/>
           </a:p>
@@ -9237,7 +9037,6 @@
             <a:avLst/>
           </a:prstGeom>
           <a:noFill/>
-          <a:ln/>
         </p:spPr>
         <p:txBody>
           <a:bodyPr wrap="square" lIns="0" tIns="0" rIns="0" bIns="0" rtlCol="0" anchor="ctr">
@@ -9245,7 +9044,7 @@
           </a:bodyPr>
           <a:lstStyle/>
           <a:p>
-            <a:pPr indent="0" marL="0">
+            <a:pPr marL="0" indent="0">
               <a:buNone/>
             </a:pPr>
             <a:r>
@@ -9290,7 +9089,7 @@
             <a:prstDash val="solid"/>
           </a:ln>
           <a:effectLst>
-            <a:outerShdw sx="100000" sy="100000" kx="0" ky="0" algn="bl" rotWithShape="0" blurRad="25400" dist="12700" dir="2700000">
+            <a:outerShdw blurRad="25400" dist="12700" dir="2700000" algn="bl" rotWithShape="0">
               <a:srgbClr val="000000">
                 <a:alpha val="16000"/>
               </a:srgbClr>
@@ -9313,13 +9112,12 @@
             <a:avLst/>
           </a:prstGeom>
           <a:noFill/>
-          <a:ln/>
         </p:spPr>
         <p:txBody>
           <a:bodyPr wrap="square" lIns="0" tIns="0" rIns="0" bIns="0" rtlCol="0" anchor="ctr"/>
           <a:lstStyle/>
           <a:p>
-            <a:pPr indent="0" marL="0">
+            <a:pPr marL="0" indent="0">
               <a:buNone/>
             </a:pPr>
             <a:r>
@@ -9349,7 +9147,6 @@
             <a:avLst/>
           </a:prstGeom>
           <a:noFill/>
-          <a:ln/>
         </p:spPr>
         <p:txBody>
           <a:bodyPr wrap="square" lIns="0" tIns="0" rIns="0" bIns="0" rtlCol="0" anchor="ctr">
@@ -9357,7 +9154,7 @@
           </a:bodyPr>
           <a:lstStyle/>
           <a:p>
-            <a:pPr indent="0" marL="0">
+            <a:pPr marL="0" indent="0">
               <a:buNone/>
             </a:pPr>
             <a:r>
@@ -9402,7 +9199,7 @@
             <a:prstDash val="solid"/>
           </a:ln>
           <a:effectLst>
-            <a:outerShdw sx="100000" sy="100000" kx="0" ky="0" algn="bl" rotWithShape="0" blurRad="25400" dist="12700" dir="2700000">
+            <a:outerShdw blurRad="25400" dist="12700" dir="2700000" algn="bl" rotWithShape="0">
               <a:srgbClr val="000000">
                 <a:alpha val="16000"/>
               </a:srgbClr>
@@ -9425,13 +9222,12 @@
             <a:avLst/>
           </a:prstGeom>
           <a:noFill/>
-          <a:ln/>
         </p:spPr>
         <p:txBody>
           <a:bodyPr wrap="square" lIns="0" tIns="0" rIns="0" bIns="0" rtlCol="0" anchor="ctr"/>
           <a:lstStyle/>
           <a:p>
-            <a:pPr indent="0" marL="0">
+            <a:pPr marL="0" indent="0">
               <a:buNone/>
             </a:pPr>
             <a:r>
@@ -9461,7 +9257,6 @@
             <a:avLst/>
           </a:prstGeom>
           <a:noFill/>
-          <a:ln/>
         </p:spPr>
         <p:txBody>
           <a:bodyPr wrap="square" lIns="0" tIns="0" rIns="0" bIns="0" rtlCol="0" anchor="ctr">
@@ -9469,7 +9264,7 @@
           </a:bodyPr>
           <a:lstStyle/>
           <a:p>
-            <a:pPr indent="0" marL="0">
+            <a:pPr marL="0" indent="0">
               <a:buNone/>
             </a:pPr>
             <a:r>
@@ -9514,7 +9309,7 @@
             <a:prstDash val="solid"/>
           </a:ln>
           <a:effectLst>
-            <a:outerShdw sx="100000" sy="100000" kx="0" ky="0" algn="bl" rotWithShape="0" blurRad="25400" dist="12700" dir="2700000">
+            <a:outerShdw blurRad="25400" dist="12700" dir="2700000" algn="bl" rotWithShape="0">
               <a:srgbClr val="000000">
                 <a:alpha val="16000"/>
               </a:srgbClr>
@@ -9537,13 +9332,12 @@
             <a:avLst/>
           </a:prstGeom>
           <a:noFill/>
-          <a:ln/>
         </p:spPr>
         <p:txBody>
           <a:bodyPr wrap="square" lIns="0" tIns="0" rIns="0" bIns="0" rtlCol="0" anchor="ctr"/>
           <a:lstStyle/>
           <a:p>
-            <a:pPr indent="0" marL="0">
+            <a:pPr marL="0" indent="0">
               <a:buNone/>
             </a:pPr>
             <a:r>
@@ -9573,7 +9367,6 @@
             <a:avLst/>
           </a:prstGeom>
           <a:noFill/>
-          <a:ln/>
         </p:spPr>
         <p:txBody>
           <a:bodyPr wrap="square" lIns="0" tIns="0" rIns="0" bIns="0" rtlCol="0" anchor="ctr">
@@ -9581,7 +9374,7 @@
           </a:bodyPr>
           <a:lstStyle/>
           <a:p>
-            <a:pPr indent="0" marL="0">
+            <a:pPr marL="0" indent="0">
               <a:buNone/>
             </a:pPr>
             <a:r>
@@ -9626,7 +9419,7 @@
             <a:prstDash val="solid"/>
           </a:ln>
           <a:effectLst>
-            <a:outerShdw sx="100000" sy="100000" kx="0" ky="0" algn="bl" rotWithShape="0" blurRad="25400" dist="12700" dir="2700000">
+            <a:outerShdw blurRad="25400" dist="12700" dir="2700000" algn="bl" rotWithShape="0">
               <a:srgbClr val="000000">
                 <a:alpha val="16000"/>
               </a:srgbClr>
@@ -9649,13 +9442,12 @@
             <a:avLst/>
           </a:prstGeom>
           <a:noFill/>
-          <a:ln/>
         </p:spPr>
         <p:txBody>
           <a:bodyPr wrap="square" lIns="0" tIns="0" rIns="0" bIns="0" rtlCol="0" anchor="ctr"/>
           <a:lstStyle/>
           <a:p>
-            <a:pPr indent="0" marL="0">
+            <a:pPr marL="0" indent="0">
               <a:buNone/>
             </a:pPr>
             <a:r>
@@ -9685,7 +9477,6 @@
             <a:avLst/>
           </a:prstGeom>
           <a:noFill/>
-          <a:ln/>
         </p:spPr>
         <p:txBody>
           <a:bodyPr wrap="square" lIns="0" tIns="0" rIns="0" bIns="0" rtlCol="0" anchor="ctr">
@@ -9693,7 +9484,7 @@
           </a:bodyPr>
           <a:lstStyle/>
           <a:p>
-            <a:pPr indent="0" marL="0">
+            <a:pPr marL="0" indent="0">
               <a:buNone/>
             </a:pPr>
             <a:r>
@@ -9738,7 +9529,7 @@
             <a:prstDash val="solid"/>
           </a:ln>
           <a:effectLst>
-            <a:outerShdw sx="100000" sy="100000" kx="0" ky="0" algn="bl" rotWithShape="0" blurRad="25400" dist="12700" dir="2700000">
+            <a:outerShdw blurRad="25400" dist="12700" dir="2700000" algn="bl" rotWithShape="0">
               <a:srgbClr val="000000">
                 <a:alpha val="16000"/>
               </a:srgbClr>
@@ -9761,13 +9552,12 @@
             <a:avLst/>
           </a:prstGeom>
           <a:noFill/>
-          <a:ln/>
         </p:spPr>
         <p:txBody>
           <a:bodyPr wrap="square" lIns="0" tIns="0" rIns="0" bIns="0" rtlCol="0" anchor="ctr"/>
           <a:lstStyle/>
           <a:p>
-            <a:pPr indent="0" marL="0">
+            <a:pPr marL="0" indent="0">
               <a:buNone/>
             </a:pPr>
             <a:r>
@@ -9797,7 +9587,6 @@
             <a:avLst/>
           </a:prstGeom>
           <a:noFill/>
-          <a:ln/>
         </p:spPr>
         <p:txBody>
           <a:bodyPr wrap="square" lIns="0" tIns="0" rIns="0" bIns="0" rtlCol="0" anchor="ctr">
@@ -9805,7 +9594,7 @@
           </a:bodyPr>
           <a:lstStyle/>
           <a:p>
-            <a:pPr indent="0" marL="0">
+            <a:pPr marL="0" indent="0">
               <a:buNone/>
             </a:pPr>
             <a:r>
@@ -9850,7 +9639,7 @@
             <a:prstDash val="solid"/>
           </a:ln>
           <a:effectLst>
-            <a:outerShdw sx="100000" sy="100000" kx="0" ky="0" algn="bl" rotWithShape="0" blurRad="25400" dist="12700" dir="2700000">
+            <a:outerShdw blurRad="25400" dist="12700" dir="2700000" algn="bl" rotWithShape="0">
               <a:srgbClr val="000000">
                 <a:alpha val="16000"/>
               </a:srgbClr>
@@ -9873,13 +9662,12 @@
             <a:avLst/>
           </a:prstGeom>
           <a:noFill/>
-          <a:ln/>
         </p:spPr>
         <p:txBody>
           <a:bodyPr wrap="square" lIns="0" tIns="0" rIns="0" bIns="0" rtlCol="0" anchor="ctr"/>
           <a:lstStyle/>
           <a:p>
-            <a:pPr indent="0" marL="0">
+            <a:pPr marL="0" indent="0">
               <a:buNone/>
             </a:pPr>
             <a:r>
@@ -9909,7 +9697,6 @@
             <a:avLst/>
           </a:prstGeom>
           <a:noFill/>
-          <a:ln/>
         </p:spPr>
         <p:txBody>
           <a:bodyPr wrap="square" lIns="0" tIns="0" rIns="0" bIns="0" rtlCol="0" anchor="ctr">
@@ -9917,7 +9704,7 @@
           </a:bodyPr>
           <a:lstStyle/>
           <a:p>
-            <a:pPr indent="0" marL="0">
+            <a:pPr marL="0" indent="0">
               <a:buNone/>
             </a:pPr>
             <a:r>
@@ -9962,7 +9749,7 @@
             <a:prstDash val="solid"/>
           </a:ln>
           <a:effectLst>
-            <a:outerShdw sx="100000" sy="100000" kx="0" ky="0" algn="bl" rotWithShape="0" blurRad="25400" dist="12700" dir="2700000">
+            <a:outerShdw blurRad="25400" dist="12700" dir="2700000" algn="bl" rotWithShape="0">
               <a:srgbClr val="000000">
                 <a:alpha val="16000"/>
               </a:srgbClr>
@@ -9985,13 +9772,12 @@
             <a:avLst/>
           </a:prstGeom>
           <a:noFill/>
-          <a:ln/>
         </p:spPr>
         <p:txBody>
           <a:bodyPr wrap="square" lIns="0" tIns="0" rIns="0" bIns="0" rtlCol="0" anchor="ctr"/>
           <a:lstStyle/>
           <a:p>
-            <a:pPr indent="0" marL="0">
+            <a:pPr marL="0" indent="0">
               <a:buNone/>
             </a:pPr>
             <a:r>
@@ -10021,7 +9807,6 @@
             <a:avLst/>
           </a:prstGeom>
           <a:noFill/>
-          <a:ln/>
         </p:spPr>
         <p:txBody>
           <a:bodyPr wrap="square" lIns="0" tIns="0" rIns="0" bIns="0" rtlCol="0" anchor="ctr">
@@ -10029,7 +9814,7 @@
           </a:bodyPr>
           <a:lstStyle/>
           <a:p>
-            <a:pPr indent="0" marL="0">
+            <a:pPr marL="0" indent="0">
               <a:buNone/>
             </a:pPr>
             <a:r>
@@ -10059,13 +9844,12 @@
             <a:avLst/>
           </a:prstGeom>
           <a:noFill/>
-          <a:ln/>
         </p:spPr>
         <p:txBody>
           <a:bodyPr wrap="square" lIns="0" tIns="0" rIns="0" bIns="0" rtlCol="0" anchor="ctr"/>
           <a:lstStyle/>
           <a:p>
-            <a:pPr indent="0" marL="0">
+            <a:pPr marL="0" indent="0">
               <a:buNone/>
             </a:pPr>
             <a:r>
@@ -10090,12 +9874,13 @@
 
 <file path=ppt/slides/slide5.xml><?xml version="1.0" encoding="utf-8"?>
 <p:sld xmlns:a="http://schemas.openxmlformats.org/drawingml/2006/main" xmlns:r="http://schemas.openxmlformats.org/officeDocument/2006/relationships" xmlns:p="http://schemas.openxmlformats.org/presentationml/2006/main">
-  <p:cSld name="Slide 5">
+  <p:cSld>
     <p:bg>
       <p:bgPr>
         <a:solidFill>
           <a:srgbClr val="050816"/>
         </a:solidFill>
+        <a:effectLst/>
       </p:bgPr>
     </p:bg>
     <p:spTree>
@@ -10847,24 +10632,23 @@
         </p:nvSpPr>
         <p:spPr>
           <a:xfrm>
-            <a:off x="566928" y="384048"/>
+            <a:off x="566928" y="246888"/>
             <a:ext cx="4389120" cy="228600"/>
           </a:xfrm>
           <a:prstGeom prst="rect">
             <a:avLst/>
           </a:prstGeom>
           <a:noFill/>
-          <a:ln/>
         </p:spPr>
         <p:txBody>
           <a:bodyPr wrap="square" lIns="0" tIns="0" rIns="0" bIns="0" rtlCol="0" anchor="ctr"/>
           <a:lstStyle/>
           <a:p>
-            <a:pPr indent="0" marL="0">
+            <a:pPr marL="0" indent="0">
               <a:buNone/>
             </a:pPr>
             <a:r>
-              <a:rPr lang="en-US" sz="950" b="1" spc="260" kern="0" dirty="0">
+              <a:rPr lang="en-US" sz="950" b="1" kern="0" spc="260" dirty="0">
                 <a:solidFill>
                   <a:srgbClr val="5EEAD4"/>
                 </a:solidFill>
@@ -10890,13 +10674,12 @@
             <a:avLst/>
           </a:prstGeom>
           <a:noFill/>
-          <a:ln/>
         </p:spPr>
         <p:txBody>
           <a:bodyPr wrap="square" lIns="0" tIns="0" rIns="0" bIns="0" rtlCol="0" anchor="ctr"/>
           <a:lstStyle/>
           <a:p>
-            <a:pPr indent="0" marL="0">
+            <a:pPr marL="0" indent="0">
               <a:buNone/>
             </a:pPr>
             <a:r>
@@ -10904,9 +10687,9 @@
                 <a:solidFill>
                   <a:srgbClr val="F8FAFC"/>
                 </a:solidFill>
-                <a:latin typeface="Microsoft YaHei UI" pitchFamily="34" charset="0"/>
-                <a:ea typeface="Microsoft YaHei UI" pitchFamily="34" charset="-122"/>
-                <a:cs typeface="Microsoft YaHei UI" pitchFamily="34" charset="-120"/>
+                <a:latin typeface="Microsoft YaHei UI" panose="020B0503020204020204" pitchFamily="34" charset="-122"/>
+                <a:ea typeface="Microsoft YaHei UI" panose="020B0503020204020204" pitchFamily="34" charset="-122"/>
+                <a:cs typeface="Microsoft YaHei UI" panose="020B0503020204020204" pitchFamily="34" charset="-120"/>
               </a:rPr>
               <a:t>从一段日记，到一次完整 Agent 成长闭环</a:t>
             </a:r>
@@ -10929,7 +10712,6 @@
             <a:avLst/>
           </a:prstGeom>
           <a:noFill/>
-          <a:ln/>
         </p:spPr>
         <p:txBody>
           <a:bodyPr wrap="square" lIns="0" tIns="0" rIns="0" bIns="0" rtlCol="0" anchor="ctr">
@@ -10937,7 +10719,7 @@
           </a:bodyPr>
           <a:lstStyle/>
           <a:p>
-            <a:pPr indent="0" marL="0">
+            <a:pPr marL="0" indent="0">
               <a:buNone/>
             </a:pPr>
             <a:r>
@@ -10998,22 +10780,37 @@
             <a:avLst/>
           </a:prstGeom>
           <a:noFill/>
-          <a:ln/>
         </p:spPr>
         <p:txBody>
           <a:bodyPr wrap="square" lIns="0" tIns="0" rIns="0" bIns="0" rtlCol="0" anchor="ctr"/>
           <a:lstStyle/>
           <a:p>
-            <a:pPr algn="ctr" indent="0" marL="0">
+            <a:pPr marL="0" indent="0" algn="ctr">
               <a:buNone/>
             </a:pPr>
             <a:r>
-              <a:rPr lang="en-US" sz="840" b="1" spc="120" kern="0" dirty="0">
+              <a:rPr lang="en-US" sz="840" b="1" kern="0" spc="120" dirty="0">
                 <a:solidFill>
                   <a:srgbClr val="A78BFA"/>
                 </a:solidFill>
               </a:rPr>
-              <a:t>二 / 1-2</a:t>
+              <a:t>二 </a:t>
+            </a:r>
+            <a:r>
+              <a:rPr lang="zh-CN" altLang="en-US" sz="840" b="1" kern="0" spc="120" dirty="0">
+                <a:solidFill>
+                  <a:srgbClr val="A78BFA"/>
+                </a:solidFill>
+              </a:rPr>
+              <a:t>、</a:t>
+            </a:r>
+            <a:r>
+              <a:rPr lang="en-US" sz="840" b="1" kern="0" spc="120" dirty="0">
+                <a:solidFill>
+                  <a:srgbClr val="A78BFA"/>
+                </a:solidFill>
+              </a:rPr>
+              <a:t> 1-2</a:t>
             </a:r>
             <a:endParaRPr lang="en-US" sz="840" dirty="0"/>
           </a:p>
@@ -11034,7 +10831,6 @@
             <a:avLst/>
           </a:prstGeom>
           <a:noFill/>
-          <a:ln/>
         </p:spPr>
         <p:txBody>
           <a:bodyPr wrap="square" lIns="0" tIns="0" rIns="0" bIns="0" rtlCol="0" anchor="ctr">
@@ -11042,7 +10838,7 @@
           </a:bodyPr>
           <a:lstStyle/>
           <a:p>
-            <a:pPr indent="0" marL="0">
+            <a:pPr marL="0" indent="0">
               <a:buNone/>
             </a:pPr>
             <a:r>
@@ -11087,7 +10883,7 @@
             <a:prstDash val="solid"/>
           </a:ln>
           <a:effectLst>
-            <a:outerShdw sx="100000" sy="100000" kx="0" ky="0" algn="bl" rotWithShape="0" blurRad="25400" dist="12700" dir="2700000">
+            <a:outerShdw blurRad="25400" dist="12700" dir="2700000" algn="bl" rotWithShape="0">
               <a:srgbClr val="000000">
                 <a:alpha val="16000"/>
               </a:srgbClr>
@@ -11110,13 +10906,12 @@
             <a:avLst/>
           </a:prstGeom>
           <a:noFill/>
-          <a:ln/>
         </p:spPr>
         <p:txBody>
           <a:bodyPr wrap="square" lIns="0" tIns="0" rIns="0" bIns="0" rtlCol="0" anchor="ctr"/>
           <a:lstStyle/>
           <a:p>
-            <a:pPr algn="ctr" indent="0" marL="0">
+            <a:pPr marL="0" indent="0" algn="ctr">
               <a:buNone/>
             </a:pPr>
             <a:r>
@@ -11186,7 +10981,7 @@
             <a:prstDash val="solid"/>
           </a:ln>
           <a:effectLst>
-            <a:outerShdw sx="100000" sy="100000" kx="0" ky="0" algn="bl" rotWithShape="0" blurRad="25400" dist="12700" dir="2700000">
+            <a:outerShdw blurRad="25400" dist="12700" dir="2700000" algn="bl" rotWithShape="0">
               <a:srgbClr val="000000">
                 <a:alpha val="16000"/>
               </a:srgbClr>
@@ -11209,13 +11004,12 @@
             <a:avLst/>
           </a:prstGeom>
           <a:noFill/>
-          <a:ln/>
         </p:spPr>
         <p:txBody>
           <a:bodyPr wrap="square" lIns="0" tIns="0" rIns="0" bIns="0" rtlCol="0" anchor="ctr"/>
           <a:lstStyle/>
           <a:p>
-            <a:pPr algn="ctr" indent="0" marL="0">
+            <a:pPr marL="0" indent="0" algn="ctr">
               <a:buNone/>
             </a:pPr>
             <a:r>
@@ -11285,7 +11079,7 @@
             <a:prstDash val="solid"/>
           </a:ln>
           <a:effectLst>
-            <a:outerShdw sx="100000" sy="100000" kx="0" ky="0" algn="bl" rotWithShape="0" blurRad="25400" dist="12700" dir="2700000">
+            <a:outerShdw blurRad="25400" dist="12700" dir="2700000" algn="bl" rotWithShape="0">
               <a:srgbClr val="000000">
                 <a:alpha val="16000"/>
               </a:srgbClr>
@@ -11308,13 +11102,12 @@
             <a:avLst/>
           </a:prstGeom>
           <a:noFill/>
-          <a:ln/>
         </p:spPr>
         <p:txBody>
           <a:bodyPr wrap="square" lIns="0" tIns="0" rIns="0" bIns="0" rtlCol="0" anchor="ctr"/>
           <a:lstStyle/>
           <a:p>
-            <a:pPr algn="ctr" indent="0" marL="0">
+            <a:pPr marL="0" indent="0" algn="ctr">
               <a:buNone/>
             </a:pPr>
             <a:r>
@@ -11384,7 +11177,7 @@
             <a:prstDash val="solid"/>
           </a:ln>
           <a:effectLst>
-            <a:outerShdw sx="100000" sy="100000" kx="0" ky="0" algn="bl" rotWithShape="0" blurRad="25400" dist="12700" dir="2700000">
+            <a:outerShdw blurRad="25400" dist="12700" dir="2700000" algn="bl" rotWithShape="0">
               <a:srgbClr val="000000">
                 <a:alpha val="16000"/>
               </a:srgbClr>
@@ -11407,13 +11200,12 @@
             <a:avLst/>
           </a:prstGeom>
           <a:noFill/>
-          <a:ln/>
         </p:spPr>
         <p:txBody>
           <a:bodyPr wrap="square" lIns="0" tIns="0" rIns="0" bIns="0" rtlCol="0" anchor="ctr"/>
           <a:lstStyle/>
           <a:p>
-            <a:pPr algn="ctr" indent="0" marL="0">
+            <a:pPr marL="0" indent="0" algn="ctr">
               <a:buNone/>
             </a:pPr>
             <a:r>
@@ -11483,7 +11275,7 @@
             <a:prstDash val="solid"/>
           </a:ln>
           <a:effectLst>
-            <a:outerShdw sx="100000" sy="100000" kx="0" ky="0" algn="bl" rotWithShape="0" blurRad="25400" dist="12700" dir="2700000">
+            <a:outerShdw blurRad="25400" dist="12700" dir="2700000" algn="bl" rotWithShape="0">
               <a:srgbClr val="000000">
                 <a:alpha val="16000"/>
               </a:srgbClr>
@@ -11506,13 +11298,12 @@
             <a:avLst/>
           </a:prstGeom>
           <a:noFill/>
-          <a:ln/>
         </p:spPr>
         <p:txBody>
           <a:bodyPr wrap="square" lIns="0" tIns="0" rIns="0" bIns="0" rtlCol="0" anchor="ctr"/>
           <a:lstStyle/>
           <a:p>
-            <a:pPr algn="ctr" indent="0" marL="0">
+            <a:pPr marL="0" indent="0" algn="ctr">
               <a:buNone/>
             </a:pPr>
             <a:r>
@@ -11582,7 +11373,7 @@
             <a:prstDash val="solid"/>
           </a:ln>
           <a:effectLst>
-            <a:outerShdw sx="100000" sy="100000" kx="0" ky="0" algn="bl" rotWithShape="0" blurRad="25400" dist="12700" dir="2700000">
+            <a:outerShdw blurRad="25400" dist="12700" dir="2700000" algn="bl" rotWithShape="0">
               <a:srgbClr val="000000">
                 <a:alpha val="16000"/>
               </a:srgbClr>
@@ -11605,13 +11396,12 @@
             <a:avLst/>
           </a:prstGeom>
           <a:noFill/>
-          <a:ln/>
         </p:spPr>
         <p:txBody>
           <a:bodyPr wrap="square" lIns="0" tIns="0" rIns="0" bIns="0" rtlCol="0" anchor="ctr"/>
           <a:lstStyle/>
           <a:p>
-            <a:pPr algn="ctr" indent="0" marL="0">
+            <a:pPr marL="0" indent="0" algn="ctr">
               <a:buNone/>
             </a:pPr>
             <a:r>
@@ -11656,7 +11446,7 @@
             <a:prstDash val="solid"/>
           </a:ln>
           <a:effectLst>
-            <a:outerShdw sx="100000" sy="100000" kx="0" ky="0" algn="bl" rotWithShape="0" blurRad="25400" dist="12700" dir="2700000">
+            <a:outerShdw blurRad="25400" dist="12700" dir="2700000" algn="bl" rotWithShape="0">
               <a:srgbClr val="000000">
                 <a:alpha val="16000"/>
               </a:srgbClr>
@@ -11679,13 +11469,12 @@
             <a:avLst/>
           </a:prstGeom>
           <a:noFill/>
-          <a:ln/>
         </p:spPr>
         <p:txBody>
           <a:bodyPr wrap="square" lIns="0" tIns="0" rIns="0" bIns="0" rtlCol="0" anchor="ctr"/>
           <a:lstStyle/>
           <a:p>
-            <a:pPr indent="0" marL="0">
+            <a:pPr marL="0" indent="0">
               <a:buNone/>
             </a:pPr>
             <a:r>
@@ -11715,7 +11504,6 @@
             <a:avLst/>
           </a:prstGeom>
           <a:noFill/>
-          <a:ln/>
         </p:spPr>
         <p:txBody>
           <a:bodyPr wrap="square" lIns="0" tIns="0" rIns="0" bIns="0" rtlCol="0" anchor="ctr">
@@ -11723,7 +11511,7 @@
           </a:bodyPr>
           <a:lstStyle/>
           <a:p>
-            <a:pPr indent="0" marL="0">
+            <a:pPr marL="0" indent="0">
               <a:buNone/>
             </a:pPr>
             <a:r>
@@ -11768,7 +11556,7 @@
             <a:prstDash val="solid"/>
           </a:ln>
           <a:effectLst>
-            <a:outerShdw sx="100000" sy="100000" kx="0" ky="0" algn="bl" rotWithShape="0" blurRad="25400" dist="12700" dir="2700000">
+            <a:outerShdw blurRad="25400" dist="12700" dir="2700000" algn="bl" rotWithShape="0">
               <a:srgbClr val="000000">
                 <a:alpha val="16000"/>
               </a:srgbClr>
@@ -11791,13 +11579,12 @@
             <a:avLst/>
           </a:prstGeom>
           <a:noFill/>
-          <a:ln/>
         </p:spPr>
         <p:txBody>
           <a:bodyPr wrap="square" lIns="0" tIns="0" rIns="0" bIns="0" rtlCol="0" anchor="ctr"/>
           <a:lstStyle/>
           <a:p>
-            <a:pPr indent="0" marL="0">
+            <a:pPr marL="0" indent="0">
               <a:buNone/>
             </a:pPr>
             <a:r>
@@ -11827,7 +11614,6 @@
             <a:avLst/>
           </a:prstGeom>
           <a:noFill/>
-          <a:ln/>
         </p:spPr>
         <p:txBody>
           <a:bodyPr wrap="square" lIns="0" tIns="0" rIns="0" bIns="0" rtlCol="0" anchor="ctr">
@@ -11835,7 +11621,7 @@
           </a:bodyPr>
           <a:lstStyle/>
           <a:p>
-            <a:pPr indent="0" marL="0">
+            <a:pPr marL="0" indent="0">
               <a:buNone/>
             </a:pPr>
             <a:r>
@@ -11880,7 +11666,7 @@
             <a:prstDash val="solid"/>
           </a:ln>
           <a:effectLst>
-            <a:outerShdw sx="100000" sy="100000" kx="0" ky="0" algn="bl" rotWithShape="0" blurRad="25400" dist="12700" dir="2700000">
+            <a:outerShdw blurRad="25400" dist="12700" dir="2700000" algn="bl" rotWithShape="0">
               <a:srgbClr val="000000">
                 <a:alpha val="16000"/>
               </a:srgbClr>
@@ -11903,13 +11689,12 @@
             <a:avLst/>
           </a:prstGeom>
           <a:noFill/>
-          <a:ln/>
         </p:spPr>
         <p:txBody>
           <a:bodyPr wrap="square" lIns="0" tIns="0" rIns="0" bIns="0" rtlCol="0" anchor="ctr"/>
           <a:lstStyle/>
           <a:p>
-            <a:pPr indent="0" marL="0">
+            <a:pPr marL="0" indent="0">
               <a:buNone/>
             </a:pPr>
             <a:r>
@@ -11939,7 +11724,6 @@
             <a:avLst/>
           </a:prstGeom>
           <a:noFill/>
-          <a:ln/>
         </p:spPr>
         <p:txBody>
           <a:bodyPr wrap="square" lIns="0" tIns="0" rIns="0" bIns="0" rtlCol="0" anchor="ctr">
@@ -11947,7 +11731,7 @@
           </a:bodyPr>
           <a:lstStyle/>
           <a:p>
-            <a:pPr indent="0" marL="0">
+            <a:pPr marL="0" indent="0">
               <a:buNone/>
             </a:pPr>
             <a:r>
@@ -11977,13 +11761,12 @@
             <a:avLst/>
           </a:prstGeom>
           <a:noFill/>
-          <a:ln/>
         </p:spPr>
         <p:txBody>
           <a:bodyPr wrap="square" lIns="0" tIns="0" rIns="0" bIns="0" rtlCol="0" anchor="ctr"/>
           <a:lstStyle/>
           <a:p>
-            <a:pPr indent="0" marL="0">
+            <a:pPr marL="0" indent="0">
               <a:buNone/>
             </a:pPr>
             <a:r>
@@ -12008,12 +11791,13 @@
 
 <file path=ppt/slides/slide6.xml><?xml version="1.0" encoding="utf-8"?>
 <p:sld xmlns:a="http://schemas.openxmlformats.org/drawingml/2006/main" xmlns:r="http://schemas.openxmlformats.org/officeDocument/2006/relationships" xmlns:p="http://schemas.openxmlformats.org/presentationml/2006/main">
-  <p:cSld name="Slide 6">
+  <p:cSld>
     <p:bg>
       <p:bgPr>
         <a:solidFill>
           <a:srgbClr val="050816"/>
         </a:solidFill>
+        <a:effectLst/>
       </p:bgPr>
     </p:bg>
     <p:spTree>
@@ -12765,24 +12549,23 @@
         </p:nvSpPr>
         <p:spPr>
           <a:xfrm>
-            <a:off x="566928" y="384048"/>
+            <a:off x="566928" y="246888"/>
             <a:ext cx="4389120" cy="228600"/>
           </a:xfrm>
           <a:prstGeom prst="rect">
             <a:avLst/>
           </a:prstGeom>
           <a:noFill/>
-          <a:ln/>
         </p:spPr>
         <p:txBody>
           <a:bodyPr wrap="square" lIns="0" tIns="0" rIns="0" bIns="0" rtlCol="0" anchor="ctr"/>
           <a:lstStyle/>
           <a:p>
-            <a:pPr indent="0" marL="0">
+            <a:pPr marL="0" indent="0">
               <a:buNone/>
             </a:pPr>
             <a:r>
-              <a:rPr lang="en-US" sz="950" b="1" spc="260" kern="0" dirty="0">
+              <a:rPr lang="en-US" sz="950" b="1" kern="0" spc="260" dirty="0">
                 <a:solidFill>
                   <a:srgbClr val="5EEAD4"/>
                 </a:solidFill>
@@ -12808,13 +12591,12 @@
             <a:avLst/>
           </a:prstGeom>
           <a:noFill/>
-          <a:ln/>
         </p:spPr>
         <p:txBody>
           <a:bodyPr wrap="square" lIns="0" tIns="0" rIns="0" bIns="0" rtlCol="0" anchor="ctr"/>
           <a:lstStyle/>
           <a:p>
-            <a:pPr indent="0" marL="0">
+            <a:pPr marL="0" indent="0">
               <a:buNone/>
             </a:pPr>
             <a:r>
@@ -12822,9 +12604,9 @@
                 <a:solidFill>
                   <a:srgbClr val="F8FAFC"/>
                 </a:solidFill>
-                <a:latin typeface="Microsoft YaHei UI" pitchFamily="34" charset="0"/>
-                <a:ea typeface="Microsoft YaHei UI" pitchFamily="34" charset="-122"/>
-                <a:cs typeface="Microsoft YaHei UI" pitchFamily="34" charset="-120"/>
+                <a:latin typeface="Microsoft YaHei UI" panose="020B0503020204020204" pitchFamily="34" charset="-122"/>
+                <a:ea typeface="Microsoft YaHei UI" panose="020B0503020204020204" pitchFamily="34" charset="-122"/>
+                <a:cs typeface="Microsoft YaHei UI" panose="020B0503020204020204" pitchFamily="34" charset="-120"/>
               </a:rPr>
               <a:t>让成长被看见：洞府、长河、灵根与内核舱</a:t>
             </a:r>
@@ -12847,7 +12629,6 @@
             <a:avLst/>
           </a:prstGeom>
           <a:noFill/>
-          <a:ln/>
         </p:spPr>
         <p:txBody>
           <a:bodyPr wrap="square" lIns="0" tIns="0" rIns="0" bIns="0" rtlCol="0" anchor="ctr">
@@ -12855,7 +12636,7 @@
           </a:bodyPr>
           <a:lstStyle/>
           <a:p>
-            <a:pPr indent="0" marL="0">
+            <a:pPr marL="0" indent="0">
               <a:buNone/>
             </a:pPr>
             <a:r>
@@ -12916,22 +12697,37 @@
             <a:avLst/>
           </a:prstGeom>
           <a:noFill/>
-          <a:ln/>
         </p:spPr>
         <p:txBody>
           <a:bodyPr wrap="square" lIns="0" tIns="0" rIns="0" bIns="0" rtlCol="0" anchor="ctr"/>
           <a:lstStyle/>
           <a:p>
-            <a:pPr algn="ctr" indent="0" marL="0">
+            <a:pPr marL="0" indent="0" algn="ctr">
               <a:buNone/>
             </a:pPr>
             <a:r>
-              <a:rPr lang="en-US" sz="840" b="1" spc="120" kern="0" dirty="0">
+              <a:rPr lang="en-US" sz="840" b="1" kern="0" spc="120" dirty="0">
                 <a:solidFill>
                   <a:srgbClr val="A78BFA"/>
                 </a:solidFill>
               </a:rPr>
-              <a:t>二 / 3</a:t>
+              <a:t>二 </a:t>
+            </a:r>
+            <a:r>
+              <a:rPr lang="zh-CN" altLang="en-US" sz="840" b="1" kern="0" spc="120" dirty="0">
+                <a:solidFill>
+                  <a:srgbClr val="A78BFA"/>
+                </a:solidFill>
+              </a:rPr>
+              <a:t>、</a:t>
+            </a:r>
+            <a:r>
+              <a:rPr lang="en-US" sz="840" b="1" kern="0" spc="120" dirty="0">
+                <a:solidFill>
+                  <a:srgbClr val="A78BFA"/>
+                </a:solidFill>
+              </a:rPr>
+              <a:t> 3</a:t>
             </a:r>
             <a:endParaRPr lang="en-US" sz="840" dirty="0"/>
           </a:p>
@@ -12952,7 +12748,6 @@
             <a:avLst/>
           </a:prstGeom>
           <a:noFill/>
-          <a:ln/>
         </p:spPr>
         <p:txBody>
           <a:bodyPr wrap="square" lIns="0" tIns="0" rIns="0" bIns="0" rtlCol="0" anchor="ctr">
@@ -12960,7 +12755,7 @@
           </a:bodyPr>
           <a:lstStyle/>
           <a:p>
-            <a:pPr indent="0" marL="0">
+            <a:pPr marL="0" indent="0">
               <a:buNone/>
             </a:pPr>
             <a:r>
@@ -13005,7 +12800,7 @@
             <a:prstDash val="solid"/>
           </a:ln>
           <a:effectLst>
-            <a:outerShdw sx="100000" sy="100000" kx="0" ky="0" algn="bl" rotWithShape="0" blurRad="25400" dist="12700" dir="2700000">
+            <a:outerShdw blurRad="25400" dist="12700" dir="2700000" algn="bl" rotWithShape="0">
               <a:srgbClr val="000000">
                 <a:alpha val="16000"/>
               </a:srgbClr>
@@ -13028,13 +12823,12 @@
             <a:avLst/>
           </a:prstGeom>
           <a:noFill/>
-          <a:ln/>
         </p:spPr>
         <p:txBody>
           <a:bodyPr wrap="square" lIns="0" tIns="0" rIns="0" bIns="0" rtlCol="0" anchor="ctr"/>
           <a:lstStyle/>
           <a:p>
-            <a:pPr indent="0" marL="0">
+            <a:pPr marL="0" indent="0">
               <a:buNone/>
             </a:pPr>
             <a:r>
@@ -13064,7 +12858,6 @@
             <a:avLst/>
           </a:prstGeom>
           <a:noFill/>
-          <a:ln/>
         </p:spPr>
         <p:txBody>
           <a:bodyPr wrap="square" lIns="0" tIns="0" rIns="0" bIns="0" rtlCol="0" anchor="ctr">
@@ -13072,7 +12865,7 @@
           </a:bodyPr>
           <a:lstStyle/>
           <a:p>
-            <a:pPr indent="0" marL="0">
+            <a:pPr marL="0" indent="0">
               <a:buNone/>
             </a:pPr>
             <a:r>
@@ -13117,7 +12910,7 @@
             <a:prstDash val="solid"/>
           </a:ln>
           <a:effectLst>
-            <a:outerShdw sx="100000" sy="100000" kx="0" ky="0" algn="bl" rotWithShape="0" blurRad="25400" dist="12700" dir="2700000">
+            <a:outerShdw blurRad="25400" dist="12700" dir="2700000" algn="bl" rotWithShape="0">
               <a:srgbClr val="000000">
                 <a:alpha val="16000"/>
               </a:srgbClr>
@@ -13140,13 +12933,12 @@
             <a:avLst/>
           </a:prstGeom>
           <a:noFill/>
-          <a:ln/>
         </p:spPr>
         <p:txBody>
           <a:bodyPr wrap="square" lIns="0" tIns="0" rIns="0" bIns="0" rtlCol="0" anchor="ctr"/>
           <a:lstStyle/>
           <a:p>
-            <a:pPr indent="0" marL="0">
+            <a:pPr marL="0" indent="0">
               <a:buNone/>
             </a:pPr>
             <a:r>
@@ -13176,7 +12968,6 @@
             <a:avLst/>
           </a:prstGeom>
           <a:noFill/>
-          <a:ln/>
         </p:spPr>
         <p:txBody>
           <a:bodyPr wrap="square" lIns="0" tIns="0" rIns="0" bIns="0" rtlCol="0" anchor="ctr">
@@ -13184,7 +12975,7 @@
           </a:bodyPr>
           <a:lstStyle/>
           <a:p>
-            <a:pPr indent="0" marL="0">
+            <a:pPr marL="0" indent="0">
               <a:buNone/>
             </a:pPr>
             <a:r>
@@ -13229,7 +13020,7 @@
             <a:prstDash val="solid"/>
           </a:ln>
           <a:effectLst>
-            <a:outerShdw sx="100000" sy="100000" kx="0" ky="0" algn="bl" rotWithShape="0" blurRad="25400" dist="12700" dir="2700000">
+            <a:outerShdw blurRad="25400" dist="12700" dir="2700000" algn="bl" rotWithShape="0">
               <a:srgbClr val="000000">
                 <a:alpha val="16000"/>
               </a:srgbClr>
@@ -13252,13 +13043,12 @@
             <a:avLst/>
           </a:prstGeom>
           <a:noFill/>
-          <a:ln/>
         </p:spPr>
         <p:txBody>
           <a:bodyPr wrap="square" lIns="0" tIns="0" rIns="0" bIns="0" rtlCol="0" anchor="ctr"/>
           <a:lstStyle/>
           <a:p>
-            <a:pPr indent="0" marL="0">
+            <a:pPr marL="0" indent="0">
               <a:buNone/>
             </a:pPr>
             <a:r>
@@ -13288,7 +13078,6 @@
             <a:avLst/>
           </a:prstGeom>
           <a:noFill/>
-          <a:ln/>
         </p:spPr>
         <p:txBody>
           <a:bodyPr wrap="square" lIns="0" tIns="0" rIns="0" bIns="0" rtlCol="0" anchor="ctr">
@@ -13296,7 +13085,7 @@
           </a:bodyPr>
           <a:lstStyle/>
           <a:p>
-            <a:pPr indent="0" marL="0">
+            <a:pPr marL="0" indent="0">
               <a:buNone/>
             </a:pPr>
             <a:r>
@@ -13341,7 +13130,7 @@
             <a:prstDash val="solid"/>
           </a:ln>
           <a:effectLst>
-            <a:outerShdw sx="100000" sy="100000" kx="0" ky="0" algn="bl" rotWithShape="0" blurRad="25400" dist="12700" dir="2700000">
+            <a:outerShdw blurRad="25400" dist="12700" dir="2700000" algn="bl" rotWithShape="0">
               <a:srgbClr val="000000">
                 <a:alpha val="16000"/>
               </a:srgbClr>
@@ -13364,13 +13153,12 @@
             <a:avLst/>
           </a:prstGeom>
           <a:noFill/>
-          <a:ln/>
         </p:spPr>
         <p:txBody>
           <a:bodyPr wrap="square" lIns="0" tIns="0" rIns="0" bIns="0" rtlCol="0" anchor="ctr"/>
           <a:lstStyle/>
           <a:p>
-            <a:pPr indent="0" marL="0">
+            <a:pPr marL="0" indent="0">
               <a:buNone/>
             </a:pPr>
             <a:r>
@@ -13400,7 +13188,6 @@
             <a:avLst/>
           </a:prstGeom>
           <a:noFill/>
-          <a:ln/>
         </p:spPr>
         <p:txBody>
           <a:bodyPr wrap="square" lIns="0" tIns="0" rIns="0" bIns="0" rtlCol="0" anchor="ctr">
@@ -13408,7 +13195,7 @@
           </a:bodyPr>
           <a:lstStyle/>
           <a:p>
-            <a:pPr indent="0" marL="0">
+            <a:pPr marL="0" indent="0">
               <a:buNone/>
             </a:pPr>
             <a:r>
@@ -13438,13 +13225,12 @@
             <a:avLst/>
           </a:prstGeom>
           <a:noFill/>
-          <a:ln/>
         </p:spPr>
         <p:txBody>
           <a:bodyPr wrap="square" lIns="0" tIns="0" rIns="0" bIns="0" rtlCol="0" anchor="ctr"/>
           <a:lstStyle/>
           <a:p>
-            <a:pPr indent="0" marL="0">
+            <a:pPr marL="0" indent="0">
               <a:buNone/>
             </a:pPr>
             <a:r>
@@ -13474,7 +13260,6 @@
             <a:avLst/>
           </a:prstGeom>
           <a:noFill/>
-          <a:ln/>
         </p:spPr>
         <p:txBody>
           <a:bodyPr wrap="square" lIns="0" tIns="0" rIns="0" bIns="0" rtlCol="0" anchor="ctr">
@@ -13482,7 +13267,7 @@
           </a:bodyPr>
           <a:lstStyle/>
           <a:p>
-            <a:pPr indent="0" marL="0">
+            <a:pPr marL="0" indent="0">
               <a:buNone/>
             </a:pPr>
             <a:r>
@@ -13512,13 +13297,12 @@
             <a:avLst/>
           </a:prstGeom>
           <a:noFill/>
-          <a:ln/>
         </p:spPr>
         <p:txBody>
           <a:bodyPr wrap="square" lIns="0" tIns="0" rIns="0" bIns="0" rtlCol="0" anchor="ctr"/>
           <a:lstStyle/>
           <a:p>
-            <a:pPr indent="0" marL="0">
+            <a:pPr marL="0" indent="0">
               <a:buNone/>
             </a:pPr>
             <a:r>
@@ -13543,12 +13327,13 @@
 
 <file path=ppt/slides/slide7.xml><?xml version="1.0" encoding="utf-8"?>
 <p:sld xmlns:a="http://schemas.openxmlformats.org/drawingml/2006/main" xmlns:r="http://schemas.openxmlformats.org/officeDocument/2006/relationships" xmlns:p="http://schemas.openxmlformats.org/presentationml/2006/main">
-  <p:cSld name="Slide 7">
+  <p:cSld>
     <p:bg>
       <p:bgPr>
         <a:solidFill>
           <a:srgbClr val="050816"/>
         </a:solidFill>
+        <a:effectLst/>
       </p:bgPr>
     </p:bg>
     <p:spTree>
@@ -14307,17 +14092,16 @@
             <a:avLst/>
           </a:prstGeom>
           <a:noFill/>
-          <a:ln/>
         </p:spPr>
         <p:txBody>
           <a:bodyPr wrap="square" lIns="0" tIns="0" rIns="0" bIns="0" rtlCol="0" anchor="ctr"/>
           <a:lstStyle/>
           <a:p>
-            <a:pPr indent="0" marL="0">
+            <a:pPr marL="0" indent="0">
               <a:buNone/>
             </a:pPr>
             <a:r>
-              <a:rPr lang="en-US" sz="950" b="1" spc="260" kern="0" dirty="0">
+              <a:rPr lang="en-US" sz="950" b="1" kern="0" spc="260" dirty="0">
                 <a:solidFill>
                   <a:srgbClr val="5EEAD4"/>
                 </a:solidFill>
@@ -14343,13 +14127,12 @@
             <a:avLst/>
           </a:prstGeom>
           <a:noFill/>
-          <a:ln/>
         </p:spPr>
         <p:txBody>
           <a:bodyPr wrap="square" lIns="0" tIns="0" rIns="0" bIns="0" rtlCol="0" anchor="ctr"/>
           <a:lstStyle/>
           <a:p>
-            <a:pPr indent="0" marL="0">
+            <a:pPr marL="0" indent="0">
               <a:buNone/>
             </a:pPr>
             <a:r>
@@ -14357,9 +14140,9 @@
                 <a:solidFill>
                   <a:srgbClr val="F8FAFC"/>
                 </a:solidFill>
-                <a:latin typeface="Microsoft YaHei UI" pitchFamily="34" charset="0"/>
-                <a:ea typeface="Microsoft YaHei UI" pitchFamily="34" charset="-122"/>
-                <a:cs typeface="Microsoft YaHei UI" pitchFamily="34" charset="-120"/>
+                <a:latin typeface="Microsoft YaHei UI" panose="020B0503020204020204" pitchFamily="34" charset="-122"/>
+                <a:ea typeface="Microsoft YaHei UI" panose="020B0503020204020204" pitchFamily="34" charset="-122"/>
+                <a:cs typeface="Microsoft YaHei UI" panose="020B0503020204020204" pitchFamily="34" charset="-120"/>
               </a:rPr>
               <a:t>可追踪的 Agent 工程闭环</a:t>
             </a:r>
@@ -14382,7 +14165,6 @@
             <a:avLst/>
           </a:prstGeom>
           <a:noFill/>
-          <a:ln/>
         </p:spPr>
         <p:txBody>
           <a:bodyPr wrap="square" lIns="0" tIns="0" rIns="0" bIns="0" rtlCol="0" anchor="ctr">
@@ -14390,7 +14172,7 @@
           </a:bodyPr>
           <a:lstStyle/>
           <a:p>
-            <a:pPr indent="0" marL="0">
+            <a:pPr marL="0" indent="0">
               <a:buNone/>
             </a:pPr>
             <a:r>
@@ -14451,22 +14233,37 @@
             <a:avLst/>
           </a:prstGeom>
           <a:noFill/>
-          <a:ln/>
         </p:spPr>
         <p:txBody>
           <a:bodyPr wrap="square" lIns="0" tIns="0" rIns="0" bIns="0" rtlCol="0" anchor="ctr"/>
           <a:lstStyle/>
           <a:p>
-            <a:pPr algn="ctr" indent="0" marL="0">
+            <a:pPr marL="0" indent="0" algn="ctr">
               <a:buNone/>
             </a:pPr>
             <a:r>
-              <a:rPr lang="en-US" sz="840" b="1" spc="120" kern="0" dirty="0">
+              <a:rPr lang="en-US" sz="840" b="1" kern="0" spc="120" dirty="0">
                 <a:solidFill>
                   <a:srgbClr val="F6C768"/>
                 </a:solidFill>
               </a:rPr>
-              <a:t>三 / 1</a:t>
+              <a:t>三 </a:t>
+            </a:r>
+            <a:r>
+              <a:rPr lang="zh-CN" altLang="en-US" sz="840" b="1" kern="0" spc="120" dirty="0">
+                <a:solidFill>
+                  <a:srgbClr val="F6C768"/>
+                </a:solidFill>
+              </a:rPr>
+              <a:t>、</a:t>
+            </a:r>
+            <a:r>
+              <a:rPr lang="en-US" sz="840" b="1" kern="0" spc="120" dirty="0">
+                <a:solidFill>
+                  <a:srgbClr val="F6C768"/>
+                </a:solidFill>
+              </a:rPr>
+              <a:t> 1</a:t>
             </a:r>
             <a:endParaRPr lang="en-US" sz="840" dirty="0"/>
           </a:p>
@@ -14487,7 +14284,6 @@
             <a:avLst/>
           </a:prstGeom>
           <a:noFill/>
-          <a:ln/>
         </p:spPr>
         <p:txBody>
           <a:bodyPr wrap="square" lIns="0" tIns="0" rIns="0" bIns="0" rtlCol="0" anchor="ctr">
@@ -14495,7 +14291,7 @@
           </a:bodyPr>
           <a:lstStyle/>
           <a:p>
-            <a:pPr indent="0" marL="0">
+            <a:pPr marL="0" indent="0">
               <a:buNone/>
             </a:pPr>
             <a:r>
@@ -14540,7 +14336,7 @@
             <a:prstDash val="solid"/>
           </a:ln>
           <a:effectLst>
-            <a:outerShdw sx="100000" sy="100000" kx="0" ky="0" algn="bl" rotWithShape="0" blurRad="25400" dist="12700" dir="2700000">
+            <a:outerShdw blurRad="25400" dist="12700" dir="2700000" algn="bl" rotWithShape="0">
               <a:srgbClr val="000000">
                 <a:alpha val="16000"/>
               </a:srgbClr>
@@ -14563,13 +14359,12 @@
             <a:avLst/>
           </a:prstGeom>
           <a:noFill/>
-          <a:ln/>
         </p:spPr>
         <p:txBody>
           <a:bodyPr wrap="square" lIns="0" tIns="0" rIns="0" bIns="0" rtlCol="0" anchor="ctr"/>
           <a:lstStyle/>
           <a:p>
-            <a:pPr algn="ctr" indent="0" marL="0">
+            <a:pPr marL="0" indent="0" algn="ctr">
               <a:buNone/>
             </a:pPr>
             <a:r>
@@ -14599,17 +14394,16 @@
             <a:avLst/>
           </a:prstGeom>
           <a:noFill/>
-          <a:ln/>
         </p:spPr>
         <p:txBody>
           <a:bodyPr wrap="square" lIns="0" tIns="0" rIns="0" bIns="0" rtlCol="0" anchor="ctr"/>
           <a:lstStyle/>
           <a:p>
-            <a:pPr algn="ctr" indent="0" marL="0">
+            <a:pPr marL="0" indent="0" algn="ctr">
               <a:buNone/>
             </a:pPr>
             <a:r>
-              <a:rPr lang="en-US" sz="950" spc="120" kern="0" dirty="0">
+              <a:rPr lang="en-US" sz="950" kern="0" spc="120" dirty="0">
                 <a:solidFill>
                   <a:srgbClr val="5EEAD4"/>
                 </a:solidFill>
@@ -14650,7 +14444,7 @@
             <a:prstDash val="solid"/>
           </a:ln>
           <a:effectLst>
-            <a:outerShdw sx="100000" sy="100000" kx="0" ky="0" algn="bl" rotWithShape="0" blurRad="25400" dist="12700" dir="2700000">
+            <a:outerShdw blurRad="25400" dist="12700" dir="2700000" algn="bl" rotWithShape="0">
               <a:srgbClr val="000000">
                 <a:alpha val="16000"/>
               </a:srgbClr>
@@ -14673,13 +14467,12 @@
             <a:avLst/>
           </a:prstGeom>
           <a:noFill/>
-          <a:ln/>
         </p:spPr>
         <p:txBody>
           <a:bodyPr wrap="square" lIns="0" tIns="0" rIns="0" bIns="0" rtlCol="0" anchor="ctr"/>
           <a:lstStyle/>
           <a:p>
-            <a:pPr algn="ctr" indent="0" marL="0">
+            <a:pPr marL="0" indent="0" algn="ctr">
               <a:buNone/>
             </a:pPr>
             <a:r>
@@ -14702,8 +14495,8 @@
         </p:nvSpPr>
         <p:spPr>
           <a:xfrm>
-            <a:off x="1938528" y="2231136"/>
-            <a:ext cx="4160520" cy="630936"/>
+            <a:off x="1938655" y="2231390"/>
+            <a:ext cx="2377440" cy="393700"/>
           </a:xfrm>
           <a:prstGeom prst="line">
             <a:avLst/>
@@ -14749,7 +14542,7 @@
             <a:prstDash val="solid"/>
           </a:ln>
           <a:effectLst>
-            <a:outerShdw sx="100000" sy="100000" kx="0" ky="0" algn="bl" rotWithShape="0" blurRad="25400" dist="12700" dir="2700000">
+            <a:outerShdw blurRad="25400" dist="12700" dir="2700000" algn="bl" rotWithShape="0">
               <a:srgbClr val="000000">
                 <a:alpha val="16000"/>
               </a:srgbClr>
@@ -14772,13 +14565,12 @@
             <a:avLst/>
           </a:prstGeom>
           <a:noFill/>
-          <a:ln/>
         </p:spPr>
         <p:txBody>
           <a:bodyPr wrap="square" lIns="0" tIns="0" rIns="0" bIns="0" rtlCol="0" anchor="ctr"/>
           <a:lstStyle/>
           <a:p>
-            <a:pPr algn="ctr" indent="0" marL="0">
+            <a:pPr marL="0" indent="0" algn="ctr">
               <a:buNone/>
             </a:pPr>
             <a:r>
@@ -14800,9 +14592,9 @@
           <p:nvPr/>
         </p:nvSpPr>
         <p:spPr>
-          <a:xfrm>
-            <a:off x="1984248" y="2862072"/>
-            <a:ext cx="4114800" cy="2048256"/>
+          <a:xfrm flipV="1">
+            <a:off x="2089150" y="3415665"/>
+            <a:ext cx="2226310" cy="911225"/>
           </a:xfrm>
           <a:prstGeom prst="line">
             <a:avLst/>
@@ -14848,7 +14640,7 @@
             <a:prstDash val="solid"/>
           </a:ln>
           <a:effectLst>
-            <a:outerShdw sx="100000" sy="100000" kx="0" ky="0" algn="bl" rotWithShape="0" blurRad="25400" dist="12700" dir="2700000">
+            <a:outerShdw blurRad="25400" dist="12700" dir="2700000" algn="bl" rotWithShape="0">
               <a:srgbClr val="000000">
                 <a:alpha val="16000"/>
               </a:srgbClr>
@@ -14871,13 +14663,12 @@
             <a:avLst/>
           </a:prstGeom>
           <a:noFill/>
-          <a:ln/>
         </p:spPr>
         <p:txBody>
           <a:bodyPr wrap="square" lIns="0" tIns="0" rIns="0" bIns="0" rtlCol="0" anchor="ctr"/>
           <a:lstStyle/>
           <a:p>
-            <a:pPr algn="ctr" indent="0" marL="0">
+            <a:pPr marL="0" indent="0" algn="ctr">
               <a:buNone/>
             </a:pPr>
             <a:r>
@@ -14900,8 +14691,8 @@
         </p:nvSpPr>
         <p:spPr>
           <a:xfrm>
-            <a:off x="5596128" y="2862072"/>
-            <a:ext cx="502920" cy="2688336"/>
+            <a:off x="5688330" y="3454400"/>
+            <a:ext cx="64770" cy="1529080"/>
           </a:xfrm>
           <a:prstGeom prst="line">
             <a:avLst/>
@@ -14947,7 +14738,7 @@
             <a:prstDash val="solid"/>
           </a:ln>
           <a:effectLst>
-            <a:outerShdw sx="100000" sy="100000" kx="0" ky="0" algn="bl" rotWithShape="0" blurRad="25400" dist="12700" dir="2700000">
+            <a:outerShdw blurRad="25400" dist="12700" dir="2700000" algn="bl" rotWithShape="0">
               <a:srgbClr val="000000">
                 <a:alpha val="16000"/>
               </a:srgbClr>
@@ -14970,13 +14761,12 @@
             <a:avLst/>
           </a:prstGeom>
           <a:noFill/>
-          <a:ln/>
         </p:spPr>
         <p:txBody>
           <a:bodyPr wrap="square" lIns="0" tIns="0" rIns="0" bIns="0" rtlCol="0" anchor="ctr"/>
           <a:lstStyle/>
           <a:p>
-            <a:pPr algn="ctr" indent="0" marL="0">
+            <a:pPr marL="0" indent="0" algn="ctr">
               <a:buNone/>
             </a:pPr>
             <a:r>
@@ -14999,8 +14789,8 @@
         </p:nvSpPr>
         <p:spPr>
           <a:xfrm>
-            <a:off x="6099048" y="2862072"/>
-            <a:ext cx="3886200" cy="2048256"/>
+            <a:off x="6947535" y="3453765"/>
+            <a:ext cx="2733675" cy="913130"/>
           </a:xfrm>
           <a:prstGeom prst="line">
             <a:avLst/>
@@ -15046,7 +14836,7 @@
             <a:prstDash val="solid"/>
           </a:ln>
           <a:effectLst>
-            <a:outerShdw sx="100000" sy="100000" kx="0" ky="0" algn="bl" rotWithShape="0" blurRad="25400" dist="12700" dir="2700000">
+            <a:outerShdw blurRad="25400" dist="12700" dir="2700000" algn="bl" rotWithShape="0">
               <a:srgbClr val="000000">
                 <a:alpha val="16000"/>
               </a:srgbClr>
@@ -15069,13 +14859,12 @@
             <a:avLst/>
           </a:prstGeom>
           <a:noFill/>
-          <a:ln/>
         </p:spPr>
         <p:txBody>
           <a:bodyPr wrap="square" lIns="0" tIns="0" rIns="0" bIns="0" rtlCol="0" anchor="ctr"/>
           <a:lstStyle/>
           <a:p>
-            <a:pPr algn="ctr" indent="0" marL="0">
+            <a:pPr marL="0" indent="0" algn="ctr">
               <a:buNone/>
             </a:pPr>
             <a:r>
@@ -15097,9 +14886,9 @@
           <p:nvPr/>
         </p:nvSpPr>
         <p:spPr>
-          <a:xfrm>
-            <a:off x="6099048" y="2231136"/>
-            <a:ext cx="4069080" cy="630936"/>
+          <a:xfrm flipV="1">
+            <a:off x="6191885" y="1821815"/>
+            <a:ext cx="2952115" cy="464185"/>
           </a:xfrm>
           <a:prstGeom prst="line">
             <a:avLst/>
@@ -15130,13 +14919,12 @@
             <a:avLst/>
           </a:prstGeom>
           <a:noFill/>
-          <a:ln/>
         </p:spPr>
         <p:txBody>
           <a:bodyPr wrap="square" lIns="0" tIns="0" rIns="0" bIns="0" rtlCol="0" anchor="ctr"/>
           <a:lstStyle/>
           <a:p>
-            <a:pPr indent="0" marL="0">
+            <a:pPr marL="0" indent="0">
               <a:buNone/>
             </a:pPr>
             <a:r>
@@ -15166,7 +14954,6 @@
             <a:avLst/>
           </a:prstGeom>
           <a:noFill/>
-          <a:ln/>
         </p:spPr>
         <p:txBody>
           <a:bodyPr wrap="square" lIns="0" tIns="0" rIns="0" bIns="0" rtlCol="0" anchor="ctr">
@@ -15174,7 +14961,7 @@
           </a:bodyPr>
           <a:lstStyle/>
           <a:p>
-            <a:pPr indent="0" marL="0">
+            <a:pPr marL="0" indent="0">
               <a:buNone/>
             </a:pPr>
             <a:r>
@@ -15204,13 +14991,12 @@
             <a:avLst/>
           </a:prstGeom>
           <a:noFill/>
-          <a:ln/>
         </p:spPr>
         <p:txBody>
           <a:bodyPr wrap="square" lIns="0" tIns="0" rIns="0" bIns="0" rtlCol="0" anchor="ctr"/>
           <a:lstStyle/>
           <a:p>
-            <a:pPr indent="0" marL="0">
+            <a:pPr marL="0" indent="0">
               <a:buNone/>
             </a:pPr>
             <a:r>
@@ -15235,12 +15021,13 @@
 
 <file path=ppt/slides/slide8.xml><?xml version="1.0" encoding="utf-8"?>
 <p:sld xmlns:a="http://schemas.openxmlformats.org/drawingml/2006/main" xmlns:r="http://schemas.openxmlformats.org/officeDocument/2006/relationships" xmlns:p="http://schemas.openxmlformats.org/presentationml/2006/main">
-  <p:cSld name="Slide 8">
+  <p:cSld>
     <p:bg>
       <p:bgPr>
         <a:solidFill>
           <a:srgbClr val="050816"/>
         </a:solidFill>
+        <a:effectLst/>
       </p:bgPr>
     </p:bg>
     <p:spTree>
@@ -15999,17 +15786,16 @@
             <a:avLst/>
           </a:prstGeom>
           <a:noFill/>
-          <a:ln/>
         </p:spPr>
         <p:txBody>
           <a:bodyPr wrap="square" lIns="0" tIns="0" rIns="0" bIns="0" rtlCol="0" anchor="ctr"/>
           <a:lstStyle/>
           <a:p>
-            <a:pPr indent="0" marL="0">
+            <a:pPr marL="0" indent="0">
               <a:buNone/>
             </a:pPr>
             <a:r>
-              <a:rPr lang="en-US" sz="950" b="1" spc="260" kern="0" dirty="0">
+              <a:rPr lang="en-US" sz="950" b="1" kern="0" spc="260" dirty="0">
                 <a:solidFill>
                   <a:srgbClr val="5EEAD4"/>
                 </a:solidFill>
@@ -16035,13 +15821,12 @@
             <a:avLst/>
           </a:prstGeom>
           <a:noFill/>
-          <a:ln/>
         </p:spPr>
         <p:txBody>
           <a:bodyPr wrap="square" lIns="0" tIns="0" rIns="0" bIns="0" rtlCol="0" anchor="ctr"/>
           <a:lstStyle/>
           <a:p>
-            <a:pPr indent="0" marL="0">
+            <a:pPr marL="0" indent="0">
               <a:buNone/>
             </a:pPr>
             <a:r>
@@ -16049,9 +15834,9 @@
                 <a:solidFill>
                   <a:srgbClr val="F8FAFC"/>
                 </a:solidFill>
-                <a:latin typeface="Microsoft YaHei UI" pitchFamily="34" charset="0"/>
-                <a:ea typeface="Microsoft YaHei UI" pitchFamily="34" charset="-122"/>
-                <a:cs typeface="Microsoft YaHei UI" pitchFamily="34" charset="-120"/>
+                <a:latin typeface="Microsoft YaHei UI" panose="020B0503020204020204" pitchFamily="34" charset="-122"/>
+                <a:ea typeface="Microsoft YaHei UI" panose="020B0503020204020204" pitchFamily="34" charset="-122"/>
+                <a:cs typeface="Microsoft YaHei UI" panose="020B0503020204020204" pitchFamily="34" charset="-120"/>
               </a:rPr>
               <a:t>双循环：越懂你，也越会帮你</a:t>
             </a:r>
@@ -16074,7 +15859,6 @@
             <a:avLst/>
           </a:prstGeom>
           <a:noFill/>
-          <a:ln/>
         </p:spPr>
         <p:txBody>
           <a:bodyPr wrap="square" lIns="0" tIns="0" rIns="0" bIns="0" rtlCol="0" anchor="ctr">
@@ -16082,7 +15866,7 @@
           </a:bodyPr>
           <a:lstStyle/>
           <a:p>
-            <a:pPr indent="0" marL="0">
+            <a:pPr marL="0" indent="0">
               <a:buNone/>
             </a:pPr>
             <a:r>
@@ -16143,22 +15927,37 @@
             <a:avLst/>
           </a:prstGeom>
           <a:noFill/>
-          <a:ln/>
         </p:spPr>
         <p:txBody>
           <a:bodyPr wrap="square" lIns="0" tIns="0" rIns="0" bIns="0" rtlCol="0" anchor="ctr"/>
           <a:lstStyle/>
           <a:p>
-            <a:pPr algn="ctr" indent="0" marL="0">
+            <a:pPr marL="0" indent="0" algn="ctr">
               <a:buNone/>
             </a:pPr>
             <a:r>
-              <a:rPr lang="en-US" sz="840" b="1" spc="120" kern="0" dirty="0">
+              <a:rPr lang="en-US" sz="840" b="1" kern="0" spc="120" dirty="0">
                 <a:solidFill>
                   <a:srgbClr val="F6C768"/>
                 </a:solidFill>
               </a:rPr>
-              <a:t>三 / 2</a:t>
+              <a:t>三 </a:t>
+            </a:r>
+            <a:r>
+              <a:rPr lang="zh-CN" altLang="en-US" sz="840" b="1" kern="0" spc="120" dirty="0">
+                <a:solidFill>
+                  <a:srgbClr val="F6C768"/>
+                </a:solidFill>
+              </a:rPr>
+              <a:t>、</a:t>
+            </a:r>
+            <a:r>
+              <a:rPr lang="en-US" sz="840" b="1" kern="0" spc="120" dirty="0">
+                <a:solidFill>
+                  <a:srgbClr val="F6C768"/>
+                </a:solidFill>
+              </a:rPr>
+              <a:t> 2</a:t>
             </a:r>
             <a:endParaRPr lang="en-US" sz="840" dirty="0"/>
           </a:p>
@@ -16179,7 +15978,6 @@
             <a:avLst/>
           </a:prstGeom>
           <a:noFill/>
-          <a:ln/>
         </p:spPr>
         <p:txBody>
           <a:bodyPr wrap="square" lIns="0" tIns="0" rIns="0" bIns="0" rtlCol="0" anchor="ctr">
@@ -16187,7 +15985,7 @@
           </a:bodyPr>
           <a:lstStyle/>
           <a:p>
-            <a:pPr indent="0" marL="0">
+            <a:pPr marL="0" indent="0">
               <a:buNone/>
             </a:pPr>
             <a:r>
@@ -16232,7 +16030,7 @@
             <a:prstDash val="solid"/>
           </a:ln>
           <a:effectLst>
-            <a:outerShdw sx="100000" sy="100000" kx="0" ky="0" algn="bl" rotWithShape="0" blurRad="25400" dist="12700" dir="2700000">
+            <a:outerShdw blurRad="25400" dist="12700" dir="2700000" algn="bl" rotWithShape="0">
               <a:srgbClr val="000000">
                 <a:alpha val="16000"/>
               </a:srgbClr>
@@ -16284,13 +16082,12 @@
             <a:avLst/>
           </a:prstGeom>
           <a:noFill/>
-          <a:ln/>
         </p:spPr>
         <p:txBody>
           <a:bodyPr wrap="square" lIns="0" tIns="0" rIns="0" bIns="0" rtlCol="0" anchor="ctr"/>
           <a:lstStyle/>
           <a:p>
-            <a:pPr indent="0" marL="0">
+            <a:pPr marL="0" indent="0">
               <a:buNone/>
             </a:pPr>
             <a:r>
@@ -16320,13 +16117,12 @@
             <a:avLst/>
           </a:prstGeom>
           <a:noFill/>
-          <a:ln/>
         </p:spPr>
         <p:txBody>
           <a:bodyPr wrap="square" lIns="0" tIns="0" rIns="0" bIns="0" rtlCol="0" anchor="ctr"/>
           <a:lstStyle/>
           <a:p>
-            <a:pPr indent="0" marL="0">
+            <a:pPr marL="0" indent="0">
               <a:buNone/>
             </a:pPr>
             <a:r>
@@ -16356,13 +16152,12 @@
             <a:avLst/>
           </a:prstGeom>
           <a:noFill/>
-          <a:ln/>
         </p:spPr>
         <p:txBody>
           <a:bodyPr wrap="square" lIns="0" tIns="0" rIns="0" bIns="0" rtlCol="0" anchor="ctr"/>
           <a:lstStyle/>
           <a:p>
-            <a:pPr indent="0" marL="0">
+            <a:pPr marL="0" indent="0">
               <a:buNone/>
             </a:pPr>
             <a:r>
@@ -16370,16 +16165,16 @@
                 <a:solidFill>
                   <a:srgbClr val="5EEAD4"/>
                 </a:solidFill>
-                <a:latin typeface="Consolas" pitchFamily="34" charset="0"/>
-                <a:ea typeface="Consolas" pitchFamily="34" charset="-122"/>
-                <a:cs typeface="Consolas" pitchFamily="34" charset="-120"/>
+                <a:latin typeface="Consolas" panose="020B0609020204030204" pitchFamily="34" charset="0"/>
+                <a:ea typeface="Consolas" panose="020B0609020204030204" pitchFamily="34" charset="-122"/>
+                <a:cs typeface="Consolas" panose="020B0609020204030204" pitchFamily="34" charset="-120"/>
               </a:rPr>
               <a:t>/memory-vault</a:t>
             </a:r>
             <a:endParaRPr lang="en-US" sz="1400" dirty="0"/>
           </a:p>
           <a:p>
-            <a:pPr indent="0" marL="0">
+            <a:pPr marL="0" indent="0">
               <a:buNone/>
             </a:pPr>
             <a:r>
@@ -16387,16 +16182,16 @@
                 <a:solidFill>
                   <a:srgbClr val="5EEAD4"/>
                 </a:solidFill>
-                <a:latin typeface="Consolas" pitchFamily="34" charset="0"/>
-                <a:ea typeface="Consolas" pitchFamily="34" charset="-122"/>
-                <a:cs typeface="Consolas" pitchFamily="34" charset="-120"/>
+                <a:latin typeface="Consolas" panose="020B0609020204030204" pitchFamily="34" charset="0"/>
+                <a:ea typeface="Consolas" panose="020B0609020204030204" pitchFamily="34" charset="-122"/>
+                <a:cs typeface="Consolas" panose="020B0609020204030204" pitchFamily="34" charset="-120"/>
               </a:rPr>
               <a:t>  /profile.md</a:t>
             </a:r>
             <a:endParaRPr lang="en-US" sz="1400" dirty="0"/>
           </a:p>
           <a:p>
-            <a:pPr indent="0" marL="0">
+            <a:pPr marL="0" indent="0">
               <a:buNone/>
             </a:pPr>
             <a:r>
@@ -16404,16 +16199,16 @@
                 <a:solidFill>
                   <a:srgbClr val="5EEAD4"/>
                 </a:solidFill>
-                <a:latin typeface="Consolas" pitchFamily="34" charset="0"/>
-                <a:ea typeface="Consolas" pitchFamily="34" charset="-122"/>
-                <a:cs typeface="Consolas" pitchFamily="34" charset="-120"/>
+                <a:latin typeface="Consolas" panose="020B0609020204030204" pitchFamily="34" charset="0"/>
+                <a:ea typeface="Consolas" panose="020B0609020204030204" pitchFamily="34" charset="-122"/>
+                <a:cs typeface="Consolas" panose="020B0609020204030204" pitchFamily="34" charset="-120"/>
               </a:rPr>
               <a:t>  /memories/*.md</a:t>
             </a:r>
             <a:endParaRPr lang="en-US" sz="1400" dirty="0"/>
           </a:p>
           <a:p>
-            <a:pPr indent="0" marL="0">
+            <a:pPr marL="0" indent="0">
               <a:buNone/>
             </a:pPr>
             <a:r>
@@ -16421,16 +16216,16 @@
                 <a:solidFill>
                   <a:srgbClr val="5EEAD4"/>
                 </a:solidFill>
-                <a:latin typeface="Consolas" pitchFamily="34" charset="0"/>
-                <a:ea typeface="Consolas" pitchFamily="34" charset="-122"/>
-                <a:cs typeface="Consolas" pitchFamily="34" charset="-120"/>
+                <a:latin typeface="Consolas" panose="020B0609020204030204" pitchFamily="34" charset="0"/>
+                <a:ea typeface="Consolas" panose="020B0609020204030204" pitchFamily="34" charset="-122"/>
+                <a:cs typeface="Consolas" panose="020B0609020204030204" pitchFamily="34" charset="-120"/>
               </a:rPr>
               <a:t>  /skills/*.md</a:t>
             </a:r>
             <a:endParaRPr lang="en-US" sz="1400" dirty="0"/>
           </a:p>
           <a:p>
-            <a:pPr indent="0" marL="0">
+            <a:pPr marL="0" indent="0">
               <a:buNone/>
             </a:pPr>
             <a:r>
@@ -16438,16 +16233,16 @@
                 <a:solidFill>
                   <a:srgbClr val="5EEAD4"/>
                 </a:solidFill>
-                <a:latin typeface="Consolas" pitchFamily="34" charset="0"/>
-                <a:ea typeface="Consolas" pitchFamily="34" charset="-122"/>
-                <a:cs typeface="Consolas" pitchFamily="34" charset="-120"/>
+                <a:latin typeface="Consolas" panose="020B0609020204030204" pitchFamily="34" charset="0"/>
+                <a:ea typeface="Consolas" panose="020B0609020204030204" pitchFamily="34" charset="-122"/>
+                <a:cs typeface="Consolas" panose="020B0609020204030204" pitchFamily="34" charset="-120"/>
               </a:rPr>
               <a:t>  /traces/*.md</a:t>
             </a:r>
             <a:endParaRPr lang="en-US" sz="1400" dirty="0"/>
           </a:p>
           <a:p>
-            <a:pPr indent="0" marL="0">
+            <a:pPr marL="0" indent="0">
               <a:buNone/>
             </a:pPr>
             <a:r>
@@ -16455,9 +16250,9 @@
                 <a:solidFill>
                   <a:srgbClr val="5EEAD4"/>
                 </a:solidFill>
-                <a:latin typeface="Consolas" pitchFamily="34" charset="0"/>
-                <a:ea typeface="Consolas" pitchFamily="34" charset="-122"/>
-                <a:cs typeface="Consolas" pitchFamily="34" charset="-120"/>
+                <a:latin typeface="Consolas" panose="020B0609020204030204" pitchFamily="34" charset="0"/>
+                <a:ea typeface="Consolas" panose="020B0609020204030204" pitchFamily="34" charset="-122"/>
+                <a:cs typeface="Consolas" panose="020B0609020204030204" pitchFamily="34" charset="-120"/>
               </a:rPr>
               <a:t>  /dreams/*.md</a:t>
             </a:r>
@@ -16480,7 +16275,6 @@
             <a:avLst/>
           </a:prstGeom>
           <a:noFill/>
-          <a:ln/>
         </p:spPr>
         <p:txBody>
           <a:bodyPr wrap="square" lIns="254" tIns="254" rIns="254" bIns="254" rtlCol="0" anchor="ctr">
@@ -16564,7 +16358,7 @@
             <a:prstDash val="solid"/>
           </a:ln>
           <a:effectLst>
-            <a:outerShdw sx="100000" sy="100000" kx="0" ky="0" algn="bl" rotWithShape="0" blurRad="25400" dist="12700" dir="2700000">
+            <a:outerShdw blurRad="25400" dist="12700" dir="2700000" algn="bl" rotWithShape="0">
               <a:srgbClr val="000000">
                 <a:alpha val="16000"/>
               </a:srgbClr>
@@ -16616,13 +16410,12 @@
             <a:avLst/>
           </a:prstGeom>
           <a:noFill/>
-          <a:ln/>
         </p:spPr>
         <p:txBody>
           <a:bodyPr wrap="square" lIns="0" tIns="0" rIns="0" bIns="0" rtlCol="0" anchor="ctr"/>
           <a:lstStyle/>
           <a:p>
-            <a:pPr indent="0" marL="0">
+            <a:pPr marL="0" indent="0">
               <a:buNone/>
             </a:pPr>
             <a:r>
@@ -16652,13 +16445,12 @@
             <a:avLst/>
           </a:prstGeom>
           <a:noFill/>
-          <a:ln/>
         </p:spPr>
         <p:txBody>
           <a:bodyPr wrap="square" lIns="0" tIns="0" rIns="0" bIns="0" rtlCol="0" anchor="ctr"/>
           <a:lstStyle/>
           <a:p>
-            <a:pPr indent="0" marL="0">
+            <a:pPr marL="0" indent="0">
               <a:buNone/>
             </a:pPr>
             <a:r>
@@ -16688,13 +16480,12 @@
             <a:avLst/>
           </a:prstGeom>
           <a:noFill/>
-          <a:ln/>
         </p:spPr>
         <p:txBody>
           <a:bodyPr wrap="square" lIns="0" tIns="0" rIns="0" bIns="0" rtlCol="0" anchor="ctr"/>
           <a:lstStyle/>
           <a:p>
-            <a:pPr indent="0" marL="0">
+            <a:pPr marL="0" indent="0">
               <a:buNone/>
             </a:pPr>
             <a:r>
@@ -16702,9 +16493,9 @@
                 <a:solidFill>
                   <a:srgbClr val="A78BFA"/>
                 </a:solidFill>
-                <a:latin typeface="Consolas" pitchFamily="34" charset="0"/>
-                <a:ea typeface="Consolas" pitchFamily="34" charset="-122"/>
-                <a:cs typeface="Consolas" pitchFamily="34" charset="-120"/>
+                <a:latin typeface="Consolas" panose="020B0609020204030204" pitchFamily="34" charset="0"/>
+                <a:ea typeface="Consolas" panose="020B0609020204030204" pitchFamily="34" charset="-122"/>
+                <a:cs typeface="Consolas" panose="020B0609020204030204" pitchFamily="34" charset="-120"/>
               </a:rPr>
               <a:t>daily_reflection</a:t>
             </a:r>
@@ -16727,13 +16518,12 @@
             <a:avLst/>
           </a:prstGeom>
           <a:noFill/>
-          <a:ln/>
         </p:spPr>
         <p:txBody>
           <a:bodyPr wrap="square" lIns="0" tIns="0" rIns="0" bIns="0" rtlCol="0" anchor="ctr"/>
           <a:lstStyle/>
           <a:p>
-            <a:pPr indent="0" marL="0">
+            <a:pPr marL="0" indent="0">
               <a:buNone/>
             </a:pPr>
             <a:r>
@@ -16763,13 +16553,12 @@
             <a:avLst/>
           </a:prstGeom>
           <a:noFill/>
-          <a:ln/>
         </p:spPr>
         <p:txBody>
           <a:bodyPr wrap="square" lIns="0" tIns="0" rIns="0" bIns="0" rtlCol="0" anchor="ctr"/>
           <a:lstStyle/>
           <a:p>
-            <a:pPr indent="0" marL="0">
+            <a:pPr marL="0" indent="0">
               <a:buNone/>
             </a:pPr>
             <a:r>
@@ -16777,9 +16566,9 @@
                 <a:solidFill>
                   <a:srgbClr val="A78BFA"/>
                 </a:solidFill>
-                <a:latin typeface="Consolas" pitchFamily="34" charset="0"/>
-                <a:ea typeface="Consolas" pitchFamily="34" charset="-122"/>
-                <a:cs typeface="Consolas" pitchFamily="34" charset="-120"/>
+                <a:latin typeface="Consolas" panose="020B0609020204030204" pitchFamily="34" charset="0"/>
+                <a:ea typeface="Consolas" panose="020B0609020204030204" pitchFamily="34" charset="-122"/>
+                <a:cs typeface="Consolas" panose="020B0609020204030204" pitchFamily="34" charset="-120"/>
               </a:rPr>
               <a:t>planning</a:t>
             </a:r>
@@ -16802,13 +16591,12 @@
             <a:avLst/>
           </a:prstGeom>
           <a:noFill/>
-          <a:ln/>
         </p:spPr>
         <p:txBody>
           <a:bodyPr wrap="square" lIns="0" tIns="0" rIns="0" bIns="0" rtlCol="0" anchor="ctr"/>
           <a:lstStyle/>
           <a:p>
-            <a:pPr indent="0" marL="0">
+            <a:pPr marL="0" indent="0">
               <a:buNone/>
             </a:pPr>
             <a:r>
@@ -16838,13 +16626,12 @@
             <a:avLst/>
           </a:prstGeom>
           <a:noFill/>
-          <a:ln/>
         </p:spPr>
         <p:txBody>
           <a:bodyPr wrap="square" lIns="0" tIns="0" rIns="0" bIns="0" rtlCol="0" anchor="ctr"/>
           <a:lstStyle/>
           <a:p>
-            <a:pPr indent="0" marL="0">
+            <a:pPr marL="0" indent="0">
               <a:buNone/>
             </a:pPr>
             <a:r>
@@ -16852,9 +16639,9 @@
                 <a:solidFill>
                   <a:srgbClr val="A78BFA"/>
                 </a:solidFill>
-                <a:latin typeface="Consolas" pitchFamily="34" charset="0"/>
-                <a:ea typeface="Consolas" pitchFamily="34" charset="-122"/>
-                <a:cs typeface="Consolas" pitchFamily="34" charset="-120"/>
+                <a:latin typeface="Consolas" panose="020B0609020204030204" pitchFamily="34" charset="0"/>
+                <a:ea typeface="Consolas" panose="020B0609020204030204" pitchFamily="34" charset="-122"/>
+                <a:cs typeface="Consolas" panose="020B0609020204030204" pitchFamily="34" charset="-120"/>
               </a:rPr>
               <a:t>obstacle_detection</a:t>
             </a:r>
@@ -16877,13 +16664,12 @@
             <a:avLst/>
           </a:prstGeom>
           <a:noFill/>
-          <a:ln/>
         </p:spPr>
         <p:txBody>
           <a:bodyPr wrap="square" lIns="0" tIns="0" rIns="0" bIns="0" rtlCol="0" anchor="ctr"/>
           <a:lstStyle/>
           <a:p>
-            <a:pPr indent="0" marL="0">
+            <a:pPr marL="0" indent="0">
               <a:buNone/>
             </a:pPr>
             <a:r>
@@ -16913,13 +16699,12 @@
             <a:avLst/>
           </a:prstGeom>
           <a:noFill/>
-          <a:ln/>
         </p:spPr>
         <p:txBody>
           <a:bodyPr wrap="square" lIns="0" tIns="0" rIns="0" bIns="0" rtlCol="0" anchor="ctr"/>
           <a:lstStyle/>
           <a:p>
-            <a:pPr indent="0" marL="0">
+            <a:pPr marL="0" indent="0">
               <a:buNone/>
             </a:pPr>
             <a:r>
@@ -16927,9 +16712,9 @@
                 <a:solidFill>
                   <a:srgbClr val="A78BFA"/>
                 </a:solidFill>
-                <a:latin typeface="Consolas" pitchFamily="34" charset="0"/>
-                <a:ea typeface="Consolas" pitchFamily="34" charset="-122"/>
-                <a:cs typeface="Consolas" pitchFamily="34" charset="-120"/>
+                <a:latin typeface="Consolas" panose="020B0609020204030204" pitchFamily="34" charset="0"/>
+                <a:ea typeface="Consolas" panose="020B0609020204030204" pitchFamily="34" charset="-122"/>
+                <a:cs typeface="Consolas" panose="020B0609020204030204" pitchFamily="34" charset="-120"/>
               </a:rPr>
               <a:t>memory_consolidation</a:t>
             </a:r>
@@ -16952,13 +16737,12 @@
             <a:avLst/>
           </a:prstGeom>
           <a:noFill/>
-          <a:ln/>
         </p:spPr>
         <p:txBody>
           <a:bodyPr wrap="square" lIns="0" tIns="0" rIns="0" bIns="0" rtlCol="0" anchor="ctr"/>
           <a:lstStyle/>
           <a:p>
-            <a:pPr indent="0" marL="0">
+            <a:pPr marL="0" indent="0">
               <a:buNone/>
             </a:pPr>
             <a:r>
@@ -16988,13 +16772,12 @@
             <a:avLst/>
           </a:prstGeom>
           <a:noFill/>
-          <a:ln/>
         </p:spPr>
         <p:txBody>
           <a:bodyPr wrap="square" lIns="0" tIns="0" rIns="0" bIns="0" rtlCol="0" anchor="ctr"/>
           <a:lstStyle/>
           <a:p>
-            <a:pPr indent="0" marL="0">
+            <a:pPr marL="0" indent="0">
               <a:buNone/>
             </a:pPr>
             <a:r>
@@ -17002,9 +16785,9 @@
                 <a:solidFill>
                   <a:srgbClr val="A78BFA"/>
                 </a:solidFill>
-                <a:latin typeface="Consolas" pitchFamily="34" charset="0"/>
-                <a:ea typeface="Consolas" pitchFamily="34" charset="-122"/>
-                <a:cs typeface="Consolas" pitchFamily="34" charset="-120"/>
+                <a:latin typeface="Consolas" panose="020B0609020204030204" pitchFamily="34" charset="0"/>
+                <a:ea typeface="Consolas" panose="020B0609020204030204" pitchFamily="34" charset="-122"/>
+                <a:cs typeface="Consolas" panose="020B0609020204030204" pitchFamily="34" charset="-120"/>
               </a:rPr>
               <a:t>project_breakdown</a:t>
             </a:r>
@@ -17027,13 +16810,12 @@
             <a:avLst/>
           </a:prstGeom>
           <a:noFill/>
-          <a:ln/>
         </p:spPr>
         <p:txBody>
           <a:bodyPr wrap="square" lIns="0" tIns="0" rIns="0" bIns="0" rtlCol="0" anchor="ctr"/>
           <a:lstStyle/>
           <a:p>
-            <a:pPr indent="0" marL="0">
+            <a:pPr marL="0" indent="0">
               <a:buNone/>
             </a:pPr>
             <a:r>
@@ -17063,13 +16845,12 @@
             <a:avLst/>
           </a:prstGeom>
           <a:noFill/>
-          <a:ln/>
         </p:spPr>
         <p:txBody>
           <a:bodyPr wrap="square" lIns="0" tIns="0" rIns="0" bIns="0" rtlCol="0" anchor="ctr"/>
           <a:lstStyle/>
           <a:p>
-            <a:pPr indent="0" marL="0">
+            <a:pPr marL="0" indent="0">
               <a:buNone/>
             </a:pPr>
             <a:r>
@@ -17099,13 +16880,12 @@
             <a:avLst/>
           </a:prstGeom>
           <a:noFill/>
-          <a:ln/>
         </p:spPr>
         <p:txBody>
           <a:bodyPr wrap="square" lIns="0" tIns="0" rIns="0" bIns="0" rtlCol="0" anchor="ctr"/>
           <a:lstStyle/>
           <a:p>
-            <a:pPr indent="0" marL="0">
+            <a:pPr marL="0" indent="0">
               <a:buNone/>
             </a:pPr>
             <a:r>
@@ -17130,12 +16910,13 @@
 
 <file path=ppt/slides/slide9.xml><?xml version="1.0" encoding="utf-8"?>
 <p:sld xmlns:a="http://schemas.openxmlformats.org/drawingml/2006/main" xmlns:r="http://schemas.openxmlformats.org/officeDocument/2006/relationships" xmlns:p="http://schemas.openxmlformats.org/presentationml/2006/main">
-  <p:cSld name="Slide 9">
+  <p:cSld>
     <p:bg>
       <p:bgPr>
         <a:solidFill>
           <a:srgbClr val="050816"/>
         </a:solidFill>
+        <a:effectLst/>
       </p:bgPr>
     </p:bg>
     <p:spTree>
@@ -17894,17 +17675,16 @@
             <a:avLst/>
           </a:prstGeom>
           <a:noFill/>
-          <a:ln/>
         </p:spPr>
         <p:txBody>
           <a:bodyPr wrap="square" lIns="0" tIns="0" rIns="0" bIns="0" rtlCol="0" anchor="ctr"/>
           <a:lstStyle/>
           <a:p>
-            <a:pPr indent="0" marL="0">
+            <a:pPr marL="0" indent="0">
               <a:buNone/>
             </a:pPr>
             <a:r>
-              <a:rPr lang="en-US" sz="950" b="1" spc="260" kern="0" dirty="0">
+              <a:rPr lang="en-US" sz="950" b="1" kern="0" spc="260" dirty="0">
                 <a:solidFill>
                   <a:srgbClr val="5EEAD4"/>
                 </a:solidFill>
@@ -17930,13 +17710,12 @@
             <a:avLst/>
           </a:prstGeom>
           <a:noFill/>
-          <a:ln/>
         </p:spPr>
         <p:txBody>
           <a:bodyPr wrap="square" lIns="0" tIns="0" rIns="0" bIns="0" rtlCol="0" anchor="ctr"/>
           <a:lstStyle/>
           <a:p>
-            <a:pPr indent="0" marL="0">
+            <a:pPr marL="0" indent="0">
               <a:buNone/>
             </a:pPr>
             <a:r>
@@ -17944,9 +17723,9 @@
                 <a:solidFill>
                   <a:srgbClr val="F8FAFC"/>
                 </a:solidFill>
-                <a:latin typeface="Microsoft YaHei UI" pitchFamily="34" charset="0"/>
-                <a:ea typeface="Microsoft YaHei UI" pitchFamily="34" charset="-122"/>
-                <a:cs typeface="Microsoft YaHei UI" pitchFamily="34" charset="-120"/>
+                <a:latin typeface="Microsoft YaHei UI" panose="020B0503020204020204" pitchFamily="34" charset="-122"/>
+                <a:ea typeface="Microsoft YaHei UI" panose="020B0503020204020204" pitchFamily="34" charset="-122"/>
+                <a:cs typeface="Microsoft YaHei UI" panose="020B0503020204020204" pitchFamily="34" charset="-120"/>
               </a:rPr>
               <a:t>自进化不是玄学，是明确的反馈回路</a:t>
             </a:r>
@@ -17969,7 +17748,6 @@
             <a:avLst/>
           </a:prstGeom>
           <a:noFill/>
-          <a:ln/>
         </p:spPr>
         <p:txBody>
           <a:bodyPr wrap="square" lIns="0" tIns="0" rIns="0" bIns="0" rtlCol="0" anchor="ctr">
@@ -17977,7 +17755,7 @@
           </a:bodyPr>
           <a:lstStyle/>
           <a:p>
-            <a:pPr indent="0" marL="0">
+            <a:pPr marL="0" indent="0">
               <a:buNone/>
             </a:pPr>
             <a:r>
@@ -18038,22 +17816,37 @@
             <a:avLst/>
           </a:prstGeom>
           <a:noFill/>
-          <a:ln/>
         </p:spPr>
         <p:txBody>
           <a:bodyPr wrap="square" lIns="0" tIns="0" rIns="0" bIns="0" rtlCol="0" anchor="ctr"/>
           <a:lstStyle/>
           <a:p>
-            <a:pPr algn="ctr" indent="0" marL="0">
+            <a:pPr marL="0" indent="0" algn="ctr">
               <a:buNone/>
             </a:pPr>
             <a:r>
-              <a:rPr lang="en-US" sz="840" b="1" spc="120" kern="0" dirty="0">
+              <a:rPr lang="en-US" sz="840" b="1" kern="0" spc="120" dirty="0">
                 <a:solidFill>
                   <a:srgbClr val="F6C768"/>
                 </a:solidFill>
               </a:rPr>
-              <a:t>三 / 3</a:t>
+              <a:t>三 </a:t>
+            </a:r>
+            <a:r>
+              <a:rPr lang="zh-CN" altLang="en-US" sz="840" b="1" kern="0" spc="120" dirty="0">
+                <a:solidFill>
+                  <a:srgbClr val="F6C768"/>
+                </a:solidFill>
+              </a:rPr>
+              <a:t>、</a:t>
+            </a:r>
+            <a:r>
+              <a:rPr lang="en-US" sz="840" b="1" kern="0" spc="120" dirty="0">
+                <a:solidFill>
+                  <a:srgbClr val="F6C768"/>
+                </a:solidFill>
+              </a:rPr>
+              <a:t> 3</a:t>
             </a:r>
             <a:endParaRPr lang="en-US" sz="840" dirty="0"/>
           </a:p>
@@ -18074,7 +17867,6 @@
             <a:avLst/>
           </a:prstGeom>
           <a:noFill/>
-          <a:ln/>
         </p:spPr>
         <p:txBody>
           <a:bodyPr wrap="square" lIns="0" tIns="0" rIns="0" bIns="0" rtlCol="0" anchor="ctr">
@@ -18082,7 +17874,7 @@
           </a:bodyPr>
           <a:lstStyle/>
           <a:p>
-            <a:pPr indent="0" marL="0">
+            <a:pPr marL="0" indent="0">
               <a:buNone/>
             </a:pPr>
             <a:r>
@@ -18127,7 +17919,7 @@
             <a:prstDash val="solid"/>
           </a:ln>
           <a:effectLst>
-            <a:outerShdw sx="100000" sy="100000" kx="0" ky="0" algn="bl" rotWithShape="0" blurRad="25400" dist="12700" dir="2700000">
+            <a:outerShdw blurRad="25400" dist="12700" dir="2700000" algn="bl" rotWithShape="0">
               <a:srgbClr val="000000">
                 <a:alpha val="16000"/>
               </a:srgbClr>
@@ -18150,13 +17942,12 @@
             <a:avLst/>
           </a:prstGeom>
           <a:noFill/>
-          <a:ln/>
         </p:spPr>
         <p:txBody>
           <a:bodyPr wrap="square" lIns="0" tIns="0" rIns="0" bIns="0" rtlCol="0" anchor="ctr"/>
           <a:lstStyle/>
           <a:p>
-            <a:pPr indent="0" marL="0">
+            <a:pPr marL="0" indent="0">
               <a:buNone/>
             </a:pPr>
             <a:r>
@@ -18186,7 +17977,6 @@
             <a:avLst/>
           </a:prstGeom>
           <a:noFill/>
-          <a:ln/>
         </p:spPr>
         <p:txBody>
           <a:bodyPr wrap="square" lIns="0" tIns="0" rIns="0" bIns="0" rtlCol="0" anchor="ctr">
@@ -18194,7 +17984,7 @@
           </a:bodyPr>
           <a:lstStyle/>
           <a:p>
-            <a:pPr indent="0" marL="0">
+            <a:pPr marL="0" indent="0">
               <a:buNone/>
             </a:pPr>
             <a:r>
@@ -18224,13 +18014,12 @@
             <a:avLst/>
           </a:prstGeom>
           <a:noFill/>
-          <a:ln/>
         </p:spPr>
         <p:txBody>
           <a:bodyPr wrap="square" lIns="0" tIns="0" rIns="0" bIns="0" rtlCol="0" anchor="ctr"/>
           <a:lstStyle/>
           <a:p>
-            <a:pPr indent="0" marL="0">
+            <a:pPr marL="0" indent="0">
               <a:buNone/>
             </a:pPr>
             <a:r>
@@ -18260,7 +18049,6 @@
             <a:avLst/>
           </a:prstGeom>
           <a:noFill/>
-          <a:ln/>
         </p:spPr>
         <p:txBody>
           <a:bodyPr wrap="square" lIns="0" tIns="0" rIns="0" bIns="0" rtlCol="0" anchor="ctr">
@@ -18268,7 +18056,7 @@
           </a:bodyPr>
           <a:lstStyle/>
           <a:p>
-            <a:pPr indent="0" marL="0">
+            <a:pPr marL="0" indent="0">
               <a:buNone/>
             </a:pPr>
             <a:r>
@@ -18313,7 +18101,7 @@
             <a:prstDash val="solid"/>
           </a:ln>
           <a:effectLst>
-            <a:outerShdw sx="100000" sy="100000" kx="0" ky="0" algn="bl" rotWithShape="0" blurRad="25400" dist="12700" dir="2700000">
+            <a:outerShdw blurRad="25400" dist="12700" dir="2700000" algn="bl" rotWithShape="0">
               <a:srgbClr val="000000">
                 <a:alpha val="16000"/>
               </a:srgbClr>
@@ -18336,13 +18124,12 @@
             <a:avLst/>
           </a:prstGeom>
           <a:noFill/>
-          <a:ln/>
         </p:spPr>
         <p:txBody>
           <a:bodyPr wrap="square" lIns="0" tIns="0" rIns="0" bIns="0" rtlCol="0" anchor="ctr"/>
           <a:lstStyle/>
           <a:p>
-            <a:pPr indent="0" marL="0">
+            <a:pPr marL="0" indent="0">
               <a:buNone/>
             </a:pPr>
             <a:r>
@@ -18372,7 +18159,6 @@
             <a:avLst/>
           </a:prstGeom>
           <a:noFill/>
-          <a:ln/>
         </p:spPr>
         <p:txBody>
           <a:bodyPr wrap="square" lIns="0" tIns="0" rIns="0" bIns="0" rtlCol="0" anchor="ctr">
@@ -18380,7 +18166,7 @@
           </a:bodyPr>
           <a:lstStyle/>
           <a:p>
-            <a:pPr indent="0" marL="0">
+            <a:pPr marL="0" indent="0">
               <a:buNone/>
             </a:pPr>
             <a:r>
@@ -18410,13 +18196,12 @@
             <a:avLst/>
           </a:prstGeom>
           <a:noFill/>
-          <a:ln/>
         </p:spPr>
         <p:txBody>
           <a:bodyPr wrap="square" lIns="0" tIns="0" rIns="0" bIns="0" rtlCol="0" anchor="ctr"/>
           <a:lstStyle/>
           <a:p>
-            <a:pPr indent="0" marL="0">
+            <a:pPr marL="0" indent="0">
               <a:buNone/>
             </a:pPr>
             <a:r>
@@ -18446,7 +18231,6 @@
             <a:avLst/>
           </a:prstGeom>
           <a:noFill/>
-          <a:ln/>
         </p:spPr>
         <p:txBody>
           <a:bodyPr wrap="square" lIns="0" tIns="0" rIns="0" bIns="0" rtlCol="0" anchor="ctr">
@@ -18454,7 +18238,7 @@
           </a:bodyPr>
           <a:lstStyle/>
           <a:p>
-            <a:pPr indent="0" marL="0">
+            <a:pPr marL="0" indent="0">
               <a:buNone/>
             </a:pPr>
             <a:r>
@@ -18499,7 +18283,7 @@
             <a:prstDash val="solid"/>
           </a:ln>
           <a:effectLst>
-            <a:outerShdw sx="100000" sy="100000" kx="0" ky="0" algn="bl" rotWithShape="0" blurRad="25400" dist="12700" dir="2700000">
+            <a:outerShdw blurRad="25400" dist="12700" dir="2700000" algn="bl" rotWithShape="0">
               <a:srgbClr val="000000">
                 <a:alpha val="16000"/>
               </a:srgbClr>
@@ -18522,13 +18306,12 @@
             <a:avLst/>
           </a:prstGeom>
           <a:noFill/>
-          <a:ln/>
         </p:spPr>
         <p:txBody>
           <a:bodyPr wrap="square" lIns="0" tIns="0" rIns="0" bIns="0" rtlCol="0" anchor="ctr"/>
           <a:lstStyle/>
           <a:p>
-            <a:pPr indent="0" marL="0">
+            <a:pPr marL="0" indent="0">
               <a:buNone/>
             </a:pPr>
             <a:r>
@@ -18558,7 +18341,6 @@
             <a:avLst/>
           </a:prstGeom>
           <a:noFill/>
-          <a:ln/>
         </p:spPr>
         <p:txBody>
           <a:bodyPr wrap="square" lIns="0" tIns="0" rIns="0" bIns="0" rtlCol="0" anchor="ctr">
@@ -18566,7 +18348,7 @@
           </a:bodyPr>
           <a:lstStyle/>
           <a:p>
-            <a:pPr indent="0" marL="0">
+            <a:pPr marL="0" indent="0">
               <a:buNone/>
             </a:pPr>
             <a:r>
@@ -18596,13 +18378,12 @@
             <a:avLst/>
           </a:prstGeom>
           <a:noFill/>
-          <a:ln/>
         </p:spPr>
         <p:txBody>
           <a:bodyPr wrap="square" lIns="0" tIns="0" rIns="0" bIns="0" rtlCol="0" anchor="ctr"/>
           <a:lstStyle/>
           <a:p>
-            <a:pPr indent="0" marL="0">
+            <a:pPr marL="0" indent="0">
               <a:buNone/>
             </a:pPr>
             <a:r>
@@ -18632,7 +18413,6 @@
             <a:avLst/>
           </a:prstGeom>
           <a:noFill/>
-          <a:ln/>
         </p:spPr>
         <p:txBody>
           <a:bodyPr wrap="square" lIns="0" tIns="0" rIns="0" bIns="0" rtlCol="0" anchor="ctr">
@@ -18640,7 +18420,7 @@
           </a:bodyPr>
           <a:lstStyle/>
           <a:p>
-            <a:pPr indent="0" marL="0">
+            <a:pPr marL="0" indent="0">
               <a:buNone/>
             </a:pPr>
             <a:r>
@@ -18685,7 +18465,7 @@
             <a:prstDash val="solid"/>
           </a:ln>
           <a:effectLst>
-            <a:outerShdw sx="100000" sy="100000" kx="0" ky="0" algn="bl" rotWithShape="0" blurRad="25400" dist="12700" dir="2700000">
+            <a:outerShdw blurRad="25400" dist="12700" dir="2700000" algn="bl" rotWithShape="0">
               <a:srgbClr val="000000">
                 <a:alpha val="16000"/>
               </a:srgbClr>
@@ -18708,13 +18488,12 @@
             <a:avLst/>
           </a:prstGeom>
           <a:noFill/>
-          <a:ln/>
         </p:spPr>
         <p:txBody>
           <a:bodyPr wrap="square" lIns="0" tIns="0" rIns="0" bIns="0" rtlCol="0" anchor="ctr"/>
           <a:lstStyle/>
           <a:p>
-            <a:pPr algn="ctr" indent="0" marL="0">
+            <a:pPr marL="0" indent="0" algn="ctr">
               <a:buNone/>
             </a:pPr>
             <a:r>
@@ -18722,9 +18501,9 @@
                 <a:solidFill>
                   <a:srgbClr val="5EEAD4"/>
                 </a:solidFill>
-                <a:latin typeface="Consolas" pitchFamily="34" charset="0"/>
-                <a:ea typeface="Consolas" pitchFamily="34" charset="-122"/>
-                <a:cs typeface="Consolas" pitchFamily="34" charset="-120"/>
+                <a:latin typeface="Consolas" panose="020B0609020204030204" pitchFamily="34" charset="0"/>
+                <a:ea typeface="Consolas" panose="020B0609020204030204" pitchFamily="34" charset="-122"/>
+                <a:cs typeface="Consolas" panose="020B0609020204030204" pitchFamily="34" charset="-120"/>
               </a:rPr>
               <a:t>最终形成：Daily Input -&gt; Memory Retrieval -&gt; Skill Selection -&gt; Reflection -&gt; Evaluation -&gt; Memory Update -&gt; Skill Evolution</a:t>
             </a:r>
@@ -18747,13 +18526,12 @@
             <a:avLst/>
           </a:prstGeom>
           <a:noFill/>
-          <a:ln/>
         </p:spPr>
         <p:txBody>
           <a:bodyPr wrap="square" lIns="0" tIns="0" rIns="0" bIns="0" rtlCol="0" anchor="ctr"/>
           <a:lstStyle/>
           <a:p>
-            <a:pPr indent="0" marL="0">
+            <a:pPr marL="0" indent="0">
               <a:buNone/>
             </a:pPr>
             <a:r>
@@ -18852,23 +18630,6 @@
         <a:font script="Viet" typeface="Times New Roman"/>
         <a:font script="Uigh" typeface="Microsoft Uighur"/>
         <a:font script="Geor" typeface="Sylfaen"/>
-        <a:font script="Armn" typeface="Arial"/>
-        <a:font script="Bugi" typeface="Leelawadee UI"/>
-        <a:font script="Bopo" typeface="Microsoft JhengHei"/>
-        <a:font script="Java" typeface="Javanese Text"/>
-        <a:font script="Lisu" typeface="Segoe UI"/>
-        <a:font script="Mymr" typeface="Myanmar Text"/>
-        <a:font script="Nkoo" typeface="Ebrima"/>
-        <a:font script="Olck" typeface="Nirmala UI"/>
-        <a:font script="Osma" typeface="Ebrima"/>
-        <a:font script="Phag" typeface="Phagspa"/>
-        <a:font script="Syrn" typeface="Estrangelo Edessa"/>
-        <a:font script="Syrj" typeface="Estrangelo Edessa"/>
-        <a:font script="Syre" typeface="Estrangelo Edessa"/>
-        <a:font script="Sora" typeface="Nirmala UI"/>
-        <a:font script="Tale" typeface="Microsoft Tai Le"/>
-        <a:font script="Talu" typeface="Microsoft New Tai Lue"/>
-        <a:font script="Tfng" typeface="Ebrima"/>
       </a:majorFont>
       <a:minorFont>
         <a:latin typeface="Microsoft YaHei UI"/>
@@ -18904,23 +18665,6 @@
         <a:font script="Viet" typeface="Arial"/>
         <a:font script="Uigh" typeface="Microsoft Uighur"/>
         <a:font script="Geor" typeface="Sylfaen"/>
-        <a:font script="Armn" typeface="Arial"/>
-        <a:font script="Bugi" typeface="Leelawadee UI"/>
-        <a:font script="Bopo" typeface="Microsoft JhengHei"/>
-        <a:font script="Java" typeface="Javanese Text"/>
-        <a:font script="Lisu" typeface="Segoe UI"/>
-        <a:font script="Mymr" typeface="Myanmar Text"/>
-        <a:font script="Nkoo" typeface="Ebrima"/>
-        <a:font script="Olck" typeface="Nirmala UI"/>
-        <a:font script="Osma" typeface="Ebrima"/>
-        <a:font script="Phag" typeface="Phagspa"/>
-        <a:font script="Syrn" typeface="Estrangelo Edessa"/>
-        <a:font script="Syrj" typeface="Estrangelo Edessa"/>
-        <a:font script="Syre" typeface="Estrangelo Edessa"/>
-        <a:font script="Sora" typeface="Nirmala UI"/>
-        <a:font script="Tale" typeface="Microsoft Tai Le"/>
-        <a:font script="Talu" typeface="Microsoft New Tai Lue"/>
-        <a:font script="Tfng" typeface="Ebrima"/>
       </a:minorFont>
     </a:fontScheme>
     <a:fmtScheme name="Office">
@@ -19061,8 +18805,265 @@
       </a:bgFillStyleLst>
     </a:fmtScheme>
   </a:themeElements>
-  <a:objectDefaults/>
-  <a:extraClrSchemeLst/>
+  <a:extLst>
+    <a:ext uri="{05A4C25C-085E-4340-85A3-A5531E510DB2}">
+      <thm15:themeFamily xmlns:thm15="http://schemas.microsoft.com/office/thememl/2012/main" name="Office Theme" id="{62F939B6-93AF-4DB8-9C6B-D6C7DFDC589F}" vid="{4A3C46E8-61CC-4603-A589-7422A47A8E4A}"/>
+    </a:ext>
+  </a:extLst>
+</a:theme>
+</file>
+
+<file path=ppt/theme/theme2.xml><?xml version="1.0" encoding="utf-8"?>
+<a:theme xmlns:a="http://schemas.openxmlformats.org/drawingml/2006/main" name="Office Theme">
+  <a:themeElements>
+    <a:clrScheme name="Office">
+      <a:dk1>
+        <a:sysClr val="windowText" lastClr="000000"/>
+      </a:dk1>
+      <a:lt1>
+        <a:sysClr val="window" lastClr="FFFFFF"/>
+      </a:lt1>
+      <a:dk2>
+        <a:srgbClr val="44546A"/>
+      </a:dk2>
+      <a:lt2>
+        <a:srgbClr val="E7E6E6"/>
+      </a:lt2>
+      <a:accent1>
+        <a:srgbClr val="4472C4"/>
+      </a:accent1>
+      <a:accent2>
+        <a:srgbClr val="ED7D31"/>
+      </a:accent2>
+      <a:accent3>
+        <a:srgbClr val="A5A5A5"/>
+      </a:accent3>
+      <a:accent4>
+        <a:srgbClr val="FFC000"/>
+      </a:accent4>
+      <a:accent5>
+        <a:srgbClr val="5B9BD5"/>
+      </a:accent5>
+      <a:accent6>
+        <a:srgbClr val="70AD47"/>
+      </a:accent6>
+      <a:hlink>
+        <a:srgbClr val="0563C1"/>
+      </a:hlink>
+      <a:folHlink>
+        <a:srgbClr val="954F72"/>
+      </a:folHlink>
+    </a:clrScheme>
+    <a:fontScheme name="Office">
+      <a:majorFont>
+        <a:latin typeface="Microsoft YaHei UI"/>
+        <a:ea typeface=""/>
+        <a:cs typeface=""/>
+        <a:font script="Jpan" typeface="游ゴシック Light"/>
+        <a:font script="Hang" typeface="맑은 고딕"/>
+        <a:font script="Hans" typeface="等线 Light"/>
+        <a:font script="Hant" typeface="新細明體"/>
+        <a:font script="Arab" typeface="Times New Roman"/>
+        <a:font script="Hebr" typeface="Times New Roman"/>
+        <a:font script="Thai" typeface="Angsana New"/>
+        <a:font script="Ethi" typeface="Nyala"/>
+        <a:font script="Beng" typeface="Vrinda"/>
+        <a:font script="Gujr" typeface="Shruti"/>
+        <a:font script="Khmr" typeface="MoolBoran"/>
+        <a:font script="Knda" typeface="Tunga"/>
+        <a:font script="Guru" typeface="Raavi"/>
+        <a:font script="Cans" typeface="Euphemia"/>
+        <a:font script="Cher" typeface="Plantagenet Cherokee"/>
+        <a:font script="Yiii" typeface="Microsoft Yi Baiti"/>
+        <a:font script="Tibt" typeface="Microsoft Himalaya"/>
+        <a:font script="Thaa" typeface="MV Boli"/>
+        <a:font script="Deva" typeface="Mangal"/>
+        <a:font script="Telu" typeface="Gautami"/>
+        <a:font script="Taml" typeface="Latha"/>
+        <a:font script="Syrc" typeface="Estrangelo Edessa"/>
+        <a:font script="Orya" typeface="Kalinga"/>
+        <a:font script="Mlym" typeface="Kartika"/>
+        <a:font script="Laoo" typeface="DokChampa"/>
+        <a:font script="Sinh" typeface="Iskoola Pota"/>
+        <a:font script="Mong" typeface="Mongolian Baiti"/>
+        <a:font script="Viet" typeface="Times New Roman"/>
+        <a:font script="Uigh" typeface="Microsoft Uighur"/>
+        <a:font script="Geor" typeface="Sylfaen"/>
+      </a:majorFont>
+      <a:minorFont>
+        <a:latin typeface="Microsoft YaHei UI"/>
+        <a:ea typeface=""/>
+        <a:cs typeface=""/>
+        <a:font script="Jpan" typeface="游ゴシック"/>
+        <a:font script="Hang" typeface="맑은 고딕"/>
+        <a:font script="Hans" typeface="等线"/>
+        <a:font script="Hant" typeface="新細明體"/>
+        <a:font script="Arab" typeface="Arial"/>
+        <a:font script="Hebr" typeface="Arial"/>
+        <a:font script="Thai" typeface="Cordia New"/>
+        <a:font script="Ethi" typeface="Nyala"/>
+        <a:font script="Beng" typeface="Vrinda"/>
+        <a:font script="Gujr" typeface="Shruti"/>
+        <a:font script="Khmr" typeface="DaunPenh"/>
+        <a:font script="Knda" typeface="Tunga"/>
+        <a:font script="Guru" typeface="Raavi"/>
+        <a:font script="Cans" typeface="Euphemia"/>
+        <a:font script="Cher" typeface="Plantagenet Cherokee"/>
+        <a:font script="Yiii" typeface="Microsoft Yi Baiti"/>
+        <a:font script="Tibt" typeface="Microsoft Himalaya"/>
+        <a:font script="Thaa" typeface="MV Boli"/>
+        <a:font script="Deva" typeface="Mangal"/>
+        <a:font script="Telu" typeface="Gautami"/>
+        <a:font script="Taml" typeface="Latha"/>
+        <a:font script="Syrc" typeface="Estrangelo Edessa"/>
+        <a:font script="Orya" typeface="Kalinga"/>
+        <a:font script="Mlym" typeface="Kartika"/>
+        <a:font script="Laoo" typeface="DokChampa"/>
+        <a:font script="Sinh" typeface="Iskoola Pota"/>
+        <a:font script="Mong" typeface="Mongolian Baiti"/>
+        <a:font script="Viet" typeface="Arial"/>
+        <a:font script="Uigh" typeface="Microsoft Uighur"/>
+        <a:font script="Geor" typeface="Sylfaen"/>
+      </a:minorFont>
+    </a:fontScheme>
+    <a:fmtScheme name="Office">
+      <a:fillStyleLst>
+        <a:solidFill>
+          <a:schemeClr val="phClr"/>
+        </a:solidFill>
+        <a:gradFill rotWithShape="1">
+          <a:gsLst>
+            <a:gs pos="0">
+              <a:schemeClr val="phClr">
+                <a:lumMod val="110000"/>
+                <a:satMod val="105000"/>
+                <a:tint val="67000"/>
+              </a:schemeClr>
+            </a:gs>
+            <a:gs pos="50000">
+              <a:schemeClr val="phClr">
+                <a:lumMod val="105000"/>
+                <a:satMod val="103000"/>
+                <a:tint val="73000"/>
+              </a:schemeClr>
+            </a:gs>
+            <a:gs pos="100000">
+              <a:schemeClr val="phClr">
+                <a:lumMod val="105000"/>
+                <a:satMod val="109000"/>
+                <a:tint val="81000"/>
+              </a:schemeClr>
+            </a:gs>
+          </a:gsLst>
+          <a:lin ang="5400000" scaled="0"/>
+        </a:gradFill>
+        <a:gradFill rotWithShape="1">
+          <a:gsLst>
+            <a:gs pos="0">
+              <a:schemeClr val="phClr">
+                <a:satMod val="103000"/>
+                <a:lumMod val="102000"/>
+                <a:tint val="94000"/>
+              </a:schemeClr>
+            </a:gs>
+            <a:gs pos="50000">
+              <a:schemeClr val="phClr">
+                <a:satMod val="110000"/>
+                <a:lumMod val="100000"/>
+                <a:shade val="100000"/>
+              </a:schemeClr>
+            </a:gs>
+            <a:gs pos="100000">
+              <a:schemeClr val="phClr">
+                <a:lumMod val="99000"/>
+                <a:satMod val="120000"/>
+                <a:shade val="78000"/>
+              </a:schemeClr>
+            </a:gs>
+          </a:gsLst>
+          <a:lin ang="5400000" scaled="0"/>
+        </a:gradFill>
+      </a:fillStyleLst>
+      <a:lnStyleLst>
+        <a:ln w="6350" cap="flat" cmpd="sng" algn="ctr">
+          <a:solidFill>
+            <a:schemeClr val="phClr"/>
+          </a:solidFill>
+          <a:prstDash val="solid"/>
+          <a:miter lim="800000"/>
+        </a:ln>
+        <a:ln w="12700" cap="flat" cmpd="sng" algn="ctr">
+          <a:solidFill>
+            <a:schemeClr val="phClr"/>
+          </a:solidFill>
+          <a:prstDash val="solid"/>
+          <a:miter lim="800000"/>
+        </a:ln>
+        <a:ln w="19050" cap="flat" cmpd="sng" algn="ctr">
+          <a:solidFill>
+            <a:schemeClr val="phClr"/>
+          </a:solidFill>
+          <a:prstDash val="solid"/>
+          <a:miter lim="800000"/>
+        </a:ln>
+      </a:lnStyleLst>
+      <a:effectStyleLst>
+        <a:effectStyle>
+          <a:effectLst/>
+        </a:effectStyle>
+        <a:effectStyle>
+          <a:effectLst/>
+        </a:effectStyle>
+        <a:effectStyle>
+          <a:effectLst>
+            <a:outerShdw blurRad="57150" dist="19050" dir="5400000" algn="ctr" rotWithShape="0">
+              <a:srgbClr val="000000">
+                <a:alpha val="63000"/>
+              </a:srgbClr>
+            </a:outerShdw>
+          </a:effectLst>
+        </a:effectStyle>
+      </a:effectStyleLst>
+      <a:bgFillStyleLst>
+        <a:solidFill>
+          <a:schemeClr val="phClr"/>
+        </a:solidFill>
+        <a:solidFill>
+          <a:schemeClr val="phClr">
+            <a:tint val="95000"/>
+            <a:satMod val="170000"/>
+          </a:schemeClr>
+        </a:solidFill>
+        <a:gradFill rotWithShape="1">
+          <a:gsLst>
+            <a:gs pos="0">
+              <a:schemeClr val="phClr">
+                <a:tint val="93000"/>
+                <a:satMod val="150000"/>
+                <a:shade val="98000"/>
+                <a:lumMod val="102000"/>
+              </a:schemeClr>
+            </a:gs>
+            <a:gs pos="50000">
+              <a:schemeClr val="phClr">
+                <a:tint val="98000"/>
+                <a:satMod val="130000"/>
+                <a:shade val="90000"/>
+                <a:lumMod val="103000"/>
+              </a:schemeClr>
+            </a:gs>
+            <a:gs pos="100000">
+              <a:schemeClr val="phClr">
+                <a:shade val="63000"/>
+                <a:satMod val="120000"/>
+              </a:schemeClr>
+            </a:gs>
+          </a:gsLst>
+          <a:lin ang="5400000" scaled="0"/>
+        </a:gradFill>
+      </a:bgFillStyleLst>
+    </a:fmtScheme>
+  </a:themeElements>
   <a:extLst>
     <a:ext uri="{05A4C25C-085E-4340-85A3-A5531E510DB2}">
       <thm15:themeFamily xmlns:thm15="http://schemas.microsoft.com/office/thememl/2012/main" name="Office Theme" id="{62F939B6-93AF-4DB8-9C6B-D6C7DFDC589F}" vid="{4A3C46E8-61CC-4603-A589-7422A47A8E4A}"/>

</xml_diff>